<commit_message>
Update presentation with Todoist and Jira
</commit_message>
<xml_diff>
--- a/Homework3_Presentation.pptx
+++ b/Homework3_Presentation.pptx
@@ -15,9 +15,11 @@
     <p:sldId id="263" r:id="rId9"/>
     <p:sldId id="264" r:id="rId10"/>
     <p:sldId id="265" r:id="rId11"/>
+    <p:sldId id="266" r:id="rId12"/>
+    <p:sldId id="267" r:id="rId13"/>
   </p:sldIdLst>
   <p:notesMasterIdLst>
-    <p:notesMasterId r:id="rId12"/>
+    <p:notesMasterId r:id="rId14"/>
   </p:notesMasterIdLst>
   <p:sldSz cx="12192000" cy="6858000"/>
   <p:notesSz cx="6858000" cy="12192000"/>
@@ -116,34 +118,36 @@
   <p:extLst>
     <p:ext uri="{521415D9-36F7-43E2-AB2F-B90AF26B5E84}">
       <p14:sectionLst xmlns:p14="http://schemas.microsoft.com/office/powerpoint/2010/main">
-        <p14:section name="Introduction" id="{a162cea3-673e-1154-51a3-9862e18a0883}">
+        <p14:section name="Introduction" id="{251908e4-bf33-6eac-ab4c-bad627d3eaf3}">
           <p14:sldIdLst>
             <p14:sldId id="256"/>
             <p14:sldId id="257"/>
           </p14:sldIdLst>
         </p14:section>
-        <p14:section name="Connections" id="{301e3a2d-1c4a-8ba2-9e39-7a861b601708}">
+        <p14:section name="Connections" id="{7e853a16-54d2-5edf-5b20-75f55ff2f346}">
           <p14:sldIdLst>
             <p14:sldId id="258"/>
           </p14:sldIdLst>
         </p14:section>
-        <p14:section name="Original vs dashboard" id="{f5753c7f-9222-07b6-a900-976ac92fd5f8}">
+        <p14:section name="Original vs dashboard" id="{6064c56f-a05c-4f18-0809-980c8a67a907}">
           <p14:sldIdLst>
             <p14:sldId id="259"/>
             <p14:sldId id="260"/>
             <p14:sldId id="261"/>
             <p14:sldId id="262"/>
-          </p14:sldIdLst>
-        </p14:section>
-        <p14:section name="Dashboard" id="{fb08bf35-bcfd-cc85-dd52-a0df1fab2a8a}">
-          <p14:sldIdLst>
             <p14:sldId id="263"/>
             <p14:sldId id="264"/>
           </p14:sldIdLst>
         </p14:section>
-        <p14:section name="Summary" id="{3d555681-db48-6222-b892-cf4beae378a5}">
+        <p14:section name="Dashboard" id="{4d9fec0d-629c-5f1d-47d1-01ecf361197d}">
           <p14:sldIdLst>
             <p14:sldId id="265"/>
+            <p14:sldId id="266"/>
+          </p14:sldIdLst>
+        </p14:section>
+        <p14:section name="Summary" id="{7a6670a9-c633-6976-9860-c975423f79cd}">
+          <p14:sldIdLst>
+            <p14:sldId id="267"/>
           </p14:sldIdLst>
         </p14:section>
       </p14:sectionLst>
@@ -680,6 +684,182 @@
 </p:notes>
 </file>
 
+<file path=ppt/notesSlides/notesSlide11.xml><?xml version="1.0" encoding="utf-8"?>
+<p:notes xmlns:a="http://schemas.openxmlformats.org/drawingml/2006/main" xmlns:r="http://schemas.openxmlformats.org/officeDocument/2006/relationships" xmlns:p="http://schemas.openxmlformats.org/presentationml/2006/main">
+  <p:cSld>
+    <p:spTree>
+      <p:nvGrpSpPr>
+        <p:cNvPr id="1" name=""/>
+        <p:cNvGrpSpPr/>
+        <p:nvPr/>
+      </p:nvGrpSpPr>
+      <p:grpSpPr>
+        <a:xfrm>
+          <a:off x="0" y="0"/>
+          <a:ext cx="0" cy="0"/>
+          <a:chOff x="0" y="0"/>
+          <a:chExt cx="0" cy="0"/>
+        </a:xfrm>
+      </p:grpSpPr>
+      <p:sp>
+        <p:nvSpPr>
+          <p:cNvPr id="2" name="Slide Image Placeholder 1"/>
+          <p:cNvSpPr>
+            <a:spLocks noGrp="1" noRot="1" noChangeAspect="1"/>
+          </p:cNvSpPr>
+          <p:nvPr>
+            <p:ph type="sldImg"/>
+          </p:nvPr>
+        </p:nvSpPr>
+        <p:spPr/>
+      </p:sp>
+      <p:sp>
+        <p:nvSpPr>
+          <p:cNvPr id="3" name="Notes Placeholder 2"/>
+          <p:cNvSpPr>
+            <a:spLocks noGrp="1"/>
+          </p:cNvSpPr>
+          <p:nvPr>
+            <p:ph type="body" idx="1"/>
+          </p:nvPr>
+        </p:nvSpPr>
+        <p:spPr/>
+        <p:txBody>
+          <a:bodyPr/>
+          <a:lstStyle/>
+          <a:p>
+            <a:r>
+              <a:rPr lang="en-US" dirty="0"/>
+              <a:t/>
+            </a:r>
+            <a:endParaRPr lang="en-US" dirty="0"/>
+          </a:p>
+        </p:txBody>
+      </p:sp>
+      <p:sp>
+        <p:nvSpPr>
+          <p:cNvPr id="4" name="Slide Number Placeholder 3"/>
+          <p:cNvSpPr>
+            <a:spLocks noGrp="1"/>
+          </p:cNvSpPr>
+          <p:nvPr>
+            <p:ph type="sldNum" sz="quarter" idx="10"/>
+          </p:nvPr>
+        </p:nvSpPr>
+        <p:spPr/>
+        <p:txBody>
+          <a:bodyPr/>
+          <a:lstStyle/>
+          <a:p>
+            <a:fld id="{F7021451-1387-4CA6-816F-3879F97B5CBC}" type="slidenum">
+              <a:rPr lang="en-US"/>
+              <a:t>11</a:t>
+            </a:fld>
+            <a:endParaRPr lang="en-US"/>
+          </a:p>
+        </p:txBody>
+      </p:sp>
+    </p:spTree>
+    <p:extLst>
+      <p:ext uri="{BB962C8B-B14F-4D97-AF65-F5344CB8AC3E}">
+        <p14:creationId xmlns:p14="http://schemas.microsoft.com/office/powerpoint/2010/main" val="1024086991"/>
+      </p:ext>
+    </p:extLst>
+  </p:cSld>
+  <p:clrMapOvr>
+    <a:masterClrMapping/>
+  </p:clrMapOvr>
+</p:notes>
+</file>
+
+<file path=ppt/notesSlides/notesSlide12.xml><?xml version="1.0" encoding="utf-8"?>
+<p:notes xmlns:a="http://schemas.openxmlformats.org/drawingml/2006/main" xmlns:r="http://schemas.openxmlformats.org/officeDocument/2006/relationships" xmlns:p="http://schemas.openxmlformats.org/presentationml/2006/main">
+  <p:cSld>
+    <p:spTree>
+      <p:nvGrpSpPr>
+        <p:cNvPr id="1" name=""/>
+        <p:cNvGrpSpPr/>
+        <p:nvPr/>
+      </p:nvGrpSpPr>
+      <p:grpSpPr>
+        <a:xfrm>
+          <a:off x="0" y="0"/>
+          <a:ext cx="0" cy="0"/>
+          <a:chOff x="0" y="0"/>
+          <a:chExt cx="0" cy="0"/>
+        </a:xfrm>
+      </p:grpSpPr>
+      <p:sp>
+        <p:nvSpPr>
+          <p:cNvPr id="2" name="Slide Image Placeholder 1"/>
+          <p:cNvSpPr>
+            <a:spLocks noGrp="1" noRot="1" noChangeAspect="1"/>
+          </p:cNvSpPr>
+          <p:nvPr>
+            <p:ph type="sldImg"/>
+          </p:nvPr>
+        </p:nvSpPr>
+        <p:spPr/>
+      </p:sp>
+      <p:sp>
+        <p:nvSpPr>
+          <p:cNvPr id="3" name="Notes Placeholder 2"/>
+          <p:cNvSpPr>
+            <a:spLocks noGrp="1"/>
+          </p:cNvSpPr>
+          <p:nvPr>
+            <p:ph type="body" idx="1"/>
+          </p:nvPr>
+        </p:nvSpPr>
+        <p:spPr/>
+        <p:txBody>
+          <a:bodyPr/>
+          <a:lstStyle/>
+          <a:p>
+            <a:r>
+              <a:rPr lang="en-US" dirty="0"/>
+              <a:t/>
+            </a:r>
+            <a:endParaRPr lang="en-US" dirty="0"/>
+          </a:p>
+        </p:txBody>
+      </p:sp>
+      <p:sp>
+        <p:nvSpPr>
+          <p:cNvPr id="4" name="Slide Number Placeholder 3"/>
+          <p:cNvSpPr>
+            <a:spLocks noGrp="1"/>
+          </p:cNvSpPr>
+          <p:nvPr>
+            <p:ph type="sldNum" sz="quarter" idx="10"/>
+          </p:nvPr>
+        </p:nvSpPr>
+        <p:spPr/>
+        <p:txBody>
+          <a:bodyPr/>
+          <a:lstStyle/>
+          <a:p>
+            <a:fld id="{F7021451-1387-4CA6-816F-3879F97B5CBC}" type="slidenum">
+              <a:rPr lang="en-US"/>
+              <a:t>12</a:t>
+            </a:fld>
+            <a:endParaRPr lang="en-US"/>
+          </a:p>
+        </p:txBody>
+      </p:sp>
+    </p:spTree>
+    <p:extLst>
+      <p:ext uri="{BB962C8B-B14F-4D97-AF65-F5344CB8AC3E}">
+        <p14:creationId xmlns:p14="http://schemas.microsoft.com/office/powerpoint/2010/main" val="1024086991"/>
+      </p:ext>
+    </p:extLst>
+  </p:cSld>
+  <p:clrMapOvr>
+    <a:masterClrMapping/>
+  </p:clrMapOvr>
+</p:notes>
+</file>
+
 <file path=ppt/notesSlides/notesSlide2.xml><?xml version="1.0" encoding="utf-8"?>
 <p:notes xmlns:a="http://schemas.openxmlformats.org/drawingml/2006/main" xmlns:r="http://schemas.openxmlformats.org/officeDocument/2006/relationships" xmlns:p="http://schemas.openxmlformats.org/presentationml/2006/main">
   <p:cSld>
@@ -1254,7 +1434,7 @@
           <a:p>
             <a:r>
               <a:rPr lang="en-US" dirty="0"/>
-              <a:t/>
+              <a:t>Left: the Todoist test item in the real service. Right: the same item read from the local JSON export in the dashboard.</a:t>
             </a:r>
             <a:endParaRPr lang="en-US" dirty="0"/>
           </a:p>
@@ -1342,7 +1522,7 @@
           <a:p>
             <a:r>
               <a:rPr lang="en-US" dirty="0"/>
-              <a:t/>
+              <a:t>Left: the Jira test item in the real service. Right: the same item read from the local JSON export in the dashboard.</a:t>
             </a:r>
             <a:endParaRPr lang="en-US" dirty="0"/>
           </a:p>
@@ -2051,7 +2231,7 @@
                   <a:schemeClr val="bg2"/>
                 </a:solidFill>
               </a:rPr>
-              <a:t>Claude Code + MCP: Gmail, GitHub, Notion and Linear</a:t>
+              <a:t>Claude Code + MCP: Gmail, GitHub, Notion, Linear, Todoist and Jira</a:t>
             </a:r>
             <a:endParaRPr lang="en-US" sz="2000" dirty="0"/>
           </a:p>
@@ -2240,6 +2420,86 @@
                 </a:solidFill>
               </a:rPr>
               <a:t>Linear</a:t>
+            </a:r>
+            <a:endParaRPr lang="en-US" sz="1200" dirty="0"/>
+          </a:p>
+        </p:txBody>
+      </p:sp>
+      <p:sp>
+        <p:nvSpPr>
+          <p:cNvPr id="8" name="label Todoist"/>
+          <p:cNvSpPr txBox="1"/>
+          <p:nvPr/>
+        </p:nvSpPr>
+        <p:spPr>
+          <a:xfrm>
+            <a:off x="6035040" y="1280160"/>
+            <a:ext cx="1143000" cy="329184"/>
+          </a:xfrm>
+          <a:prstGeom prst="roundRect">
+            <a:avLst>
+              <a:gd name="adj" fmla="val 22222"/>
+            </a:avLst>
+          </a:prstGeom>
+          <a:solidFill>
+            <a:srgbClr val="C2410C"/>
+          </a:solidFill>
+          <a:ln/>
+        </p:spPr>
+        <p:txBody>
+          <a:bodyPr wrap="square" lIns="0" tIns="0" rIns="0" bIns="0" rtlCol="0" anchor="ctr"/>
+          <a:lstStyle/>
+          <a:p>
+            <a:pPr algn="ctr" indent="0" marL="0">
+              <a:buNone/>
+            </a:pPr>
+            <a:r>
+              <a:rPr lang="en-US" sz="1200" b="1" dirty="0">
+                <a:solidFill>
+                  <a:srgbClr val="FFFFFF"/>
+                </a:solidFill>
+              </a:rPr>
+              <a:t>Todoist</a:t>
+            </a:r>
+            <a:endParaRPr lang="en-US" sz="1200" dirty="0"/>
+          </a:p>
+        </p:txBody>
+      </p:sp>
+      <p:sp>
+        <p:nvSpPr>
+          <p:cNvPr id="9" name="label Jira"/>
+          <p:cNvSpPr txBox="1"/>
+          <p:nvPr/>
+        </p:nvSpPr>
+        <p:spPr>
+          <a:xfrm>
+            <a:off x="7360920" y="1280160"/>
+            <a:ext cx="1143000" cy="329184"/>
+          </a:xfrm>
+          <a:prstGeom prst="roundRect">
+            <a:avLst>
+              <a:gd name="adj" fmla="val 22222"/>
+            </a:avLst>
+          </a:prstGeom>
+          <a:solidFill>
+            <a:srgbClr val="0C66E4"/>
+          </a:solidFill>
+          <a:ln/>
+        </p:spPr>
+        <p:txBody>
+          <a:bodyPr wrap="square" lIns="0" tIns="0" rIns="0" bIns="0" rtlCol="0" anchor="ctr"/>
+          <a:lstStyle/>
+          <a:p>
+            <a:pPr algn="ctr" indent="0" marL="0">
+              <a:buNone/>
+            </a:pPr>
+            <a:r>
+              <a:rPr lang="en-US" sz="1200" b="1" dirty="0">
+                <a:solidFill>
+                  <a:srgbClr val="FFFFFF"/>
+                </a:solidFill>
+              </a:rPr>
+              <a:t>Jira</a:t>
             </a:r>
             <a:endParaRPr lang="en-US" sz="1200" dirty="0"/>
           </a:p>
@@ -2280,6 +2540,1005 @@
         </p:nvSpPr>
         <p:spPr>
           <a:xfrm>
+            <a:off x="457200" y="320040"/>
+            <a:ext cx="11247120" cy="777240"/>
+          </a:xfrm>
+          <a:prstGeom prst="rect">
+            <a:avLst/>
+          </a:prstGeom>
+          <a:noFill/>
+          <a:ln/>
+        </p:spPr>
+        <p:txBody>
+          <a:bodyPr wrap="square" lIns="0" tIns="0" rIns="0" bIns="0" rtlCol="0" anchor="ctr"/>
+          <a:lstStyle/>
+          <a:p>
+            <a:pPr algn="l" indent="0" marL="0">
+              <a:buNone/>
+            </a:pPr>
+            <a:r>
+              <a:rPr lang="en-US" sz="3600" b="1" dirty="0">
+                <a:solidFill>
+                  <a:schemeClr val="tx1"/>
+                </a:solidFill>
+              </a:rPr>
+              <a:t>One search across every service</a:t>
+            </a:r>
+            <a:endParaRPr lang="en-US" sz="3600" dirty="0"/>
+          </a:p>
+        </p:txBody>
+      </p:sp>
+      <p:pic>
+        <p:nvPicPr>
+          <p:cNvPr id="3" name="Dashboard search for joe smith returning results from all services" descr="Dashboard search for joe smith returning results from all services">    </p:cNvPr>
+          <p:cNvPicPr>
+            <a:picLocks noChangeAspect="1"/>
+          </p:cNvPicPr>
+          <p:nvPr/>
+        </p:nvPicPr>
+        <p:blipFill>
+          <a:blip r:embed="rId1"/>
+          <a:stretch>
+            <a:fillRect/>
+          </a:stretch>
+        </p:blipFill>
+        <p:spPr>
+          <a:xfrm>
+            <a:off x="457200" y="1371600"/>
+            <a:ext cx="7863840" cy="4914900"/>
+          </a:xfrm>
+          <a:prstGeom prst="rect">
+            <a:avLst/>
+          </a:prstGeom>
+          <a:effectLst>
+            <a:outerShdw sx="100000" sy="100000" kx="0" ky="0" algn="bl" rotWithShape="0" blurRad="101600" dist="25400" dir="5400000">
+              <a:srgbClr val="1B2433">
+                <a:alpha val="18000"/>
+              </a:srgbClr>
+            </a:outerShdw>
+          </a:effectLst>
+        </p:spPr>
+      </p:pic>
+      <p:sp>
+        <p:nvSpPr>
+          <p:cNvPr id="4" name="stat results for “joe smith”"/>
+          <p:cNvSpPr txBox="1"/>
+          <p:nvPr/>
+        </p:nvSpPr>
+        <p:spPr>
+          <a:xfrm>
+            <a:off x="8778240" y="1463040"/>
+            <a:ext cx="2926080" cy="822960"/>
+          </a:xfrm>
+          <a:prstGeom prst="rect">
+            <a:avLst/>
+          </a:prstGeom>
+          <a:noFill/>
+          <a:ln/>
+        </p:spPr>
+        <p:txBody>
+          <a:bodyPr wrap="square" lIns="0" tIns="0" rIns="0" bIns="0" rtlCol="0" anchor="ctr"/>
+          <a:lstStyle/>
+          <a:p>
+            <a:pPr indent="0" marL="0">
+              <a:buNone/>
+            </a:pPr>
+            <a:r>
+              <a:rPr lang="en-US" sz="5400" b="1" dirty="0">
+                <a:solidFill>
+                  <a:schemeClr val="tx1"/>
+                </a:solidFill>
+              </a:rPr>
+              <a:t>19</a:t>
+            </a:r>
+            <a:endParaRPr lang="en-US" sz="5400" dirty="0"/>
+          </a:p>
+        </p:txBody>
+      </p:sp>
+      <p:sp>
+        <p:nvSpPr>
+          <p:cNvPr id="5" name="stat label results for “joe smith”"/>
+          <p:cNvSpPr txBox="1"/>
+          <p:nvPr/>
+        </p:nvSpPr>
+        <p:spPr>
+          <a:xfrm>
+            <a:off x="8778240" y="2286000"/>
+            <a:ext cx="2926080" cy="457200"/>
+          </a:xfrm>
+          <a:prstGeom prst="rect">
+            <a:avLst/>
+          </a:prstGeom>
+          <a:noFill/>
+          <a:ln/>
+        </p:spPr>
+        <p:txBody>
+          <a:bodyPr wrap="square" lIns="0" tIns="0" rIns="0" bIns="0" rtlCol="0" anchor="ctr"/>
+          <a:lstStyle/>
+          <a:p>
+            <a:pPr indent="0" marL="0">
+              <a:buNone/>
+            </a:pPr>
+            <a:r>
+              <a:rPr lang="en-US" sz="1500" dirty="0">
+                <a:solidFill>
+                  <a:schemeClr val="tx2"/>
+                </a:solidFill>
+              </a:rPr>
+              <a:t>results for “joe smith”</a:t>
+            </a:r>
+            <a:endParaRPr lang="en-US" sz="1500" dirty="0"/>
+          </a:p>
+        </p:txBody>
+      </p:sp>
+      <p:sp>
+        <p:nvSpPr>
+          <p:cNvPr id="6" name="stat services in one list"/>
+          <p:cNvSpPr txBox="1"/>
+          <p:nvPr/>
+        </p:nvSpPr>
+        <p:spPr>
+          <a:xfrm>
+            <a:off x="8778240" y="3063240"/>
+            <a:ext cx="2926080" cy="822960"/>
+          </a:xfrm>
+          <a:prstGeom prst="rect">
+            <a:avLst/>
+          </a:prstGeom>
+          <a:noFill/>
+          <a:ln/>
+        </p:spPr>
+        <p:txBody>
+          <a:bodyPr wrap="square" lIns="0" tIns="0" rIns="0" bIns="0" rtlCol="0" anchor="ctr"/>
+          <a:lstStyle/>
+          <a:p>
+            <a:pPr indent="0" marL="0">
+              <a:buNone/>
+            </a:pPr>
+            <a:r>
+              <a:rPr lang="en-US" sz="5400" b="1" dirty="0">
+                <a:solidFill>
+                  <a:schemeClr val="tx1"/>
+                </a:solidFill>
+              </a:rPr>
+              <a:t>4</a:t>
+            </a:r>
+            <a:endParaRPr lang="en-US" sz="5400" dirty="0"/>
+          </a:p>
+        </p:txBody>
+      </p:sp>
+      <p:sp>
+        <p:nvSpPr>
+          <p:cNvPr id="7" name="stat label services in one list"/>
+          <p:cNvSpPr txBox="1"/>
+          <p:nvPr/>
+        </p:nvSpPr>
+        <p:spPr>
+          <a:xfrm>
+            <a:off x="8778240" y="3886200"/>
+            <a:ext cx="2926080" cy="457200"/>
+          </a:xfrm>
+          <a:prstGeom prst="rect">
+            <a:avLst/>
+          </a:prstGeom>
+          <a:noFill/>
+          <a:ln/>
+        </p:spPr>
+        <p:txBody>
+          <a:bodyPr wrap="square" lIns="0" tIns="0" rIns="0" bIns="0" rtlCol="0" anchor="ctr"/>
+          <a:lstStyle/>
+          <a:p>
+            <a:pPr indent="0" marL="0">
+              <a:buNone/>
+            </a:pPr>
+            <a:r>
+              <a:rPr lang="en-US" sz="1500" dirty="0">
+                <a:solidFill>
+                  <a:schemeClr val="tx2"/>
+                </a:solidFill>
+              </a:rPr>
+              <a:t>services in one list</a:t>
+            </a:r>
+            <a:endParaRPr lang="en-US" sz="1500" dirty="0"/>
+          </a:p>
+        </p:txBody>
+      </p:sp>
+      <p:sp>
+        <p:nvSpPr>
+          <p:cNvPr id="8" name="stat items searchable offline"/>
+          <p:cNvSpPr txBox="1"/>
+          <p:nvPr/>
+        </p:nvSpPr>
+        <p:spPr>
+          <a:xfrm>
+            <a:off x="8778240" y="4663440"/>
+            <a:ext cx="2926080" cy="822960"/>
+          </a:xfrm>
+          <a:prstGeom prst="rect">
+            <a:avLst/>
+          </a:prstGeom>
+          <a:noFill/>
+          <a:ln/>
+        </p:spPr>
+        <p:txBody>
+          <a:bodyPr wrap="square" lIns="0" tIns="0" rIns="0" bIns="0" rtlCol="0" anchor="ctr"/>
+          <a:lstStyle/>
+          <a:p>
+            <a:pPr indent="0" marL="0">
+              <a:buNone/>
+            </a:pPr>
+            <a:r>
+              <a:rPr lang="en-US" sz="5400" b="1" dirty="0">
+                <a:solidFill>
+                  <a:schemeClr val="tx1"/>
+                </a:solidFill>
+              </a:rPr>
+              <a:t>102</a:t>
+            </a:r>
+            <a:endParaRPr lang="en-US" sz="5400" dirty="0"/>
+          </a:p>
+        </p:txBody>
+      </p:sp>
+      <p:sp>
+        <p:nvSpPr>
+          <p:cNvPr id="9" name="stat label items searchable offline"/>
+          <p:cNvSpPr txBox="1"/>
+          <p:nvPr/>
+        </p:nvSpPr>
+        <p:spPr>
+          <a:xfrm>
+            <a:off x="8778240" y="5486400"/>
+            <a:ext cx="2926080" cy="457200"/>
+          </a:xfrm>
+          <a:prstGeom prst="rect">
+            <a:avLst/>
+          </a:prstGeom>
+          <a:noFill/>
+          <a:ln/>
+        </p:spPr>
+        <p:txBody>
+          <a:bodyPr wrap="square" lIns="0" tIns="0" rIns="0" bIns="0" rtlCol="0" anchor="ctr"/>
+          <a:lstStyle/>
+          <a:p>
+            <a:pPr indent="0" marL="0">
+              <a:buNone/>
+            </a:pPr>
+            <a:r>
+              <a:rPr lang="en-US" sz="1500" dirty="0">
+                <a:solidFill>
+                  <a:schemeClr val="tx2"/>
+                </a:solidFill>
+              </a:rPr>
+              <a:t>items searchable offline</a:t>
+            </a:r>
+            <a:endParaRPr lang="en-US" sz="1500" dirty="0"/>
+          </a:p>
+        </p:txBody>
+      </p:sp>
+      <p:sp>
+        <p:nvSpPr>
+          <p:cNvPr id="25" name="Slide Number Placeholder 0"/>
+          <p:cNvSpPr>
+            <a:spLocks noGrp="1"/>
+          </p:cNvSpPr>
+          <p:nvPr>
+            <p:ph type="sldNum" sz="quarter" idx="4294967295"/>
+          </p:nvPr>
+        </p:nvSpPr>
+        <p:spPr>
+          <a:xfrm>
+            <a:off x="11338560" y="6400800"/>
+            <a:ext cx="457200" cy="274320"/>
+          </a:xfrm>
+          <a:prstGeom prst="rect">
+            <a:avLst/>
+          </a:prstGeom>
+          <a:extLst>
+            <a:ext uri="{C572A759-6A51-4108-AA02-DFA0A04FC94B}">
+              <ma14:wrappingTextBoxFlag xmlns:ma14="http://schemas.microsoft.com/office/mac/drawingml/2011/main" val="0"/>
+            </a:ext>
+          </a:extLst>
+        </p:spPr>
+        <p:txBody>
+          <a:bodyPr/>
+          <a:lstStyle>
+            <a:lvl1pPr>
+              <a:defRPr sz="1000">
+                <a:solidFill>
+                  <a:schemeClr val="tx2"/>
+                </a:solidFill>
+              </a:defRPr>
+            </a:lvl1pPr>
+          </a:lstStyle>
+          <a:p>
+            <a:pPr algn="l"/>
+            <a:fld id="{F7021451-1387-4CA6-816F-3879F97B5CBC}" type="slidenum">
+              <a:rPr b="0" lang="en-US"/>
+              <a:t>10</a:t>
+            </a:fld>
+            <a:endParaRPr lang="en-US"/>
+          </a:p>
+        </p:txBody>
+      </p:sp>
+    </p:spTree>
+  </p:cSld>
+  <p:clrMapOvr>
+    <a:masterClrMapping/>
+  </p:clrMapOvr>
+</p:sld>
+</file>
+
+<file path=ppt/slides/slide11.xml><?xml version="1.0" encoding="utf-8"?>
+<p:sld xmlns:a="http://schemas.openxmlformats.org/drawingml/2006/main" xmlns:r="http://schemas.openxmlformats.org/officeDocument/2006/relationships" xmlns:p="http://schemas.openxmlformats.org/presentationml/2006/main">
+  <p:cSld name="Slide 11">
+    <p:spTree>
+      <p:nvGrpSpPr>
+        <p:cNvPr id="1" name=""/>
+        <p:cNvGrpSpPr/>
+        <p:nvPr/>
+      </p:nvGrpSpPr>
+      <p:grpSpPr>
+        <a:xfrm>
+          <a:off x="0" y="0"/>
+          <a:ext cx="0" cy="0"/>
+          <a:chOff x="0" y="0"/>
+          <a:chExt cx="0" cy="0"/>
+        </a:xfrm>
+      </p:grpSpPr>
+      <p:sp>
+        <p:nvSpPr>
+          <p:cNvPr id="2" name="Text 0"/>
+          <p:cNvSpPr/>
+          <p:nvPr>
+            <p:ph idx="100" type="title" hasCustomPrompt="1"/>
+          </p:nvPr>
+        </p:nvSpPr>
+        <p:spPr>
+          <a:xfrm>
+            <a:off x="457200" y="320040"/>
+            <a:ext cx="11247120" cy="777240"/>
+          </a:xfrm>
+          <a:prstGeom prst="rect">
+            <a:avLst/>
+          </a:prstGeom>
+          <a:noFill/>
+          <a:ln/>
+        </p:spPr>
+        <p:txBody>
+          <a:bodyPr wrap="square" lIns="0" tIns="0" rIns="0" bIns="0" rtlCol="0" anchor="ctr"/>
+          <a:lstStyle/>
+          <a:p>
+            <a:pPr algn="l" indent="0" marL="0">
+              <a:buNone/>
+            </a:pPr>
+            <a:r>
+              <a:rPr lang="en-US" sz="3600" b="1" dirty="0">
+                <a:solidFill>
+                  <a:schemeClr val="tx1"/>
+                </a:solidFill>
+              </a:rPr>
+              <a:t>A documented format and a reusable skill</a:t>
+            </a:r>
+            <a:endParaRPr lang="en-US" sz="3600" dirty="0"/>
+          </a:p>
+        </p:txBody>
+      </p:sp>
+      <p:sp>
+        <p:nvSpPr>
+          <p:cNvPr id="3" name="localStorageFormats.md card"/>
+          <p:cNvSpPr/>
+          <p:nvPr/>
+        </p:nvSpPr>
+        <p:spPr>
+          <a:xfrm>
+            <a:off x="457200" y="1463040"/>
+            <a:ext cx="5486400" cy="3657600"/>
+          </a:xfrm>
+          <a:prstGeom prst="roundRect">
+            <a:avLst>
+              <a:gd name="adj" fmla="val 3000"/>
+            </a:avLst>
+          </a:prstGeom>
+          <a:solidFill>
+            <a:schemeClr val="bg2"/>
+          </a:solidFill>
+          <a:ln w="12700">
+            <a:solidFill>
+              <a:schemeClr val="bg2"/>
+            </a:solidFill>
+            <a:prstDash val="solid"/>
+          </a:ln>
+        </p:spPr>
+      </p:sp>
+      <p:sp>
+        <p:nvSpPr>
+          <p:cNvPr id="4" name="localStorageFormats.md heading"/>
+          <p:cNvSpPr txBox="1"/>
+          <p:nvPr/>
+        </p:nvSpPr>
+        <p:spPr>
+          <a:xfrm>
+            <a:off x="777240" y="1691640"/>
+            <a:ext cx="4846320" cy="502920"/>
+          </a:xfrm>
+          <a:prstGeom prst="rect">
+            <a:avLst/>
+          </a:prstGeom>
+          <a:noFill/>
+          <a:ln/>
+        </p:spPr>
+        <p:txBody>
+          <a:bodyPr wrap="square" lIns="0" tIns="0" rIns="0" bIns="0" rtlCol="0" anchor="ctr"/>
+          <a:lstStyle/>
+          <a:p>
+            <a:pPr indent="0" marL="0">
+              <a:buNone/>
+            </a:pPr>
+            <a:r>
+              <a:rPr lang="en-US" sz="2000" b="1" dirty="0">
+                <a:solidFill>
+                  <a:schemeClr val="tx1"/>
+                </a:solidFill>
+              </a:rPr>
+              <a:t>localStorageFormats.md</a:t>
+            </a:r>
+            <a:endParaRPr lang="en-US" sz="2000" dirty="0"/>
+          </a:p>
+        </p:txBody>
+      </p:sp>
+      <p:sp>
+        <p:nvSpPr>
+          <p:cNvPr id="5" name="localStorageFormats.md list"/>
+          <p:cNvSpPr txBox="1"/>
+          <p:nvPr/>
+        </p:nvSpPr>
+        <p:spPr>
+          <a:xfrm>
+            <a:off x="777240" y="2331720"/>
+            <a:ext cx="4846320" cy="3108960"/>
+          </a:xfrm>
+          <a:prstGeom prst="rect">
+            <a:avLst/>
+          </a:prstGeom>
+          <a:noFill/>
+          <a:ln/>
+        </p:spPr>
+        <p:txBody>
+          <a:bodyPr wrap="square" lIns="0" tIns="0" rIns="0" bIns="0" rtlCol="0" anchor="t"/>
+          <a:lstStyle/>
+          <a:p>
+            <a:pPr marL="342900" indent="-342900">
+              <a:spcAft>
+                <a:spcPts val="800"/>
+              </a:spcAft>
+              <a:buSzPct val="100000"/>
+              <a:buChar char="•"/>
+            </a:pPr>
+            <a:r>
+              <a:rPr lang="en-US" sz="1500" dirty="0">
+                <a:solidFill>
+                  <a:schemeClr val="tx2"/>
+                </a:solidFill>
+              </a:rPr>
+              <a:t>One sub-folder per service in dataExports/</a:t>
+            </a:r>
+            <a:endParaRPr lang="en-US" sz="1500" dirty="0"/>
+          </a:p>
+          <a:p>
+            <a:pPr marL="342900" indent="-342900">
+              <a:spcAft>
+                <a:spcPts val="800"/>
+              </a:spcAft>
+              <a:buSzPct val="100000"/>
+              <a:buChar char="•"/>
+            </a:pPr>
+            <a:r>
+              <a:rPr lang="en-US" sz="1500" dirty="0">
+                <a:solidFill>
+                  <a:schemeClr val="tx2"/>
+                </a:solidFill>
+              </a:rPr>
+              <a:t>One JSON file per item: &lt;UTC time&gt;_&lt;short id&gt;.json</a:t>
+            </a:r>
+            <a:endParaRPr lang="en-US" sz="1500" dirty="0"/>
+          </a:p>
+          <a:p>
+            <a:pPr marL="342900" indent="-342900">
+              <a:spcAft>
+                <a:spcPts val="800"/>
+              </a:spcAft>
+              <a:buSzPct val="100000"/>
+              <a:buChar char="•"/>
+            </a:pPr>
+            <a:r>
+              <a:rPr lang="en-US" sz="1500" dirty="0">
+                <a:solidFill>
+                  <a:schemeClr val="tx2"/>
+                </a:solidFill>
+              </a:rPr>
+              <a:t>Shared fields: service, id, title, body, author, created, updated, url</a:t>
+            </a:r>
+            <a:endParaRPr lang="en-US" sz="1500" dirty="0"/>
+          </a:p>
+          <a:p>
+            <a:pPr marL="342900" indent="-342900">
+              <a:spcAft>
+                <a:spcPts val="800"/>
+              </a:spcAft>
+              <a:buSzPct val="100000"/>
+              <a:buChar char="•"/>
+            </a:pPr>
+            <a:r>
+              <a:rPr lang="en-US" sz="1500" dirty="0">
+                <a:solidFill>
+                  <a:schemeClr val="tx2"/>
+                </a:solidFill>
+              </a:rPr>
+              <a:t>Service-specific details in a metadata object (email from/to/labels, repo README, issue status/priority…)</a:t>
+            </a:r>
+            <a:endParaRPr lang="en-US" sz="1500" dirty="0"/>
+          </a:p>
+        </p:txBody>
+      </p:sp>
+      <p:sp>
+        <p:nvSpPr>
+          <p:cNvPr id="6" name=".claude/skills/export-service-data card"/>
+          <p:cNvSpPr/>
+          <p:nvPr/>
+        </p:nvSpPr>
+        <p:spPr>
+          <a:xfrm>
+            <a:off x="6172200" y="1463040"/>
+            <a:ext cx="5486400" cy="3657600"/>
+          </a:xfrm>
+          <a:prstGeom prst="roundRect">
+            <a:avLst>
+              <a:gd name="adj" fmla="val 3000"/>
+            </a:avLst>
+          </a:prstGeom>
+          <a:solidFill>
+            <a:schemeClr val="bg2"/>
+          </a:solidFill>
+          <a:ln w="12700">
+            <a:solidFill>
+              <a:schemeClr val="bg2"/>
+            </a:solidFill>
+            <a:prstDash val="solid"/>
+          </a:ln>
+        </p:spPr>
+      </p:sp>
+      <p:sp>
+        <p:nvSpPr>
+          <p:cNvPr id="7" name=".claude/skills/export-service-data heading"/>
+          <p:cNvSpPr txBox="1"/>
+          <p:nvPr/>
+        </p:nvSpPr>
+        <p:spPr>
+          <a:xfrm>
+            <a:off x="6492240" y="1691640"/>
+            <a:ext cx="4846320" cy="502920"/>
+          </a:xfrm>
+          <a:prstGeom prst="rect">
+            <a:avLst/>
+          </a:prstGeom>
+          <a:noFill/>
+          <a:ln/>
+        </p:spPr>
+        <p:txBody>
+          <a:bodyPr wrap="square" lIns="0" tIns="0" rIns="0" bIns="0" rtlCol="0" anchor="ctr"/>
+          <a:lstStyle/>
+          <a:p>
+            <a:pPr indent="0" marL="0">
+              <a:buNone/>
+            </a:pPr>
+            <a:r>
+              <a:rPr lang="en-US" sz="2000" b="1" dirty="0">
+                <a:solidFill>
+                  <a:schemeClr val="tx1"/>
+                </a:solidFill>
+              </a:rPr>
+              <a:t>.claude/skills/export-service-data</a:t>
+            </a:r>
+            <a:endParaRPr lang="en-US" sz="2000" dirty="0"/>
+          </a:p>
+        </p:txBody>
+      </p:sp>
+      <p:sp>
+        <p:nvSpPr>
+          <p:cNvPr id="8" name=".claude/skills/export-service-data list"/>
+          <p:cNvSpPr txBox="1"/>
+          <p:nvPr/>
+        </p:nvSpPr>
+        <p:spPr>
+          <a:xfrm>
+            <a:off x="6492240" y="2331720"/>
+            <a:ext cx="4846320" cy="3108960"/>
+          </a:xfrm>
+          <a:prstGeom prst="rect">
+            <a:avLst/>
+          </a:prstGeom>
+          <a:noFill/>
+          <a:ln/>
+        </p:spPr>
+        <p:txBody>
+          <a:bodyPr wrap="square" lIns="0" tIns="0" rIns="0" bIns="0" rtlCol="0" anchor="t"/>
+          <a:lstStyle/>
+          <a:p>
+            <a:pPr marL="342900" indent="-342900">
+              <a:spcAft>
+                <a:spcPts val="800"/>
+              </a:spcAft>
+              <a:buSzPct val="100000"/>
+              <a:buChar char="•"/>
+            </a:pPr>
+            <a:r>
+              <a:rPr lang="en-US" sz="1500" dirty="0">
+                <a:solidFill>
+                  <a:schemeClr val="tx2"/>
+                </a:solidFill>
+              </a:rPr>
+              <a:t>Tells Claude how to download from each service and store it exactly per the format doc</a:t>
+            </a:r>
+            <a:endParaRPr lang="en-US" sz="1500" dirty="0"/>
+          </a:p>
+          <a:p>
+            <a:pPr marL="342900" indent="-342900">
+              <a:spcAft>
+                <a:spcPts val="800"/>
+              </a:spcAft>
+              <a:buSzPct val="100000"/>
+              <a:buChar char="•"/>
+            </a:pPr>
+            <a:r>
+              <a:rPr lang="en-US" sz="1500" dirty="0">
+                <a:solidFill>
+                  <a:schemeClr val="tx2"/>
+                </a:solidFill>
+              </a:rPr>
+              <a:t>Skips items already on disk by comparing ids</a:t>
+            </a:r>
+            <a:endParaRPr lang="en-US" sz="1500" dirty="0"/>
+          </a:p>
+          <a:p>
+            <a:pPr marL="342900" indent="-342900">
+              <a:spcAft>
+                <a:spcPts val="800"/>
+              </a:spcAft>
+              <a:buSzPct val="100000"/>
+              <a:buChar char="•"/>
+            </a:pPr>
+            <a:r>
+              <a:rPr lang="en-US" sz="1500" dirty="0">
+                <a:solidFill>
+                  <a:schemeClr val="tx2"/>
+                </a:solidFill>
+              </a:rPr>
+              <a:t>Tested in a fresh conversation: skipped the 25 existing items and saved only new ones</a:t>
+            </a:r>
+            <a:endParaRPr lang="en-US" sz="1500" dirty="0"/>
+          </a:p>
+        </p:txBody>
+      </p:sp>
+      <p:sp>
+        <p:nvSpPr>
+          <p:cNvPr id="9" name="label Gmail: 24"/>
+          <p:cNvSpPr txBox="1"/>
+          <p:nvPr/>
+        </p:nvSpPr>
+        <p:spPr>
+          <a:xfrm>
+            <a:off x="457200" y="5440680"/>
+            <a:ext cx="1737360" cy="329184"/>
+          </a:xfrm>
+          <a:prstGeom prst="roundRect">
+            <a:avLst>
+              <a:gd name="adj" fmla="val 22222"/>
+            </a:avLst>
+          </a:prstGeom>
+          <a:solidFill>
+            <a:srgbClr val="D93025"/>
+          </a:solidFill>
+          <a:ln/>
+        </p:spPr>
+        <p:txBody>
+          <a:bodyPr wrap="square" lIns="0" tIns="0" rIns="0" bIns="0" rtlCol="0" anchor="ctr"/>
+          <a:lstStyle/>
+          <a:p>
+            <a:pPr algn="ctr" indent="0" marL="0">
+              <a:buNone/>
+            </a:pPr>
+            <a:r>
+              <a:rPr lang="en-US" sz="1200" b="1" dirty="0">
+                <a:solidFill>
+                  <a:srgbClr val="FFFFFF"/>
+                </a:solidFill>
+              </a:rPr>
+              <a:t>Gmail: 24</a:t>
+            </a:r>
+            <a:endParaRPr lang="en-US" sz="1200" dirty="0"/>
+          </a:p>
+        </p:txBody>
+      </p:sp>
+      <p:sp>
+        <p:nvSpPr>
+          <p:cNvPr id="10" name="label GitHub: 11"/>
+          <p:cNvSpPr txBox="1"/>
+          <p:nvPr/>
+        </p:nvSpPr>
+        <p:spPr>
+          <a:xfrm>
+            <a:off x="2350008" y="5440680"/>
+            <a:ext cx="1737360" cy="329184"/>
+          </a:xfrm>
+          <a:prstGeom prst="roundRect">
+            <a:avLst>
+              <a:gd name="adj" fmla="val 22222"/>
+            </a:avLst>
+          </a:prstGeom>
+          <a:solidFill>
+            <a:srgbClr val="24292F"/>
+          </a:solidFill>
+          <a:ln/>
+        </p:spPr>
+        <p:txBody>
+          <a:bodyPr wrap="square" lIns="0" tIns="0" rIns="0" bIns="0" rtlCol="0" anchor="ctr"/>
+          <a:lstStyle/>
+          <a:p>
+            <a:pPr algn="ctr" indent="0" marL="0">
+              <a:buNone/>
+            </a:pPr>
+            <a:r>
+              <a:rPr lang="en-US" sz="1200" b="1" dirty="0">
+                <a:solidFill>
+                  <a:srgbClr val="FFFFFF"/>
+                </a:solidFill>
+              </a:rPr>
+              <a:t>GitHub: 11</a:t>
+            </a:r>
+            <a:endParaRPr lang="en-US" sz="1200" dirty="0"/>
+          </a:p>
+        </p:txBody>
+      </p:sp>
+      <p:sp>
+        <p:nvSpPr>
+          <p:cNvPr id="11" name="label Notion: 20"/>
+          <p:cNvSpPr txBox="1"/>
+          <p:nvPr/>
+        </p:nvSpPr>
+        <p:spPr>
+          <a:xfrm>
+            <a:off x="4242816" y="5440680"/>
+            <a:ext cx="1737360" cy="329184"/>
+          </a:xfrm>
+          <a:prstGeom prst="roundRect">
+            <a:avLst>
+              <a:gd name="adj" fmla="val 22222"/>
+            </a:avLst>
+          </a:prstGeom>
+          <a:solidFill>
+            <a:srgbClr val="7A6A55"/>
+          </a:solidFill>
+          <a:ln/>
+        </p:spPr>
+        <p:txBody>
+          <a:bodyPr wrap="square" lIns="0" tIns="0" rIns="0" bIns="0" rtlCol="0" anchor="ctr"/>
+          <a:lstStyle/>
+          <a:p>
+            <a:pPr algn="ctr" indent="0" marL="0">
+              <a:buNone/>
+            </a:pPr>
+            <a:r>
+              <a:rPr lang="en-US" sz="1200" b="1" dirty="0">
+                <a:solidFill>
+                  <a:srgbClr val="FFFFFF"/>
+                </a:solidFill>
+              </a:rPr>
+              <a:t>Notion: 20</a:t>
+            </a:r>
+            <a:endParaRPr lang="en-US" sz="1200" dirty="0"/>
+          </a:p>
+        </p:txBody>
+      </p:sp>
+      <p:sp>
+        <p:nvSpPr>
+          <p:cNvPr id="12" name="label Linear: 14"/>
+          <p:cNvSpPr txBox="1"/>
+          <p:nvPr/>
+        </p:nvSpPr>
+        <p:spPr>
+          <a:xfrm>
+            <a:off x="6135624" y="5440680"/>
+            <a:ext cx="1737360" cy="329184"/>
+          </a:xfrm>
+          <a:prstGeom prst="roundRect">
+            <a:avLst>
+              <a:gd name="adj" fmla="val 22222"/>
+            </a:avLst>
+          </a:prstGeom>
+          <a:solidFill>
+            <a:srgbClr val="5E6AD2"/>
+          </a:solidFill>
+          <a:ln/>
+        </p:spPr>
+        <p:txBody>
+          <a:bodyPr wrap="square" lIns="0" tIns="0" rIns="0" bIns="0" rtlCol="0" anchor="ctr"/>
+          <a:lstStyle/>
+          <a:p>
+            <a:pPr algn="ctr" indent="0" marL="0">
+              <a:buNone/>
+            </a:pPr>
+            <a:r>
+              <a:rPr lang="en-US" sz="1200" b="1" dirty="0">
+                <a:solidFill>
+                  <a:srgbClr val="FFFFFF"/>
+                </a:solidFill>
+              </a:rPr>
+              <a:t>Linear: 14</a:t>
+            </a:r>
+            <a:endParaRPr lang="en-US" sz="1200" dirty="0"/>
+          </a:p>
+        </p:txBody>
+      </p:sp>
+      <p:sp>
+        <p:nvSpPr>
+          <p:cNvPr id="13" name="label Todoist: 10"/>
+          <p:cNvSpPr txBox="1"/>
+          <p:nvPr/>
+        </p:nvSpPr>
+        <p:spPr>
+          <a:xfrm>
+            <a:off x="8028432" y="5440680"/>
+            <a:ext cx="1737360" cy="329184"/>
+          </a:xfrm>
+          <a:prstGeom prst="roundRect">
+            <a:avLst>
+              <a:gd name="adj" fmla="val 22222"/>
+            </a:avLst>
+          </a:prstGeom>
+          <a:solidFill>
+            <a:srgbClr val="C2410C"/>
+          </a:solidFill>
+          <a:ln/>
+        </p:spPr>
+        <p:txBody>
+          <a:bodyPr wrap="square" lIns="0" tIns="0" rIns="0" bIns="0" rtlCol="0" anchor="ctr"/>
+          <a:lstStyle/>
+          <a:p>
+            <a:pPr algn="ctr" indent="0" marL="0">
+              <a:buNone/>
+            </a:pPr>
+            <a:r>
+              <a:rPr lang="en-US" sz="1200" b="1" dirty="0">
+                <a:solidFill>
+                  <a:srgbClr val="FFFFFF"/>
+                </a:solidFill>
+              </a:rPr>
+              <a:t>Todoist: 10</a:t>
+            </a:r>
+            <a:endParaRPr lang="en-US" sz="1200" dirty="0"/>
+          </a:p>
+        </p:txBody>
+      </p:sp>
+      <p:sp>
+        <p:nvSpPr>
+          <p:cNvPr id="14" name="label Jira: 23"/>
+          <p:cNvSpPr txBox="1"/>
+          <p:nvPr/>
+        </p:nvSpPr>
+        <p:spPr>
+          <a:xfrm>
+            <a:off x="9921240" y="5440680"/>
+            <a:ext cx="1737360" cy="329184"/>
+          </a:xfrm>
+          <a:prstGeom prst="roundRect">
+            <a:avLst>
+              <a:gd name="adj" fmla="val 22222"/>
+            </a:avLst>
+          </a:prstGeom>
+          <a:solidFill>
+            <a:srgbClr val="0C66E4"/>
+          </a:solidFill>
+          <a:ln/>
+        </p:spPr>
+        <p:txBody>
+          <a:bodyPr wrap="square" lIns="0" tIns="0" rIns="0" bIns="0" rtlCol="0" anchor="ctr"/>
+          <a:lstStyle/>
+          <a:p>
+            <a:pPr algn="ctr" indent="0" marL="0">
+              <a:buNone/>
+            </a:pPr>
+            <a:r>
+              <a:rPr lang="en-US" sz="1200" b="1" dirty="0">
+                <a:solidFill>
+                  <a:srgbClr val="FFFFFF"/>
+                </a:solidFill>
+              </a:rPr>
+              <a:t>Jira: 23</a:t>
+            </a:r>
+            <a:endParaRPr lang="en-US" sz="1200" dirty="0"/>
+          </a:p>
+        </p:txBody>
+      </p:sp>
+      <p:sp>
+        <p:nvSpPr>
+          <p:cNvPr id="25" name="Slide Number Placeholder 0"/>
+          <p:cNvSpPr>
+            <a:spLocks noGrp="1"/>
+          </p:cNvSpPr>
+          <p:nvPr>
+            <p:ph type="sldNum" sz="quarter" idx="4294967295"/>
+          </p:nvPr>
+        </p:nvSpPr>
+        <p:spPr>
+          <a:xfrm>
+            <a:off x="11338560" y="6400800"/>
+            <a:ext cx="457200" cy="274320"/>
+          </a:xfrm>
+          <a:prstGeom prst="rect">
+            <a:avLst/>
+          </a:prstGeom>
+          <a:extLst>
+            <a:ext uri="{C572A759-6A51-4108-AA02-DFA0A04FC94B}">
+              <ma14:wrappingTextBoxFlag xmlns:ma14="http://schemas.microsoft.com/office/mac/drawingml/2011/main" val="0"/>
+            </a:ext>
+          </a:extLst>
+        </p:spPr>
+        <p:txBody>
+          <a:bodyPr/>
+          <a:lstStyle>
+            <a:lvl1pPr>
+              <a:defRPr sz="1000">
+                <a:solidFill>
+                  <a:schemeClr val="tx2"/>
+                </a:solidFill>
+              </a:defRPr>
+            </a:lvl1pPr>
+          </a:lstStyle>
+          <a:p>
+            <a:pPr algn="l"/>
+            <a:fld id="{F7021451-1387-4CA6-816F-3879F97B5CBC}" type="slidenum">
+              <a:rPr b="0" lang="en-US"/>
+              <a:t>11</a:t>
+            </a:fld>
+            <a:endParaRPr lang="en-US"/>
+          </a:p>
+        </p:txBody>
+      </p:sp>
+    </p:spTree>
+  </p:cSld>
+  <p:clrMapOvr>
+    <a:masterClrMapping/>
+  </p:clrMapOvr>
+</p:sld>
+</file>
+
+<file path=ppt/slides/slide12.xml><?xml version="1.0" encoding="utf-8"?>
+<p:sld xmlns:a="http://schemas.openxmlformats.org/drawingml/2006/main" xmlns:r="http://schemas.openxmlformats.org/officeDocument/2006/relationships" xmlns:p="http://schemas.openxmlformats.org/presentationml/2006/main">
+  <p:cSld name="Slide 12">
+    <p:spTree>
+      <p:nvGrpSpPr>
+        <p:cNvPr id="1" name=""/>
+        <p:cNvGrpSpPr/>
+        <p:nvPr/>
+      </p:nvGrpSpPr>
+      <p:grpSpPr>
+        <a:xfrm>
+          <a:off x="0" y="0"/>
+          <a:ext cx="0" cy="0"/>
+          <a:chOff x="0" y="0"/>
+          <a:chExt cx="0" cy="0"/>
+        </a:xfrm>
+      </p:grpSpPr>
+      <p:sp>
+        <p:nvSpPr>
+          <p:cNvPr id="2" name="Text 0"/>
+          <p:cNvSpPr/>
+          <p:nvPr>
+            <p:ph idx="100" type="title" hasCustomPrompt="1"/>
+          </p:nvPr>
+        </p:nvSpPr>
+        <p:spPr>
+          <a:xfrm>
             <a:off x="731520" y="2011680"/>
             <a:ext cx="10698480" cy="1280160"/>
           </a:xfrm>
@@ -2568,7 +3827,7 @@
                   <a:schemeClr val="tx2"/>
                 </a:solidFill>
               </a:rPr>
-              <a:t>Official MCP servers for GitHub, Notion and Linear in .mcp.json; Gmail through Google's Gmail MCP server</a:t>
+              <a:t>Official MCP servers for GitHub, Notion, Linear, Todoist and Jira in .mcp.json; Gmail through Google's Gmail MCP server</a:t>
             </a:r>
             <a:endParaRPr lang="en-US" sz="1500" dirty="0"/>
           </a:p>
@@ -3087,7 +4346,7 @@
                   <a:schemeClr val="tx2"/>
                 </a:solidFill>
               </a:rPr>
-              <a:t>A local Python dashboard reads dataExports/ and searches all four services at once</a:t>
+              <a:t>A local Python dashboard reads dataExports/ and searches all six services at once</a:t>
             </a:r>
             <a:endParaRPr lang="en-US" sz="1500" dirty="0"/>
           </a:p>
@@ -3195,7 +4454,7 @@
                   <a:schemeClr val="tx1"/>
                 </a:solidFill>
               </a:rPr>
-              <a:t>All four services connected through MCP</a:t>
+              <a:t>Every service connected through MCP</a:t>
             </a:r>
             <a:endParaRPr lang="en-US" sz="3600" dirty="0"/>
           </a:p>
@@ -3262,7 +4521,7 @@
                   <a:schemeClr val="tx1"/>
                 </a:solidFill>
               </a:rPr>
-              <a:t>GitHub, Notion, Linear</a:t>
+              <a:t>GitHub, Notion, Linear, Todoist, Jira</a:t>
             </a:r>
             <a:endParaRPr lang="en-US" sz="1500" dirty="0"/>
           </a:p>
@@ -3276,7 +4535,7 @@
                   <a:schemeClr val="tx2"/>
                 </a:solidFill>
               </a:rPr>
-              <a:t>Vendor-hosted official MCP servers, saved in .mcp.json. GitHub's token comes from an environment variable; Notion and Linear sign in with OAuth.</a:t>
+              <a:t>Vendor-hosted official MCP servers, saved in .mcp.json. GitHub's token comes from an environment variable; the others sign in with OAuth in the browser.</a:t>
             </a:r>
             <a:endParaRPr lang="en-US" sz="1500" dirty="0"/>
           </a:p>
@@ -4670,15 +5929,95 @@
                   <a:schemeClr val="tx1"/>
                 </a:solidFill>
               </a:rPr>
-              <a:t>One search across every service</a:t>
+              <a:t>Todoist: original vs dashboard</a:t>
             </a:r>
             <a:endParaRPr lang="en-US" sz="3600" dirty="0"/>
+          </a:p>
+        </p:txBody>
+      </p:sp>
+      <p:sp>
+        <p:nvSpPr>
+          <p:cNvPr id="3" name="label Original in Todoist"/>
+          <p:cNvSpPr txBox="1"/>
+          <p:nvPr/>
+        </p:nvSpPr>
+        <p:spPr>
+          <a:xfrm>
+            <a:off x="457200" y="1280160"/>
+            <a:ext cx="2377440" cy="329184"/>
+          </a:xfrm>
+          <a:prstGeom prst="roundRect">
+            <a:avLst>
+              <a:gd name="adj" fmla="val 22222"/>
+            </a:avLst>
+          </a:prstGeom>
+          <a:solidFill>
+            <a:srgbClr val="C2410C"/>
+          </a:solidFill>
+          <a:ln/>
+        </p:spPr>
+        <p:txBody>
+          <a:bodyPr wrap="square" lIns="0" tIns="0" rIns="0" bIns="0" rtlCol="0" anchor="ctr"/>
+          <a:lstStyle/>
+          <a:p>
+            <a:pPr algn="ctr" indent="0" marL="0">
+              <a:buNone/>
+            </a:pPr>
+            <a:r>
+              <a:rPr lang="en-US" sz="1200" b="1" dirty="0">
+                <a:solidFill>
+                  <a:srgbClr val="FFFFFF"/>
+                </a:solidFill>
+              </a:rPr>
+              <a:t>Original in Todoist</a:t>
+            </a:r>
+            <a:endParaRPr lang="en-US" sz="1200" dirty="0"/>
+          </a:p>
+        </p:txBody>
+      </p:sp>
+      <p:sp>
+        <p:nvSpPr>
+          <p:cNvPr id="4" name="label In the dashboard"/>
+          <p:cNvSpPr txBox="1"/>
+          <p:nvPr/>
+        </p:nvSpPr>
+        <p:spPr>
+          <a:xfrm>
+            <a:off x="7223760" y="1280160"/>
+            <a:ext cx="2377440" cy="329184"/>
+          </a:xfrm>
+          <a:prstGeom prst="roundRect">
+            <a:avLst>
+              <a:gd name="adj" fmla="val 22222"/>
+            </a:avLst>
+          </a:prstGeom>
+          <a:solidFill>
+            <a:schemeClr val="tx1"/>
+          </a:solidFill>
+          <a:ln/>
+        </p:spPr>
+        <p:txBody>
+          <a:bodyPr wrap="square" lIns="0" tIns="0" rIns="0" bIns="0" rtlCol="0" anchor="ctr"/>
+          <a:lstStyle/>
+          <a:p>
+            <a:pPr algn="ctr" indent="0" marL="0">
+              <a:buNone/>
+            </a:pPr>
+            <a:r>
+              <a:rPr lang="en-US" sz="1200" b="1" dirty="0">
+                <a:solidFill>
+                  <a:srgbClr val="FFFFFF"/>
+                </a:solidFill>
+              </a:rPr>
+              <a:t>In the dashboard</a:t>
+            </a:r>
+            <a:endParaRPr lang="en-US" sz="1200" dirty="0"/>
           </a:p>
         </p:txBody>
       </p:sp>
       <p:pic>
         <p:nvPicPr>
-          <p:cNvPr id="3" name="Dashboard search for joe smith returning results from all services" descr="Dashboard search for joe smith returning results from all services">    </p:cNvPr>
+          <p:cNvPr id="5" name="Original Todoist content" descr="Original Todoist content">    </p:cNvPr>
           <p:cNvPicPr>
             <a:picLocks noChangeAspect="1"/>
           </p:cNvPicPr>
@@ -4692,8 +6031,8 @@
         </p:blipFill>
         <p:spPr>
           <a:xfrm>
-            <a:off x="457200" y="1371600"/>
-            <a:ext cx="7863840" cy="4914900"/>
+            <a:off x="457200" y="1783080"/>
+            <a:ext cx="6400800" cy="3622675"/>
           </a:xfrm>
           <a:prstGeom prst="rect">
             <a:avLst/>
@@ -4707,222 +6046,37 @@
           </a:effectLst>
         </p:spPr>
       </p:pic>
-      <p:sp>
-        <p:nvSpPr>
-          <p:cNvPr id="4" name="stat results for “joe smith”"/>
-          <p:cNvSpPr txBox="1"/>
-          <p:nvPr/>
-        </p:nvSpPr>
-        <p:spPr>
-          <a:xfrm>
-            <a:off x="8778240" y="1463040"/>
-            <a:ext cx="2926080" cy="822960"/>
-          </a:xfrm>
-          <a:prstGeom prst="rect">
-            <a:avLst/>
-          </a:prstGeom>
-          <a:noFill/>
-          <a:ln/>
-        </p:spPr>
-        <p:txBody>
-          <a:bodyPr wrap="square" lIns="0" tIns="0" rIns="0" bIns="0" rtlCol="0" anchor="ctr"/>
-          <a:lstStyle/>
-          <a:p>
-            <a:pPr indent="0" marL="0">
-              <a:buNone/>
-            </a:pPr>
-            <a:r>
-              <a:rPr lang="en-US" sz="5400" b="1" dirty="0">
-                <a:solidFill>
-                  <a:schemeClr val="tx1"/>
-                </a:solidFill>
-              </a:rPr>
-              <a:t>19</a:t>
-            </a:r>
-            <a:endParaRPr lang="en-US" sz="5400" dirty="0"/>
-          </a:p>
-        </p:txBody>
-      </p:sp>
-      <p:sp>
-        <p:nvSpPr>
-          <p:cNvPr id="5" name="stat label results for “joe smith”"/>
-          <p:cNvSpPr txBox="1"/>
-          <p:nvPr/>
-        </p:nvSpPr>
-        <p:spPr>
-          <a:xfrm>
-            <a:off x="8778240" y="2286000"/>
-            <a:ext cx="2926080" cy="457200"/>
-          </a:xfrm>
-          <a:prstGeom prst="rect">
-            <a:avLst/>
-          </a:prstGeom>
-          <a:noFill/>
-          <a:ln/>
-        </p:spPr>
-        <p:txBody>
-          <a:bodyPr wrap="square" lIns="0" tIns="0" rIns="0" bIns="0" rtlCol="0" anchor="ctr"/>
-          <a:lstStyle/>
-          <a:p>
-            <a:pPr indent="0" marL="0">
-              <a:buNone/>
-            </a:pPr>
-            <a:r>
-              <a:rPr lang="en-US" sz="1500" dirty="0">
-                <a:solidFill>
-                  <a:schemeClr val="tx2"/>
-                </a:solidFill>
-              </a:rPr>
-              <a:t>results for “joe smith”</a:t>
-            </a:r>
-            <a:endParaRPr lang="en-US" sz="1500" dirty="0"/>
-          </a:p>
-        </p:txBody>
-      </p:sp>
-      <p:sp>
-        <p:nvSpPr>
-          <p:cNvPr id="6" name="stat services in one list"/>
-          <p:cNvSpPr txBox="1"/>
-          <p:nvPr/>
-        </p:nvSpPr>
-        <p:spPr>
-          <a:xfrm>
-            <a:off x="8778240" y="3063240"/>
-            <a:ext cx="2926080" cy="822960"/>
-          </a:xfrm>
-          <a:prstGeom prst="rect">
-            <a:avLst/>
-          </a:prstGeom>
-          <a:noFill/>
-          <a:ln/>
-        </p:spPr>
-        <p:txBody>
-          <a:bodyPr wrap="square" lIns="0" tIns="0" rIns="0" bIns="0" rtlCol="0" anchor="ctr"/>
-          <a:lstStyle/>
-          <a:p>
-            <a:pPr indent="0" marL="0">
-              <a:buNone/>
-            </a:pPr>
-            <a:r>
-              <a:rPr lang="en-US" sz="5400" b="1" dirty="0">
-                <a:solidFill>
-                  <a:schemeClr val="tx1"/>
-                </a:solidFill>
-              </a:rPr>
-              <a:t>4</a:t>
-            </a:r>
-            <a:endParaRPr lang="en-US" sz="5400" dirty="0"/>
-          </a:p>
-        </p:txBody>
-      </p:sp>
-      <p:sp>
-        <p:nvSpPr>
-          <p:cNvPr id="7" name="stat label services in one list"/>
-          <p:cNvSpPr txBox="1"/>
-          <p:nvPr/>
-        </p:nvSpPr>
-        <p:spPr>
-          <a:xfrm>
-            <a:off x="8778240" y="3886200"/>
-            <a:ext cx="2926080" cy="457200"/>
-          </a:xfrm>
-          <a:prstGeom prst="rect">
-            <a:avLst/>
-          </a:prstGeom>
-          <a:noFill/>
-          <a:ln/>
-        </p:spPr>
-        <p:txBody>
-          <a:bodyPr wrap="square" lIns="0" tIns="0" rIns="0" bIns="0" rtlCol="0" anchor="ctr"/>
-          <a:lstStyle/>
-          <a:p>
-            <a:pPr indent="0" marL="0">
-              <a:buNone/>
-            </a:pPr>
-            <a:r>
-              <a:rPr lang="en-US" sz="1500" dirty="0">
-                <a:solidFill>
-                  <a:schemeClr val="tx2"/>
-                </a:solidFill>
-              </a:rPr>
-              <a:t>services in one list</a:t>
-            </a:r>
-            <a:endParaRPr lang="en-US" sz="1500" dirty="0"/>
-          </a:p>
-        </p:txBody>
-      </p:sp>
-      <p:sp>
-        <p:nvSpPr>
-          <p:cNvPr id="8" name="stat items searchable offline"/>
-          <p:cNvSpPr txBox="1"/>
-          <p:nvPr/>
-        </p:nvSpPr>
-        <p:spPr>
-          <a:xfrm>
-            <a:off x="8778240" y="4663440"/>
-            <a:ext cx="2926080" cy="822960"/>
-          </a:xfrm>
-          <a:prstGeom prst="rect">
-            <a:avLst/>
-          </a:prstGeom>
-          <a:noFill/>
-          <a:ln/>
-        </p:spPr>
-        <p:txBody>
-          <a:bodyPr wrap="square" lIns="0" tIns="0" rIns="0" bIns="0" rtlCol="0" anchor="ctr"/>
-          <a:lstStyle/>
-          <a:p>
-            <a:pPr indent="0" marL="0">
-              <a:buNone/>
-            </a:pPr>
-            <a:r>
-              <a:rPr lang="en-US" sz="5400" b="1" dirty="0">
-                <a:solidFill>
-                  <a:schemeClr val="tx1"/>
-                </a:solidFill>
-              </a:rPr>
-              <a:t>69</a:t>
-            </a:r>
-            <a:endParaRPr lang="en-US" sz="5400" dirty="0"/>
-          </a:p>
-        </p:txBody>
-      </p:sp>
-      <p:sp>
-        <p:nvSpPr>
-          <p:cNvPr id="9" name="stat label items searchable offline"/>
-          <p:cNvSpPr txBox="1"/>
-          <p:nvPr/>
-        </p:nvSpPr>
-        <p:spPr>
-          <a:xfrm>
-            <a:off x="8778240" y="5486400"/>
-            <a:ext cx="2926080" cy="457200"/>
-          </a:xfrm>
-          <a:prstGeom prst="rect">
-            <a:avLst/>
-          </a:prstGeom>
-          <a:noFill/>
-          <a:ln/>
-        </p:spPr>
-        <p:txBody>
-          <a:bodyPr wrap="square" lIns="0" tIns="0" rIns="0" bIns="0" rtlCol="0" anchor="ctr"/>
-          <a:lstStyle/>
-          <a:p>
-            <a:pPr indent="0" marL="0">
-              <a:buNone/>
-            </a:pPr>
-            <a:r>
-              <a:rPr lang="en-US" sz="1500" dirty="0">
-                <a:solidFill>
-                  <a:schemeClr val="tx2"/>
-                </a:solidFill>
-              </a:rPr>
-              <a:t>items searchable offline</a:t>
-            </a:r>
-            <a:endParaRPr lang="en-US" sz="1500" dirty="0"/>
-          </a:p>
-        </p:txBody>
-      </p:sp>
+      <p:pic>
+        <p:nvPicPr>
+          <p:cNvPr id="6" name="Todoist item opened in the dashboard" descr="Todoist item opened in the dashboard">    </p:cNvPr>
+          <p:cNvPicPr>
+            <a:picLocks noChangeAspect="1"/>
+          </p:cNvPicPr>
+          <p:nvPr/>
+        </p:nvPicPr>
+        <p:blipFill>
+          <a:blip r:embed="rId2"/>
+          <a:stretch>
+            <a:fillRect/>
+          </a:stretch>
+        </p:blipFill>
+        <p:spPr>
+          <a:xfrm>
+            <a:off x="7223760" y="1783080"/>
+            <a:ext cx="4507992" cy="4297829"/>
+          </a:xfrm>
+          <a:prstGeom prst="rect">
+            <a:avLst/>
+          </a:prstGeom>
+          <a:effectLst>
+            <a:outerShdw sx="100000" sy="100000" kx="0" ky="0" algn="bl" rotWithShape="0" blurRad="101600" dist="25400" dir="5400000">
+              <a:srgbClr val="1B2433">
+                <a:alpha val="18000"/>
+              </a:srgbClr>
+            </a:outerShdw>
+          </a:effectLst>
+        </p:spPr>
+      </p:pic>
       <p:sp>
         <p:nvSpPr>
           <p:cNvPr id="25" name="Slide Number Placeholder 0"/>
@@ -5025,7 +6179,7 @@
                   <a:schemeClr val="tx1"/>
                 </a:solidFill>
               </a:rPr>
-              <a:t>A documented format and a reusable skill</a:t>
+              <a:t>Jira: original vs dashboard</a:t>
             </a:r>
             <a:endParaRPr lang="en-US" sz="3600" dirty="0"/>
           </a:p>
@@ -5033,310 +6187,14 @@
       </p:sp>
       <p:sp>
         <p:nvSpPr>
-          <p:cNvPr id="3" name="localStorageFormats.md card"/>
-          <p:cNvSpPr/>
-          <p:nvPr/>
-        </p:nvSpPr>
-        <p:spPr>
-          <a:xfrm>
-            <a:off x="457200" y="1463040"/>
-            <a:ext cx="5486400" cy="3657600"/>
-          </a:xfrm>
-          <a:prstGeom prst="roundRect">
-            <a:avLst>
-              <a:gd name="adj" fmla="val 3000"/>
-            </a:avLst>
-          </a:prstGeom>
-          <a:solidFill>
-            <a:schemeClr val="bg2"/>
-          </a:solidFill>
-          <a:ln w="12700">
-            <a:solidFill>
-              <a:schemeClr val="bg2"/>
-            </a:solidFill>
-            <a:prstDash val="solid"/>
-          </a:ln>
-        </p:spPr>
-      </p:sp>
-      <p:sp>
-        <p:nvSpPr>
-          <p:cNvPr id="4" name="localStorageFormats.md heading"/>
+          <p:cNvPr id="3" name="label Original in Jira"/>
           <p:cNvSpPr txBox="1"/>
           <p:nvPr/>
         </p:nvSpPr>
         <p:spPr>
           <a:xfrm>
-            <a:off x="777240" y="1691640"/>
-            <a:ext cx="4846320" cy="502920"/>
-          </a:xfrm>
-          <a:prstGeom prst="rect">
-            <a:avLst/>
-          </a:prstGeom>
-          <a:noFill/>
-          <a:ln/>
-        </p:spPr>
-        <p:txBody>
-          <a:bodyPr wrap="square" lIns="0" tIns="0" rIns="0" bIns="0" rtlCol="0" anchor="ctr"/>
-          <a:lstStyle/>
-          <a:p>
-            <a:pPr indent="0" marL="0">
-              <a:buNone/>
-            </a:pPr>
-            <a:r>
-              <a:rPr lang="en-US" sz="2000" b="1" dirty="0">
-                <a:solidFill>
-                  <a:schemeClr val="tx1"/>
-                </a:solidFill>
-              </a:rPr>
-              <a:t>localStorageFormats.md</a:t>
-            </a:r>
-            <a:endParaRPr lang="en-US" sz="2000" dirty="0"/>
-          </a:p>
-        </p:txBody>
-      </p:sp>
-      <p:sp>
-        <p:nvSpPr>
-          <p:cNvPr id="5" name="localStorageFormats.md list"/>
-          <p:cNvSpPr txBox="1"/>
-          <p:nvPr/>
-        </p:nvSpPr>
-        <p:spPr>
-          <a:xfrm>
-            <a:off x="777240" y="2331720"/>
-            <a:ext cx="4846320" cy="3108960"/>
-          </a:xfrm>
-          <a:prstGeom prst="rect">
-            <a:avLst/>
-          </a:prstGeom>
-          <a:noFill/>
-          <a:ln/>
-        </p:spPr>
-        <p:txBody>
-          <a:bodyPr wrap="square" lIns="0" tIns="0" rIns="0" bIns="0" rtlCol="0" anchor="t"/>
-          <a:lstStyle/>
-          <a:p>
-            <a:pPr marL="342900" indent="-342900">
-              <a:spcAft>
-                <a:spcPts val="800"/>
-              </a:spcAft>
-              <a:buSzPct val="100000"/>
-              <a:buChar char="•"/>
-            </a:pPr>
-            <a:r>
-              <a:rPr lang="en-US" sz="1500" dirty="0">
-                <a:solidFill>
-                  <a:schemeClr val="tx2"/>
-                </a:solidFill>
-              </a:rPr>
-              <a:t>One sub-folder per service in dataExports/</a:t>
-            </a:r>
-            <a:endParaRPr lang="en-US" sz="1500" dirty="0"/>
-          </a:p>
-          <a:p>
-            <a:pPr marL="342900" indent="-342900">
-              <a:spcAft>
-                <a:spcPts val="800"/>
-              </a:spcAft>
-              <a:buSzPct val="100000"/>
-              <a:buChar char="•"/>
-            </a:pPr>
-            <a:r>
-              <a:rPr lang="en-US" sz="1500" dirty="0">
-                <a:solidFill>
-                  <a:schemeClr val="tx2"/>
-                </a:solidFill>
-              </a:rPr>
-              <a:t>One JSON file per item: &lt;UTC time&gt;_&lt;short id&gt;.json</a:t>
-            </a:r>
-            <a:endParaRPr lang="en-US" sz="1500" dirty="0"/>
-          </a:p>
-          <a:p>
-            <a:pPr marL="342900" indent="-342900">
-              <a:spcAft>
-                <a:spcPts val="800"/>
-              </a:spcAft>
-              <a:buSzPct val="100000"/>
-              <a:buChar char="•"/>
-            </a:pPr>
-            <a:r>
-              <a:rPr lang="en-US" sz="1500" dirty="0">
-                <a:solidFill>
-                  <a:schemeClr val="tx2"/>
-                </a:solidFill>
-              </a:rPr>
-              <a:t>Shared fields: service, id, title, body, author, created, updated, url</a:t>
-            </a:r>
-            <a:endParaRPr lang="en-US" sz="1500" dirty="0"/>
-          </a:p>
-          <a:p>
-            <a:pPr marL="342900" indent="-342900">
-              <a:spcAft>
-                <a:spcPts val="800"/>
-              </a:spcAft>
-              <a:buSzPct val="100000"/>
-              <a:buChar char="•"/>
-            </a:pPr>
-            <a:r>
-              <a:rPr lang="en-US" sz="1500" dirty="0">
-                <a:solidFill>
-                  <a:schemeClr val="tx2"/>
-                </a:solidFill>
-              </a:rPr>
-              <a:t>Service-specific details in a metadata object (email from/to/labels, repo README, issue status/priority…)</a:t>
-            </a:r>
-            <a:endParaRPr lang="en-US" sz="1500" dirty="0"/>
-          </a:p>
-        </p:txBody>
-      </p:sp>
-      <p:sp>
-        <p:nvSpPr>
-          <p:cNvPr id="6" name=".claude/skills/export-service-data card"/>
-          <p:cNvSpPr/>
-          <p:nvPr/>
-        </p:nvSpPr>
-        <p:spPr>
-          <a:xfrm>
-            <a:off x="6172200" y="1463040"/>
-            <a:ext cx="5486400" cy="3657600"/>
-          </a:xfrm>
-          <a:prstGeom prst="roundRect">
-            <a:avLst>
-              <a:gd name="adj" fmla="val 3000"/>
-            </a:avLst>
-          </a:prstGeom>
-          <a:solidFill>
-            <a:schemeClr val="bg2"/>
-          </a:solidFill>
-          <a:ln w="12700">
-            <a:solidFill>
-              <a:schemeClr val="bg2"/>
-            </a:solidFill>
-            <a:prstDash val="solid"/>
-          </a:ln>
-        </p:spPr>
-      </p:sp>
-      <p:sp>
-        <p:nvSpPr>
-          <p:cNvPr id="7" name=".claude/skills/export-service-data heading"/>
-          <p:cNvSpPr txBox="1"/>
-          <p:nvPr/>
-        </p:nvSpPr>
-        <p:spPr>
-          <a:xfrm>
-            <a:off x="6492240" y="1691640"/>
-            <a:ext cx="4846320" cy="502920"/>
-          </a:xfrm>
-          <a:prstGeom prst="rect">
-            <a:avLst/>
-          </a:prstGeom>
-          <a:noFill/>
-          <a:ln/>
-        </p:spPr>
-        <p:txBody>
-          <a:bodyPr wrap="square" lIns="0" tIns="0" rIns="0" bIns="0" rtlCol="0" anchor="ctr"/>
-          <a:lstStyle/>
-          <a:p>
-            <a:pPr indent="0" marL="0">
-              <a:buNone/>
-            </a:pPr>
-            <a:r>
-              <a:rPr lang="en-US" sz="2000" b="1" dirty="0">
-                <a:solidFill>
-                  <a:schemeClr val="tx1"/>
-                </a:solidFill>
-              </a:rPr>
-              <a:t>.claude/skills/export-service-data</a:t>
-            </a:r>
-            <a:endParaRPr lang="en-US" sz="2000" dirty="0"/>
-          </a:p>
-        </p:txBody>
-      </p:sp>
-      <p:sp>
-        <p:nvSpPr>
-          <p:cNvPr id="8" name=".claude/skills/export-service-data list"/>
-          <p:cNvSpPr txBox="1"/>
-          <p:nvPr/>
-        </p:nvSpPr>
-        <p:spPr>
-          <a:xfrm>
-            <a:off x="6492240" y="2331720"/>
-            <a:ext cx="4846320" cy="3108960"/>
-          </a:xfrm>
-          <a:prstGeom prst="rect">
-            <a:avLst/>
-          </a:prstGeom>
-          <a:noFill/>
-          <a:ln/>
-        </p:spPr>
-        <p:txBody>
-          <a:bodyPr wrap="square" lIns="0" tIns="0" rIns="0" bIns="0" rtlCol="0" anchor="t"/>
-          <a:lstStyle/>
-          <a:p>
-            <a:pPr marL="342900" indent="-342900">
-              <a:spcAft>
-                <a:spcPts val="800"/>
-              </a:spcAft>
-              <a:buSzPct val="100000"/>
-              <a:buChar char="•"/>
-            </a:pPr>
-            <a:r>
-              <a:rPr lang="en-US" sz="1500" dirty="0">
-                <a:solidFill>
-                  <a:schemeClr val="tx2"/>
-                </a:solidFill>
-              </a:rPr>
-              <a:t>Tells Claude how to download from each service and store it exactly per the format doc</a:t>
-            </a:r>
-            <a:endParaRPr lang="en-US" sz="1500" dirty="0"/>
-          </a:p>
-          <a:p>
-            <a:pPr marL="342900" indent="-342900">
-              <a:spcAft>
-                <a:spcPts val="800"/>
-              </a:spcAft>
-              <a:buSzPct val="100000"/>
-              <a:buChar char="•"/>
-            </a:pPr>
-            <a:r>
-              <a:rPr lang="en-US" sz="1500" dirty="0">
-                <a:solidFill>
-                  <a:schemeClr val="tx2"/>
-                </a:solidFill>
-              </a:rPr>
-              <a:t>Skips items already on disk by comparing ids</a:t>
-            </a:r>
-            <a:endParaRPr lang="en-US" sz="1500" dirty="0"/>
-          </a:p>
-          <a:p>
-            <a:pPr marL="342900" indent="-342900">
-              <a:spcAft>
-                <a:spcPts val="800"/>
-              </a:spcAft>
-              <a:buSzPct val="100000"/>
-              <a:buChar char="•"/>
-            </a:pPr>
-            <a:r>
-              <a:rPr lang="en-US" sz="1500" dirty="0">
-                <a:solidFill>
-                  <a:schemeClr val="tx2"/>
-                </a:solidFill>
-              </a:rPr>
-              <a:t>Tested in a fresh conversation: skipped the 25 existing items and saved only new ones</a:t>
-            </a:r>
-            <a:endParaRPr lang="en-US" sz="1500" dirty="0"/>
-          </a:p>
-        </p:txBody>
-      </p:sp>
-      <p:sp>
-        <p:nvSpPr>
-          <p:cNvPr id="9" name="label Gmail: 24 items"/>
-          <p:cNvSpPr txBox="1"/>
-          <p:nvPr/>
-        </p:nvSpPr>
-        <p:spPr>
-          <a:xfrm>
-            <a:off x="457200" y="5440680"/>
-            <a:ext cx="2560320" cy="329184"/>
+            <a:off x="457200" y="1280160"/>
+            <a:ext cx="2377440" cy="329184"/>
           </a:xfrm>
           <a:prstGeom prst="roundRect">
             <a:avLst>
@@ -5344,7 +6202,7 @@
             </a:avLst>
           </a:prstGeom>
           <a:solidFill>
-            <a:srgbClr val="D93025"/>
+            <a:srgbClr val="0C66E4"/>
           </a:solidFill>
           <a:ln/>
         </p:spPr>
@@ -5361,7 +6219,7 @@
                   <a:srgbClr val="FFFFFF"/>
                 </a:solidFill>
               </a:rPr>
-              <a:t>Gmail: 24 items</a:t>
+              <a:t>Original in Jira</a:t>
             </a:r>
             <a:endParaRPr lang="en-US" sz="1200" dirty="0"/>
           </a:p>
@@ -5369,14 +6227,14 @@
       </p:sp>
       <p:sp>
         <p:nvSpPr>
-          <p:cNvPr id="10" name="label GitHub: 11 items"/>
+          <p:cNvPr id="4" name="label In the dashboard"/>
           <p:cNvSpPr txBox="1"/>
           <p:nvPr/>
         </p:nvSpPr>
         <p:spPr>
           <a:xfrm>
-            <a:off x="3291840" y="5440680"/>
-            <a:ext cx="2560320" cy="329184"/>
+            <a:off x="7223760" y="1280160"/>
+            <a:ext cx="2377440" cy="329184"/>
           </a:xfrm>
           <a:prstGeom prst="roundRect">
             <a:avLst>
@@ -5384,7 +6242,7 @@
             </a:avLst>
           </a:prstGeom>
           <a:solidFill>
-            <a:srgbClr val="24292F"/>
+            <a:schemeClr val="tx1"/>
           </a:solidFill>
           <a:ln/>
         </p:spPr>
@@ -5401,89 +6259,143 @@
                   <a:srgbClr val="FFFFFF"/>
                 </a:solidFill>
               </a:rPr>
-              <a:t>GitHub: 11 items</a:t>
+              <a:t>In the dashboard</a:t>
             </a:r>
             <a:endParaRPr lang="en-US" sz="1200" dirty="0"/>
           </a:p>
         </p:txBody>
       </p:sp>
-      <p:sp>
-        <p:nvSpPr>
-          <p:cNvPr id="11" name="label Notion: 20 items"/>
+      <p:pic>
+        <p:nvPicPr>
+          <p:cNvPr id="5" name="Original Jira content" descr="Original Jira content">    </p:cNvPr>
+          <p:cNvPicPr>
+            <a:picLocks noChangeAspect="1"/>
+          </p:cNvPicPr>
+          <p:nvPr/>
+        </p:nvPicPr>
+        <p:blipFill>
+          <a:blip r:embed="rId1"/>
+          <a:stretch>
+            <a:fillRect/>
+          </a:stretch>
+        </p:blipFill>
+        <p:spPr>
+          <a:xfrm>
+            <a:off x="457200" y="1783080"/>
+            <a:ext cx="6400800" cy="3600450"/>
+          </a:xfrm>
+          <a:prstGeom prst="rect">
+            <a:avLst/>
+          </a:prstGeom>
+          <a:effectLst>
+            <a:outerShdw sx="100000" sy="100000" kx="0" ky="0" algn="bl" rotWithShape="0" blurRad="101600" dist="25400" dir="5400000">
+              <a:srgbClr val="1B2433">
+                <a:alpha val="18000"/>
+              </a:srgbClr>
+            </a:outerShdw>
+          </a:effectLst>
+        </p:spPr>
+      </p:pic>
+      <p:pic>
+        <p:nvPicPr>
+          <p:cNvPr id="6" name="Jira item opened in the dashboard" descr="Jira item opened in the dashboard">    </p:cNvPr>
+          <p:cNvPicPr>
+            <a:picLocks noChangeAspect="1"/>
+          </p:cNvPicPr>
+          <p:nvPr/>
+        </p:nvPicPr>
+        <p:blipFill>
+          <a:blip r:embed="rId2"/>
+          <a:stretch>
+            <a:fillRect/>
+          </a:stretch>
+        </p:blipFill>
+        <p:spPr>
+          <a:xfrm>
+            <a:off x="7223760" y="1783080"/>
+            <a:ext cx="4507992" cy="4122783"/>
+          </a:xfrm>
+          <a:prstGeom prst="rect">
+            <a:avLst/>
+          </a:prstGeom>
+          <a:effectLst>
+            <a:outerShdw sx="100000" sy="100000" kx="0" ky="0" algn="bl" rotWithShape="0" blurRad="101600" dist="25400" dir="5400000">
+              <a:srgbClr val="1B2433">
+                <a:alpha val="18000"/>
+              </a:srgbClr>
+            </a:outerShdw>
+          </a:effectLst>
+        </p:spPr>
+      </p:pic>
+      <p:sp>
+        <p:nvSpPr>
+          <p:cNvPr id="7" name="Jira caption"/>
           <p:cNvSpPr txBox="1"/>
           <p:nvPr/>
         </p:nvSpPr>
         <p:spPr>
           <a:xfrm>
-            <a:off x="6126480" y="5440680"/>
-            <a:ext cx="2560320" cy="329184"/>
-          </a:xfrm>
-          <a:prstGeom prst="roundRect">
-            <a:avLst>
-              <a:gd name="adj" fmla="val 22222"/>
-            </a:avLst>
-          </a:prstGeom>
-          <a:solidFill>
-            <a:srgbClr val="7A6A55"/>
-          </a:solidFill>
-          <a:ln/>
-        </p:spPr>
-        <p:txBody>
-          <a:bodyPr wrap="square" lIns="0" tIns="0" rIns="0" bIns="0" rtlCol="0" anchor="ctr"/>
-          <a:lstStyle/>
-          <a:p>
-            <a:pPr algn="ctr" indent="0" marL="0">
-              <a:buNone/>
-            </a:pPr>
-            <a:r>
-              <a:rPr lang="en-US" sz="1200" b="1" dirty="0">
-                <a:solidFill>
-                  <a:srgbClr val="FFFFFF"/>
-                </a:solidFill>
-              </a:rPr>
-              <a:t>Notion: 20 items</a:t>
-            </a:r>
-            <a:endParaRPr lang="en-US" sz="1200" dirty="0"/>
-          </a:p>
-        </p:txBody>
-      </p:sp>
-      <p:sp>
-        <p:nvSpPr>
-          <p:cNvPr id="12" name="label Linear: 14 items"/>
-          <p:cNvSpPr txBox="1"/>
-          <p:nvPr/>
-        </p:nvSpPr>
-        <p:spPr>
-          <a:xfrm>
-            <a:off x="8961120" y="5440680"/>
-            <a:ext cx="2560320" cy="329184"/>
-          </a:xfrm>
-          <a:prstGeom prst="roundRect">
-            <a:avLst>
-              <a:gd name="adj" fmla="val 22222"/>
-            </a:avLst>
-          </a:prstGeom>
-          <a:solidFill>
-            <a:srgbClr val="5E6AD2"/>
-          </a:solidFill>
-          <a:ln/>
-        </p:spPr>
-        <p:txBody>
-          <a:bodyPr wrap="square" lIns="0" tIns="0" rIns="0" bIns="0" rtlCol="0" anchor="ctr"/>
-          <a:lstStyle/>
-          <a:p>
-            <a:pPr algn="ctr" indent="0" marL="0">
-              <a:buNone/>
-            </a:pPr>
-            <a:r>
-              <a:rPr lang="en-US" sz="1200" b="1" dirty="0">
-                <a:solidFill>
-                  <a:srgbClr val="FFFFFF"/>
-                </a:solidFill>
-              </a:rPr>
-              <a:t>Linear: 14 items</a:t>
-            </a:r>
-            <a:endParaRPr lang="en-US" sz="1200" dirty="0"/>
+            <a:off x="457200" y="5657850"/>
+            <a:ext cx="6400800" cy="697230"/>
+          </a:xfrm>
+          <a:prstGeom prst="rect">
+            <a:avLst/>
+          </a:prstGeom>
+          <a:noFill/>
+          <a:ln/>
+        </p:spPr>
+        <p:txBody>
+          <a:bodyPr wrap="square" lIns="0" tIns="0" rIns="0" bIns="0" rtlCol="0" anchor="t"/>
+          <a:lstStyle/>
+          <a:p>
+            <a:pPr indent="0" marL="0">
+              <a:buNone/>
+            </a:pPr>
+            <a:r>
+              <a:rPr lang="en-US" sz="1300" b="1" dirty="0">
+                <a:solidFill>
+                  <a:schemeClr val="tx1"/>
+                </a:solidFill>
+              </a:rPr>
+              <a:t>Item: </a:t>
+            </a:r>
+            <a:pPr indent="0" marL="0">
+              <a:buNone/>
+            </a:pPr>
+            <a:r>
+              <a:rPr lang="en-US" sz="1300" dirty="0">
+                <a:solidFill>
+                  <a:schemeClr val="tx2"/>
+                </a:solidFill>
+              </a:rPr>
+              <a:t>Issue KAN-8 “ETA prediction model v1 for Project Atlas”</a:t>
+            </a:r>
+            <a:endParaRPr lang="en-US" sz="1300" dirty="0"/>
+          </a:p>
+          <a:p>
+            <a:pPr indent="0" marL="0">
+              <a:buNone/>
+            </a:pPr>
+            <a:r>
+              <a:rPr lang="en-US" sz="1300" b="1" dirty="0">
+                <a:solidFill>
+                  <a:schemeClr val="tx1"/>
+                </a:solidFill>
+              </a:rPr>
+              <a:t>Saved as: </a:t>
+            </a:r>
+            <a:pPr indent="0" marL="0">
+              <a:buNone/>
+            </a:pPr>
+            <a:r>
+              <a:rPr lang="en-US" sz="1300" dirty="0">
+                <a:solidFill>
+                  <a:schemeClr val="tx2"/>
+                </a:solidFill>
+              </a:rPr>
+              <a:t>dataExports/jira/2026-10-20_21-21-17_KAN-8.json</a:t>
+            </a:r>
+            <a:endParaRPr lang="en-US" sz="1300" dirty="0"/>
           </a:p>
         </p:txBody>
       </p:sp>

</xml_diff>

<commit_message>
Add team section, team slide and 6-service updates
</commit_message>
<xml_diff>
--- a/Homework3_Presentation.pptx
+++ b/Homework3_Presentation.pptx
@@ -17,9 +17,10 @@
     <p:sldId id="265" r:id="rId11"/>
     <p:sldId id="266" r:id="rId12"/>
     <p:sldId id="267" r:id="rId13"/>
+    <p:sldId id="268" r:id="rId14"/>
   </p:sldIdLst>
   <p:notesMasterIdLst>
-    <p:notesMasterId r:id="rId14"/>
+    <p:notesMasterId r:id="rId15"/>
   </p:notesMasterIdLst>
   <p:sldSz cx="12192000" cy="6858000"/>
   <p:notesSz cx="6858000" cy="12192000"/>
@@ -118,36 +119,37 @@
   <p:extLst>
     <p:ext uri="{521415D9-36F7-43E2-AB2F-B90AF26B5E84}">
       <p14:sectionLst xmlns:p14="http://schemas.microsoft.com/office/powerpoint/2010/main">
-        <p14:section name="Introduction" id="{251908e4-bf33-6eac-ab4c-bad627d3eaf3}">
+        <p14:section name="Introduction" id="{50b1a9a4-d922-d4db-b55d-a4ed8cb44d70}">
           <p14:sldIdLst>
             <p14:sldId id="256"/>
             <p14:sldId id="257"/>
-          </p14:sldIdLst>
-        </p14:section>
-        <p14:section name="Connections" id="{7e853a16-54d2-5edf-5b20-75f55ff2f346}">
-          <p14:sldIdLst>
             <p14:sldId id="258"/>
           </p14:sldIdLst>
         </p14:section>
-        <p14:section name="Original vs dashboard" id="{6064c56f-a05c-4f18-0809-980c8a67a907}">
+        <p14:section name="Connections" id="{0570c131-1662-7e2f-2164-35e7b5ac5a23}">
           <p14:sldIdLst>
             <p14:sldId id="259"/>
+          </p14:sldIdLst>
+        </p14:section>
+        <p14:section name="Original vs dashboard" id="{d3d1325c-7c44-605b-2e23-92be9f86f35b}">
+          <p14:sldIdLst>
             <p14:sldId id="260"/>
             <p14:sldId id="261"/>
             <p14:sldId id="262"/>
             <p14:sldId id="263"/>
             <p14:sldId id="264"/>
+            <p14:sldId id="265"/>
           </p14:sldIdLst>
         </p14:section>
-        <p14:section name="Dashboard" id="{4d9fec0d-629c-5f1d-47d1-01ecf361197d}">
+        <p14:section name="Dashboard" id="{b321d368-fc82-16aa-c534-b759f397d4e1}">
           <p14:sldIdLst>
-            <p14:sldId id="265"/>
             <p14:sldId id="266"/>
+            <p14:sldId id="267"/>
           </p14:sldIdLst>
         </p14:section>
-        <p14:section name="Summary" id="{7a6670a9-c633-6976-9860-c975423f79cd}">
+        <p14:section name="Summary" id="{e9783b14-e356-0ca8-f1ae-9e9201579723}">
           <p14:sldIdLst>
-            <p14:sldId id="267"/>
+            <p14:sldId id="268"/>
           </p14:sldIdLst>
         </p14:section>
       </p14:sectionLst>
@@ -642,7 +644,7 @@
           <a:p>
             <a:r>
               <a:rPr lang="en-US" dirty="0"/>
-              <a:t/>
+              <a:t>Left: the Jira test item in the real service. Right: the same item read from the local JSON export in the dashboard.</a:t>
             </a:r>
             <a:endParaRPr lang="en-US" dirty="0"/>
           </a:p>
@@ -860,6 +862,94 @@
 </p:notes>
 </file>
 
+<file path=ppt/notesSlides/notesSlide13.xml><?xml version="1.0" encoding="utf-8"?>
+<p:notes xmlns:a="http://schemas.openxmlformats.org/drawingml/2006/main" xmlns:r="http://schemas.openxmlformats.org/officeDocument/2006/relationships" xmlns:p="http://schemas.openxmlformats.org/presentationml/2006/main">
+  <p:cSld>
+    <p:spTree>
+      <p:nvGrpSpPr>
+        <p:cNvPr id="1" name=""/>
+        <p:cNvGrpSpPr/>
+        <p:nvPr/>
+      </p:nvGrpSpPr>
+      <p:grpSpPr>
+        <a:xfrm>
+          <a:off x="0" y="0"/>
+          <a:ext cx="0" cy="0"/>
+          <a:chOff x="0" y="0"/>
+          <a:chExt cx="0" cy="0"/>
+        </a:xfrm>
+      </p:grpSpPr>
+      <p:sp>
+        <p:nvSpPr>
+          <p:cNvPr id="2" name="Slide Image Placeholder 1"/>
+          <p:cNvSpPr>
+            <a:spLocks noGrp="1" noRot="1" noChangeAspect="1"/>
+          </p:cNvSpPr>
+          <p:nvPr>
+            <p:ph type="sldImg"/>
+          </p:nvPr>
+        </p:nvSpPr>
+        <p:spPr/>
+      </p:sp>
+      <p:sp>
+        <p:nvSpPr>
+          <p:cNvPr id="3" name="Notes Placeholder 2"/>
+          <p:cNvSpPr>
+            <a:spLocks noGrp="1"/>
+          </p:cNvSpPr>
+          <p:nvPr>
+            <p:ph type="body" idx="1"/>
+          </p:nvPr>
+        </p:nvSpPr>
+        <p:spPr/>
+        <p:txBody>
+          <a:bodyPr/>
+          <a:lstStyle/>
+          <a:p>
+            <a:r>
+              <a:rPr lang="en-US" dirty="0"/>
+              <a:t/>
+            </a:r>
+            <a:endParaRPr lang="en-US" dirty="0"/>
+          </a:p>
+        </p:txBody>
+      </p:sp>
+      <p:sp>
+        <p:nvSpPr>
+          <p:cNvPr id="4" name="Slide Number Placeholder 3"/>
+          <p:cNvSpPr>
+            <a:spLocks noGrp="1"/>
+          </p:cNvSpPr>
+          <p:nvPr>
+            <p:ph type="sldNum" sz="quarter" idx="10"/>
+          </p:nvPr>
+        </p:nvSpPr>
+        <p:spPr/>
+        <p:txBody>
+          <a:bodyPr/>
+          <a:lstStyle/>
+          <a:p>
+            <a:fld id="{F7021451-1387-4CA6-816F-3879F97B5CBC}" type="slidenum">
+              <a:rPr lang="en-US"/>
+              <a:t>13</a:t>
+            </a:fld>
+            <a:endParaRPr lang="en-US"/>
+          </a:p>
+        </p:txBody>
+      </p:sp>
+    </p:spTree>
+    <p:extLst>
+      <p:ext uri="{BB962C8B-B14F-4D97-AF65-F5344CB8AC3E}">
+        <p14:creationId xmlns:p14="http://schemas.microsoft.com/office/powerpoint/2010/main" val="1024086991"/>
+      </p:ext>
+    </p:extLst>
+  </p:cSld>
+  <p:clrMapOvr>
+    <a:masterClrMapping/>
+  </p:clrMapOvr>
+</p:notes>
+</file>
+
 <file path=ppt/notesSlides/notesSlide2.xml><?xml version="1.0" encoding="utf-8"?>
 <p:notes xmlns:a="http://schemas.openxmlformats.org/drawingml/2006/main" xmlns:r="http://schemas.openxmlformats.org/officeDocument/2006/relationships" xmlns:p="http://schemas.openxmlformats.org/presentationml/2006/main">
   <p:cSld>
@@ -1082,7 +1172,7 @@
           <a:p>
             <a:r>
               <a:rPr lang="en-US" dirty="0"/>
-              <a:t>Left: the Gmail test item in the real service. Right: the same item read from the local JSON export in the dashboard.</a:t>
+              <a:t/>
             </a:r>
             <a:endParaRPr lang="en-US" dirty="0"/>
           </a:p>
@@ -1170,7 +1260,7 @@
           <a:p>
             <a:r>
               <a:rPr lang="en-US" dirty="0"/>
-              <a:t>Left: the GitHub test item in the real service. Right: the same item read from the local JSON export in the dashboard.</a:t>
+              <a:t>Left: the Gmail test item in the real service. Right: the same item read from the local JSON export in the dashboard.</a:t>
             </a:r>
             <a:endParaRPr lang="en-US" dirty="0"/>
           </a:p>
@@ -1258,7 +1348,7 @@
           <a:p>
             <a:r>
               <a:rPr lang="en-US" dirty="0"/>
-              <a:t>Left: the Notion test item in the real service. Right: the same item read from the local JSON export in the dashboard.</a:t>
+              <a:t>Left: the GitHub test item in the real service. Right: the same item read from the local JSON export in the dashboard.</a:t>
             </a:r>
             <a:endParaRPr lang="en-US" dirty="0"/>
           </a:p>
@@ -1346,7 +1436,7 @@
           <a:p>
             <a:r>
               <a:rPr lang="en-US" dirty="0"/>
-              <a:t>Left: the Linear test item in the real service. Right: the same item read from the local JSON export in the dashboard.</a:t>
+              <a:t>Left: the Notion test item in the real service. Right: the same item read from the local JSON export in the dashboard.</a:t>
             </a:r>
             <a:endParaRPr lang="en-US" dirty="0"/>
           </a:p>
@@ -1434,7 +1524,7 @@
           <a:p>
             <a:r>
               <a:rPr lang="en-US" dirty="0"/>
-              <a:t>Left: the Todoist test item in the real service. Right: the same item read from the local JSON export in the dashboard.</a:t>
+              <a:t>Left: the Linear test item in the real service. Right: the same item read from the local JSON export in the dashboard.</a:t>
             </a:r>
             <a:endParaRPr lang="en-US" dirty="0"/>
           </a:p>
@@ -1522,7 +1612,7 @@
           <a:p>
             <a:r>
               <a:rPr lang="en-US" dirty="0"/>
-              <a:t>Left: the Jira test item in the real service. Right: the same item read from the local JSON export in the dashboard.</a:t>
+              <a:t>Left: the Todoist test item in the real service. Right: the same item read from the local JSON export in the dashboard.</a:t>
             </a:r>
             <a:endParaRPr lang="en-US" dirty="0"/>
           </a:p>
@@ -2245,7 +2335,7 @@
                   <a:schemeClr val="accent1"/>
                 </a:solidFill>
               </a:rPr>
-              <a:t>Abraham Gabay · AI Homework 3</a:t>
+              <a:t>Abraham Gabay · Joel Aserraf · Marco Foununu · AI Homework 3</a:t>
             </a:r>
             <a:endParaRPr lang="en-US" sz="2000" dirty="0"/>
           </a:p>
@@ -2562,15 +2652,95 @@
                   <a:schemeClr val="tx1"/>
                 </a:solidFill>
               </a:rPr>
-              <a:t>One search across every service</a:t>
+              <a:t>Jira: original vs dashboard</a:t>
             </a:r>
             <a:endParaRPr lang="en-US" sz="3600" dirty="0"/>
+          </a:p>
+        </p:txBody>
+      </p:sp>
+      <p:sp>
+        <p:nvSpPr>
+          <p:cNvPr id="3" name="label Original in Jira"/>
+          <p:cNvSpPr txBox="1"/>
+          <p:nvPr/>
+        </p:nvSpPr>
+        <p:spPr>
+          <a:xfrm>
+            <a:off x="457200" y="1280160"/>
+            <a:ext cx="2377440" cy="329184"/>
+          </a:xfrm>
+          <a:prstGeom prst="roundRect">
+            <a:avLst>
+              <a:gd name="adj" fmla="val 22222"/>
+            </a:avLst>
+          </a:prstGeom>
+          <a:solidFill>
+            <a:srgbClr val="0C66E4"/>
+          </a:solidFill>
+          <a:ln/>
+        </p:spPr>
+        <p:txBody>
+          <a:bodyPr wrap="square" lIns="0" tIns="0" rIns="0" bIns="0" rtlCol="0" anchor="ctr"/>
+          <a:lstStyle/>
+          <a:p>
+            <a:pPr algn="ctr" indent="0" marL="0">
+              <a:buNone/>
+            </a:pPr>
+            <a:r>
+              <a:rPr lang="en-US" sz="1200" b="1" dirty="0">
+                <a:solidFill>
+                  <a:srgbClr val="FFFFFF"/>
+                </a:solidFill>
+              </a:rPr>
+              <a:t>Original in Jira</a:t>
+            </a:r>
+            <a:endParaRPr lang="en-US" sz="1200" dirty="0"/>
+          </a:p>
+        </p:txBody>
+      </p:sp>
+      <p:sp>
+        <p:nvSpPr>
+          <p:cNvPr id="4" name="label In the dashboard"/>
+          <p:cNvSpPr txBox="1"/>
+          <p:nvPr/>
+        </p:nvSpPr>
+        <p:spPr>
+          <a:xfrm>
+            <a:off x="7223760" y="1280160"/>
+            <a:ext cx="2377440" cy="329184"/>
+          </a:xfrm>
+          <a:prstGeom prst="roundRect">
+            <a:avLst>
+              <a:gd name="adj" fmla="val 22222"/>
+            </a:avLst>
+          </a:prstGeom>
+          <a:solidFill>
+            <a:schemeClr val="tx1"/>
+          </a:solidFill>
+          <a:ln/>
+        </p:spPr>
+        <p:txBody>
+          <a:bodyPr wrap="square" lIns="0" tIns="0" rIns="0" bIns="0" rtlCol="0" anchor="ctr"/>
+          <a:lstStyle/>
+          <a:p>
+            <a:pPr algn="ctr" indent="0" marL="0">
+              <a:buNone/>
+            </a:pPr>
+            <a:r>
+              <a:rPr lang="en-US" sz="1200" b="1" dirty="0">
+                <a:solidFill>
+                  <a:srgbClr val="FFFFFF"/>
+                </a:solidFill>
+              </a:rPr>
+              <a:t>In the dashboard</a:t>
+            </a:r>
+            <a:endParaRPr lang="en-US" sz="1200" dirty="0"/>
           </a:p>
         </p:txBody>
       </p:sp>
       <p:pic>
         <p:nvPicPr>
-          <p:cNvPr id="3" name="Dashboard search for joe smith returning results from all services" descr="Dashboard search for joe smith returning results from all services">    </p:cNvPr>
+          <p:cNvPr id="5" name="Original Jira content" descr="Original Jira content">    </p:cNvPr>
           <p:cNvPicPr>
             <a:picLocks noChangeAspect="1"/>
           </p:cNvPicPr>
@@ -2584,8 +2754,8 @@
         </p:blipFill>
         <p:spPr>
           <a:xfrm>
-            <a:off x="457200" y="1371600"/>
-            <a:ext cx="7863840" cy="4914900"/>
+            <a:off x="457200" y="1783080"/>
+            <a:ext cx="6400800" cy="3600450"/>
           </a:xfrm>
           <a:prstGeom prst="rect">
             <a:avLst/>
@@ -2599,16 +2769,47 @@
           </a:effectLst>
         </p:spPr>
       </p:pic>
-      <p:sp>
-        <p:nvSpPr>
-          <p:cNvPr id="4" name="stat results for “joe smith”"/>
+      <p:pic>
+        <p:nvPicPr>
+          <p:cNvPr id="6" name="Jira item opened in the dashboard" descr="Jira item opened in the dashboard">    </p:cNvPr>
+          <p:cNvPicPr>
+            <a:picLocks noChangeAspect="1"/>
+          </p:cNvPicPr>
+          <p:nvPr/>
+        </p:nvPicPr>
+        <p:blipFill>
+          <a:blip r:embed="rId2"/>
+          <a:stretch>
+            <a:fillRect/>
+          </a:stretch>
+        </p:blipFill>
+        <p:spPr>
+          <a:xfrm>
+            <a:off x="7223760" y="1783080"/>
+            <a:ext cx="4507992" cy="4122783"/>
+          </a:xfrm>
+          <a:prstGeom prst="rect">
+            <a:avLst/>
+          </a:prstGeom>
+          <a:effectLst>
+            <a:outerShdw sx="100000" sy="100000" kx="0" ky="0" algn="bl" rotWithShape="0" blurRad="101600" dist="25400" dir="5400000">
+              <a:srgbClr val="1B2433">
+                <a:alpha val="18000"/>
+              </a:srgbClr>
+            </a:outerShdw>
+          </a:effectLst>
+        </p:spPr>
+      </p:pic>
+      <p:sp>
+        <p:nvSpPr>
+          <p:cNvPr id="7" name="Jira caption"/>
           <p:cNvSpPr txBox="1"/>
           <p:nvPr/>
         </p:nvSpPr>
         <p:spPr>
           <a:xfrm>
-            <a:off x="8778240" y="1463040"/>
-            <a:ext cx="2926080" cy="822960"/>
+            <a:off x="457200" y="5657850"/>
+            <a:ext cx="6400800" cy="697230"/>
           </a:xfrm>
           <a:prstGeom prst="rect">
             <a:avLst/>
@@ -2617,201 +2818,57 @@
           <a:ln/>
         </p:spPr>
         <p:txBody>
-          <a:bodyPr wrap="square" lIns="0" tIns="0" rIns="0" bIns="0" rtlCol="0" anchor="ctr"/>
+          <a:bodyPr wrap="square" lIns="0" tIns="0" rIns="0" bIns="0" rtlCol="0" anchor="t"/>
           <a:lstStyle/>
           <a:p>
             <a:pPr indent="0" marL="0">
               <a:buNone/>
             </a:pPr>
             <a:r>
-              <a:rPr lang="en-US" sz="5400" b="1" dirty="0">
+              <a:rPr lang="en-US" sz="1300" b="1" dirty="0">
                 <a:solidFill>
                   <a:schemeClr val="tx1"/>
                 </a:solidFill>
               </a:rPr>
-              <a:t>19</a:t>
-            </a:r>
-            <a:endParaRPr lang="en-US" sz="5400" dirty="0"/>
-          </a:p>
-        </p:txBody>
-      </p:sp>
-      <p:sp>
-        <p:nvSpPr>
-          <p:cNvPr id="5" name="stat label results for “joe smith”"/>
-          <p:cNvSpPr txBox="1"/>
-          <p:nvPr/>
-        </p:nvSpPr>
-        <p:spPr>
-          <a:xfrm>
-            <a:off x="8778240" y="2286000"/>
-            <a:ext cx="2926080" cy="457200"/>
-          </a:xfrm>
-          <a:prstGeom prst="rect">
-            <a:avLst/>
-          </a:prstGeom>
-          <a:noFill/>
-          <a:ln/>
-        </p:spPr>
-        <p:txBody>
-          <a:bodyPr wrap="square" lIns="0" tIns="0" rIns="0" bIns="0" rtlCol="0" anchor="ctr"/>
-          <a:lstStyle/>
-          <a:p>
+              <a:t>Item: </a:t>
+            </a:r>
             <a:pPr indent="0" marL="0">
               <a:buNone/>
             </a:pPr>
             <a:r>
-              <a:rPr lang="en-US" sz="1500" dirty="0">
+              <a:rPr lang="en-US" sz="1300" dirty="0">
                 <a:solidFill>
                   <a:schemeClr val="tx2"/>
                 </a:solidFill>
               </a:rPr>
-              <a:t>results for “joe smith”</a:t>
-            </a:r>
-            <a:endParaRPr lang="en-US" sz="1500" dirty="0"/>
-          </a:p>
-        </p:txBody>
-      </p:sp>
-      <p:sp>
-        <p:nvSpPr>
-          <p:cNvPr id="6" name="stat services in one list"/>
-          <p:cNvSpPr txBox="1"/>
-          <p:nvPr/>
-        </p:nvSpPr>
-        <p:spPr>
-          <a:xfrm>
-            <a:off x="8778240" y="3063240"/>
-            <a:ext cx="2926080" cy="822960"/>
-          </a:xfrm>
-          <a:prstGeom prst="rect">
-            <a:avLst/>
-          </a:prstGeom>
-          <a:noFill/>
-          <a:ln/>
-        </p:spPr>
-        <p:txBody>
-          <a:bodyPr wrap="square" lIns="0" tIns="0" rIns="0" bIns="0" rtlCol="0" anchor="ctr"/>
-          <a:lstStyle/>
+              <a:t>Issue KAN-8 “ETA prediction model v1 for Project Atlas”</a:t>
+            </a:r>
+            <a:endParaRPr lang="en-US" sz="1300" dirty="0"/>
+          </a:p>
           <a:p>
             <a:pPr indent="0" marL="0">
               <a:buNone/>
             </a:pPr>
             <a:r>
-              <a:rPr lang="en-US" sz="5400" b="1" dirty="0">
+              <a:rPr lang="en-US" sz="1300" b="1" dirty="0">
                 <a:solidFill>
                   <a:schemeClr val="tx1"/>
                 </a:solidFill>
               </a:rPr>
-              <a:t>4</a:t>
-            </a:r>
-            <a:endParaRPr lang="en-US" sz="5400" dirty="0"/>
-          </a:p>
-        </p:txBody>
-      </p:sp>
-      <p:sp>
-        <p:nvSpPr>
-          <p:cNvPr id="7" name="stat label services in one list"/>
-          <p:cNvSpPr txBox="1"/>
-          <p:nvPr/>
-        </p:nvSpPr>
-        <p:spPr>
-          <a:xfrm>
-            <a:off x="8778240" y="3886200"/>
-            <a:ext cx="2926080" cy="457200"/>
-          </a:xfrm>
-          <a:prstGeom prst="rect">
-            <a:avLst/>
-          </a:prstGeom>
-          <a:noFill/>
-          <a:ln/>
-        </p:spPr>
-        <p:txBody>
-          <a:bodyPr wrap="square" lIns="0" tIns="0" rIns="0" bIns="0" rtlCol="0" anchor="ctr"/>
-          <a:lstStyle/>
-          <a:p>
+              <a:t>Saved as: </a:t>
+            </a:r>
             <a:pPr indent="0" marL="0">
               <a:buNone/>
             </a:pPr>
             <a:r>
-              <a:rPr lang="en-US" sz="1500" dirty="0">
+              <a:rPr lang="en-US" sz="1300" dirty="0">
                 <a:solidFill>
                   <a:schemeClr val="tx2"/>
                 </a:solidFill>
               </a:rPr>
-              <a:t>services in one list</a:t>
-            </a:r>
-            <a:endParaRPr lang="en-US" sz="1500" dirty="0"/>
-          </a:p>
-        </p:txBody>
-      </p:sp>
-      <p:sp>
-        <p:nvSpPr>
-          <p:cNvPr id="8" name="stat items searchable offline"/>
-          <p:cNvSpPr txBox="1"/>
-          <p:nvPr/>
-        </p:nvSpPr>
-        <p:spPr>
-          <a:xfrm>
-            <a:off x="8778240" y="4663440"/>
-            <a:ext cx="2926080" cy="822960"/>
-          </a:xfrm>
-          <a:prstGeom prst="rect">
-            <a:avLst/>
-          </a:prstGeom>
-          <a:noFill/>
-          <a:ln/>
-        </p:spPr>
-        <p:txBody>
-          <a:bodyPr wrap="square" lIns="0" tIns="0" rIns="0" bIns="0" rtlCol="0" anchor="ctr"/>
-          <a:lstStyle/>
-          <a:p>
-            <a:pPr indent="0" marL="0">
-              <a:buNone/>
-            </a:pPr>
-            <a:r>
-              <a:rPr lang="en-US" sz="5400" b="1" dirty="0">
-                <a:solidFill>
-                  <a:schemeClr val="tx1"/>
-                </a:solidFill>
-              </a:rPr>
-              <a:t>102</a:t>
-            </a:r>
-            <a:endParaRPr lang="en-US" sz="5400" dirty="0"/>
-          </a:p>
-        </p:txBody>
-      </p:sp>
-      <p:sp>
-        <p:nvSpPr>
-          <p:cNvPr id="9" name="stat label items searchable offline"/>
-          <p:cNvSpPr txBox="1"/>
-          <p:nvPr/>
-        </p:nvSpPr>
-        <p:spPr>
-          <a:xfrm>
-            <a:off x="8778240" y="5486400"/>
-            <a:ext cx="2926080" cy="457200"/>
-          </a:xfrm>
-          <a:prstGeom prst="rect">
-            <a:avLst/>
-          </a:prstGeom>
-          <a:noFill/>
-          <a:ln/>
-        </p:spPr>
-        <p:txBody>
-          <a:bodyPr wrap="square" lIns="0" tIns="0" rIns="0" bIns="0" rtlCol="0" anchor="ctr"/>
-          <a:lstStyle/>
-          <a:p>
-            <a:pPr indent="0" marL="0">
-              <a:buNone/>
-            </a:pPr>
-            <a:r>
-              <a:rPr lang="en-US" sz="1500" dirty="0">
-                <a:solidFill>
-                  <a:schemeClr val="tx2"/>
-                </a:solidFill>
-              </a:rPr>
-              <a:t>items searchable offline</a:t>
-            </a:r>
-            <a:endParaRPr lang="en-US" sz="1500" dirty="0"/>
+              <a:t>dataExports/jira/2026-10-20_21-21-17_KAN-8.json</a:t>
+            </a:r>
+            <a:endParaRPr lang="en-US" sz="1300" dirty="0"/>
           </a:p>
         </p:txBody>
       </p:sp>
@@ -2917,49 +2974,53 @@
                   <a:schemeClr val="tx1"/>
                 </a:solidFill>
               </a:rPr>
-              <a:t>A documented format and a reusable skill</a:t>
+              <a:t>One search across every service</a:t>
             </a:r>
             <a:endParaRPr lang="en-US" sz="3600" dirty="0"/>
           </a:p>
         </p:txBody>
       </p:sp>
-      <p:sp>
-        <p:nvSpPr>
-          <p:cNvPr id="3" name="localStorageFormats.md card"/>
-          <p:cNvSpPr/>
-          <p:nvPr/>
-        </p:nvSpPr>
-        <p:spPr>
-          <a:xfrm>
-            <a:off x="457200" y="1463040"/>
-            <a:ext cx="5486400" cy="3657600"/>
-          </a:xfrm>
-          <a:prstGeom prst="roundRect">
-            <a:avLst>
-              <a:gd name="adj" fmla="val 3000"/>
-            </a:avLst>
-          </a:prstGeom>
-          <a:solidFill>
-            <a:schemeClr val="bg2"/>
-          </a:solidFill>
-          <a:ln w="12700">
-            <a:solidFill>
-              <a:schemeClr val="bg2"/>
-            </a:solidFill>
-            <a:prstDash val="solid"/>
-          </a:ln>
-        </p:spPr>
-      </p:sp>
-      <p:sp>
-        <p:nvSpPr>
-          <p:cNvPr id="4" name="localStorageFormats.md heading"/>
+      <p:pic>
+        <p:nvPicPr>
+          <p:cNvPr id="3" name="Dashboard search for joe smith returning results from all services" descr="Dashboard search for joe smith returning results from all services">    </p:cNvPr>
+          <p:cNvPicPr>
+            <a:picLocks noChangeAspect="1"/>
+          </p:cNvPicPr>
+          <p:nvPr/>
+        </p:nvPicPr>
+        <p:blipFill>
+          <a:blip r:embed="rId1"/>
+          <a:stretch>
+            <a:fillRect/>
+          </a:stretch>
+        </p:blipFill>
+        <p:spPr>
+          <a:xfrm>
+            <a:off x="457200" y="1371600"/>
+            <a:ext cx="7863840" cy="4914900"/>
+          </a:xfrm>
+          <a:prstGeom prst="rect">
+            <a:avLst/>
+          </a:prstGeom>
+          <a:effectLst>
+            <a:outerShdw sx="100000" sy="100000" kx="0" ky="0" algn="bl" rotWithShape="0" blurRad="101600" dist="25400" dir="5400000">
+              <a:srgbClr val="1B2433">
+                <a:alpha val="18000"/>
+              </a:srgbClr>
+            </a:outerShdw>
+          </a:effectLst>
+        </p:spPr>
+      </p:pic>
+      <p:sp>
+        <p:nvSpPr>
+          <p:cNvPr id="4" name="stat results for “joe smith”"/>
           <p:cNvSpPr txBox="1"/>
           <p:nvPr/>
         </p:nvSpPr>
         <p:spPr>
           <a:xfrm>
-            <a:off x="777240" y="1691640"/>
-            <a:ext cx="4846320" cy="502920"/>
+            <a:off x="8778240" y="1463040"/>
+            <a:ext cx="2926080" cy="822960"/>
           </a:xfrm>
           <a:prstGeom prst="rect">
             <a:avLst/>
@@ -2975,27 +3036,27 @@
               <a:buNone/>
             </a:pPr>
             <a:r>
-              <a:rPr lang="en-US" sz="2000" b="1" dirty="0">
+              <a:rPr lang="en-US" sz="5400" b="1" dirty="0">
                 <a:solidFill>
                   <a:schemeClr val="tx1"/>
                 </a:solidFill>
               </a:rPr>
-              <a:t>localStorageFormats.md</a:t>
-            </a:r>
-            <a:endParaRPr lang="en-US" sz="2000" dirty="0"/>
-          </a:p>
-        </p:txBody>
-      </p:sp>
-      <p:sp>
-        <p:nvSpPr>
-          <p:cNvPr id="5" name="localStorageFormats.md list"/>
+              <a:t>19</a:t>
+            </a:r>
+            <a:endParaRPr lang="en-US" sz="5400" dirty="0"/>
+          </a:p>
+        </p:txBody>
+      </p:sp>
+      <p:sp>
+        <p:nvSpPr>
+          <p:cNvPr id="5" name="stat label results for “joe smith”"/>
           <p:cNvSpPr txBox="1"/>
           <p:nvPr/>
         </p:nvSpPr>
         <p:spPr>
           <a:xfrm>
-            <a:off x="777240" y="2331720"/>
-            <a:ext cx="4846320" cy="3108960"/>
+            <a:off x="8778240" y="2286000"/>
+            <a:ext cx="2926080" cy="457200"/>
           </a:xfrm>
           <a:prstGeom prst="rect">
             <a:avLst/>
@@ -3004,15 +3065,11 @@
           <a:ln/>
         </p:spPr>
         <p:txBody>
-          <a:bodyPr wrap="square" lIns="0" tIns="0" rIns="0" bIns="0" rtlCol="0" anchor="t"/>
-          <a:lstStyle/>
-          <a:p>
-            <a:pPr marL="342900" indent="-342900">
-              <a:spcAft>
-                <a:spcPts val="800"/>
-              </a:spcAft>
-              <a:buSzPct val="100000"/>
-              <a:buChar char="•"/>
+          <a:bodyPr wrap="square" lIns="0" tIns="0" rIns="0" bIns="0" rtlCol="0" anchor="ctr"/>
+          <a:lstStyle/>
+          <a:p>
+            <a:pPr indent="0" marL="0">
+              <a:buNone/>
             </a:pPr>
             <a:r>
               <a:rPr lang="en-US" sz="1500" dirty="0">
@@ -3020,17 +3077,71 @@
                   <a:schemeClr val="tx2"/>
                 </a:solidFill>
               </a:rPr>
-              <a:t>One sub-folder per service in dataExports/</a:t>
+              <a:t>results for “joe smith”</a:t>
             </a:r>
             <a:endParaRPr lang="en-US" sz="1500" dirty="0"/>
           </a:p>
-          <a:p>
-            <a:pPr marL="342900" indent="-342900">
-              <a:spcAft>
-                <a:spcPts val="800"/>
-              </a:spcAft>
-              <a:buSzPct val="100000"/>
-              <a:buChar char="•"/>
+        </p:txBody>
+      </p:sp>
+      <p:sp>
+        <p:nvSpPr>
+          <p:cNvPr id="6" name="stat services in one dashboard"/>
+          <p:cNvSpPr txBox="1"/>
+          <p:nvPr/>
+        </p:nvSpPr>
+        <p:spPr>
+          <a:xfrm>
+            <a:off x="8778240" y="3063240"/>
+            <a:ext cx="2926080" cy="822960"/>
+          </a:xfrm>
+          <a:prstGeom prst="rect">
+            <a:avLst/>
+          </a:prstGeom>
+          <a:noFill/>
+          <a:ln/>
+        </p:spPr>
+        <p:txBody>
+          <a:bodyPr wrap="square" lIns="0" tIns="0" rIns="0" bIns="0" rtlCol="0" anchor="ctr"/>
+          <a:lstStyle/>
+          <a:p>
+            <a:pPr indent="0" marL="0">
+              <a:buNone/>
+            </a:pPr>
+            <a:r>
+              <a:rPr lang="en-US" sz="5400" b="1" dirty="0">
+                <a:solidFill>
+                  <a:schemeClr val="tx1"/>
+                </a:solidFill>
+              </a:rPr>
+              <a:t>6</a:t>
+            </a:r>
+            <a:endParaRPr lang="en-US" sz="5400" dirty="0"/>
+          </a:p>
+        </p:txBody>
+      </p:sp>
+      <p:sp>
+        <p:nvSpPr>
+          <p:cNvPr id="7" name="stat label services in one dashboard"/>
+          <p:cNvSpPr txBox="1"/>
+          <p:nvPr/>
+        </p:nvSpPr>
+        <p:spPr>
+          <a:xfrm>
+            <a:off x="8778240" y="3886200"/>
+            <a:ext cx="2926080" cy="457200"/>
+          </a:xfrm>
+          <a:prstGeom prst="rect">
+            <a:avLst/>
+          </a:prstGeom>
+          <a:noFill/>
+          <a:ln/>
+        </p:spPr>
+        <p:txBody>
+          <a:bodyPr wrap="square" lIns="0" tIns="0" rIns="0" bIns="0" rtlCol="0" anchor="ctr"/>
+          <a:lstStyle/>
+          <a:p>
+            <a:pPr indent="0" marL="0">
+              <a:buNone/>
             </a:pPr>
             <a:r>
               <a:rPr lang="en-US" sz="1500" dirty="0">
@@ -3038,17 +3149,71 @@
                   <a:schemeClr val="tx2"/>
                 </a:solidFill>
               </a:rPr>
-              <a:t>One JSON file per item: &lt;UTC time&gt;_&lt;short id&gt;.json</a:t>
+              <a:t>services in one dashboard</a:t>
             </a:r>
             <a:endParaRPr lang="en-US" sz="1500" dirty="0"/>
           </a:p>
-          <a:p>
-            <a:pPr marL="342900" indent="-342900">
-              <a:spcAft>
-                <a:spcPts val="800"/>
-              </a:spcAft>
-              <a:buSzPct val="100000"/>
-              <a:buChar char="•"/>
+        </p:txBody>
+      </p:sp>
+      <p:sp>
+        <p:nvSpPr>
+          <p:cNvPr id="8" name="stat items searchable offline"/>
+          <p:cNvSpPr txBox="1"/>
+          <p:nvPr/>
+        </p:nvSpPr>
+        <p:spPr>
+          <a:xfrm>
+            <a:off x="8778240" y="4663440"/>
+            <a:ext cx="2926080" cy="822960"/>
+          </a:xfrm>
+          <a:prstGeom prst="rect">
+            <a:avLst/>
+          </a:prstGeom>
+          <a:noFill/>
+          <a:ln/>
+        </p:spPr>
+        <p:txBody>
+          <a:bodyPr wrap="square" lIns="0" tIns="0" rIns="0" bIns="0" rtlCol="0" anchor="ctr"/>
+          <a:lstStyle/>
+          <a:p>
+            <a:pPr indent="0" marL="0">
+              <a:buNone/>
+            </a:pPr>
+            <a:r>
+              <a:rPr lang="en-US" sz="5400" b="1" dirty="0">
+                <a:solidFill>
+                  <a:schemeClr val="tx1"/>
+                </a:solidFill>
+              </a:rPr>
+              <a:t>102</a:t>
+            </a:r>
+            <a:endParaRPr lang="en-US" sz="5400" dirty="0"/>
+          </a:p>
+        </p:txBody>
+      </p:sp>
+      <p:sp>
+        <p:nvSpPr>
+          <p:cNvPr id="9" name="stat label items searchable offline"/>
+          <p:cNvSpPr txBox="1"/>
+          <p:nvPr/>
+        </p:nvSpPr>
+        <p:spPr>
+          <a:xfrm>
+            <a:off x="8778240" y="5486400"/>
+            <a:ext cx="2926080" cy="457200"/>
+          </a:xfrm>
+          <a:prstGeom prst="rect">
+            <a:avLst/>
+          </a:prstGeom>
+          <a:noFill/>
+          <a:ln/>
+        </p:spPr>
+        <p:txBody>
+          <a:bodyPr wrap="square" lIns="0" tIns="0" rIns="0" bIns="0" rtlCol="0" anchor="ctr"/>
+          <a:lstStyle/>
+          <a:p>
+            <a:pPr indent="0" marL="0">
+              <a:buNone/>
             </a:pPr>
             <a:r>
               <a:rPr lang="en-US" sz="1500" dirty="0">
@@ -3056,406 +3221,9 @@
                   <a:schemeClr val="tx2"/>
                 </a:solidFill>
               </a:rPr>
-              <a:t>Shared fields: service, id, title, body, author, created, updated, url</a:t>
+              <a:t>items searchable offline</a:t>
             </a:r>
             <a:endParaRPr lang="en-US" sz="1500" dirty="0"/>
-          </a:p>
-          <a:p>
-            <a:pPr marL="342900" indent="-342900">
-              <a:spcAft>
-                <a:spcPts val="800"/>
-              </a:spcAft>
-              <a:buSzPct val="100000"/>
-              <a:buChar char="•"/>
-            </a:pPr>
-            <a:r>
-              <a:rPr lang="en-US" sz="1500" dirty="0">
-                <a:solidFill>
-                  <a:schemeClr val="tx2"/>
-                </a:solidFill>
-              </a:rPr>
-              <a:t>Service-specific details in a metadata object (email from/to/labels, repo README, issue status/priority…)</a:t>
-            </a:r>
-            <a:endParaRPr lang="en-US" sz="1500" dirty="0"/>
-          </a:p>
-        </p:txBody>
-      </p:sp>
-      <p:sp>
-        <p:nvSpPr>
-          <p:cNvPr id="6" name=".claude/skills/export-service-data card"/>
-          <p:cNvSpPr/>
-          <p:nvPr/>
-        </p:nvSpPr>
-        <p:spPr>
-          <a:xfrm>
-            <a:off x="6172200" y="1463040"/>
-            <a:ext cx="5486400" cy="3657600"/>
-          </a:xfrm>
-          <a:prstGeom prst="roundRect">
-            <a:avLst>
-              <a:gd name="adj" fmla="val 3000"/>
-            </a:avLst>
-          </a:prstGeom>
-          <a:solidFill>
-            <a:schemeClr val="bg2"/>
-          </a:solidFill>
-          <a:ln w="12700">
-            <a:solidFill>
-              <a:schemeClr val="bg2"/>
-            </a:solidFill>
-            <a:prstDash val="solid"/>
-          </a:ln>
-        </p:spPr>
-      </p:sp>
-      <p:sp>
-        <p:nvSpPr>
-          <p:cNvPr id="7" name=".claude/skills/export-service-data heading"/>
-          <p:cNvSpPr txBox="1"/>
-          <p:nvPr/>
-        </p:nvSpPr>
-        <p:spPr>
-          <a:xfrm>
-            <a:off x="6492240" y="1691640"/>
-            <a:ext cx="4846320" cy="502920"/>
-          </a:xfrm>
-          <a:prstGeom prst="rect">
-            <a:avLst/>
-          </a:prstGeom>
-          <a:noFill/>
-          <a:ln/>
-        </p:spPr>
-        <p:txBody>
-          <a:bodyPr wrap="square" lIns="0" tIns="0" rIns="0" bIns="0" rtlCol="0" anchor="ctr"/>
-          <a:lstStyle/>
-          <a:p>
-            <a:pPr indent="0" marL="0">
-              <a:buNone/>
-            </a:pPr>
-            <a:r>
-              <a:rPr lang="en-US" sz="2000" b="1" dirty="0">
-                <a:solidFill>
-                  <a:schemeClr val="tx1"/>
-                </a:solidFill>
-              </a:rPr>
-              <a:t>.claude/skills/export-service-data</a:t>
-            </a:r>
-            <a:endParaRPr lang="en-US" sz="2000" dirty="0"/>
-          </a:p>
-        </p:txBody>
-      </p:sp>
-      <p:sp>
-        <p:nvSpPr>
-          <p:cNvPr id="8" name=".claude/skills/export-service-data list"/>
-          <p:cNvSpPr txBox="1"/>
-          <p:nvPr/>
-        </p:nvSpPr>
-        <p:spPr>
-          <a:xfrm>
-            <a:off x="6492240" y="2331720"/>
-            <a:ext cx="4846320" cy="3108960"/>
-          </a:xfrm>
-          <a:prstGeom prst="rect">
-            <a:avLst/>
-          </a:prstGeom>
-          <a:noFill/>
-          <a:ln/>
-        </p:spPr>
-        <p:txBody>
-          <a:bodyPr wrap="square" lIns="0" tIns="0" rIns="0" bIns="0" rtlCol="0" anchor="t"/>
-          <a:lstStyle/>
-          <a:p>
-            <a:pPr marL="342900" indent="-342900">
-              <a:spcAft>
-                <a:spcPts val="800"/>
-              </a:spcAft>
-              <a:buSzPct val="100000"/>
-              <a:buChar char="•"/>
-            </a:pPr>
-            <a:r>
-              <a:rPr lang="en-US" sz="1500" dirty="0">
-                <a:solidFill>
-                  <a:schemeClr val="tx2"/>
-                </a:solidFill>
-              </a:rPr>
-              <a:t>Tells Claude how to download from each service and store it exactly per the format doc</a:t>
-            </a:r>
-            <a:endParaRPr lang="en-US" sz="1500" dirty="0"/>
-          </a:p>
-          <a:p>
-            <a:pPr marL="342900" indent="-342900">
-              <a:spcAft>
-                <a:spcPts val="800"/>
-              </a:spcAft>
-              <a:buSzPct val="100000"/>
-              <a:buChar char="•"/>
-            </a:pPr>
-            <a:r>
-              <a:rPr lang="en-US" sz="1500" dirty="0">
-                <a:solidFill>
-                  <a:schemeClr val="tx2"/>
-                </a:solidFill>
-              </a:rPr>
-              <a:t>Skips items already on disk by comparing ids</a:t>
-            </a:r>
-            <a:endParaRPr lang="en-US" sz="1500" dirty="0"/>
-          </a:p>
-          <a:p>
-            <a:pPr marL="342900" indent="-342900">
-              <a:spcAft>
-                <a:spcPts val="800"/>
-              </a:spcAft>
-              <a:buSzPct val="100000"/>
-              <a:buChar char="•"/>
-            </a:pPr>
-            <a:r>
-              <a:rPr lang="en-US" sz="1500" dirty="0">
-                <a:solidFill>
-                  <a:schemeClr val="tx2"/>
-                </a:solidFill>
-              </a:rPr>
-              <a:t>Tested in a fresh conversation: skipped the 25 existing items and saved only new ones</a:t>
-            </a:r>
-            <a:endParaRPr lang="en-US" sz="1500" dirty="0"/>
-          </a:p>
-        </p:txBody>
-      </p:sp>
-      <p:sp>
-        <p:nvSpPr>
-          <p:cNvPr id="9" name="label Gmail: 24"/>
-          <p:cNvSpPr txBox="1"/>
-          <p:nvPr/>
-        </p:nvSpPr>
-        <p:spPr>
-          <a:xfrm>
-            <a:off x="457200" y="5440680"/>
-            <a:ext cx="1737360" cy="329184"/>
-          </a:xfrm>
-          <a:prstGeom prst="roundRect">
-            <a:avLst>
-              <a:gd name="adj" fmla="val 22222"/>
-            </a:avLst>
-          </a:prstGeom>
-          <a:solidFill>
-            <a:srgbClr val="D93025"/>
-          </a:solidFill>
-          <a:ln/>
-        </p:spPr>
-        <p:txBody>
-          <a:bodyPr wrap="square" lIns="0" tIns="0" rIns="0" bIns="0" rtlCol="0" anchor="ctr"/>
-          <a:lstStyle/>
-          <a:p>
-            <a:pPr algn="ctr" indent="0" marL="0">
-              <a:buNone/>
-            </a:pPr>
-            <a:r>
-              <a:rPr lang="en-US" sz="1200" b="1" dirty="0">
-                <a:solidFill>
-                  <a:srgbClr val="FFFFFF"/>
-                </a:solidFill>
-              </a:rPr>
-              <a:t>Gmail: 24</a:t>
-            </a:r>
-            <a:endParaRPr lang="en-US" sz="1200" dirty="0"/>
-          </a:p>
-        </p:txBody>
-      </p:sp>
-      <p:sp>
-        <p:nvSpPr>
-          <p:cNvPr id="10" name="label GitHub: 11"/>
-          <p:cNvSpPr txBox="1"/>
-          <p:nvPr/>
-        </p:nvSpPr>
-        <p:spPr>
-          <a:xfrm>
-            <a:off x="2350008" y="5440680"/>
-            <a:ext cx="1737360" cy="329184"/>
-          </a:xfrm>
-          <a:prstGeom prst="roundRect">
-            <a:avLst>
-              <a:gd name="adj" fmla="val 22222"/>
-            </a:avLst>
-          </a:prstGeom>
-          <a:solidFill>
-            <a:srgbClr val="24292F"/>
-          </a:solidFill>
-          <a:ln/>
-        </p:spPr>
-        <p:txBody>
-          <a:bodyPr wrap="square" lIns="0" tIns="0" rIns="0" bIns="0" rtlCol="0" anchor="ctr"/>
-          <a:lstStyle/>
-          <a:p>
-            <a:pPr algn="ctr" indent="0" marL="0">
-              <a:buNone/>
-            </a:pPr>
-            <a:r>
-              <a:rPr lang="en-US" sz="1200" b="1" dirty="0">
-                <a:solidFill>
-                  <a:srgbClr val="FFFFFF"/>
-                </a:solidFill>
-              </a:rPr>
-              <a:t>GitHub: 11</a:t>
-            </a:r>
-            <a:endParaRPr lang="en-US" sz="1200" dirty="0"/>
-          </a:p>
-        </p:txBody>
-      </p:sp>
-      <p:sp>
-        <p:nvSpPr>
-          <p:cNvPr id="11" name="label Notion: 20"/>
-          <p:cNvSpPr txBox="1"/>
-          <p:nvPr/>
-        </p:nvSpPr>
-        <p:spPr>
-          <a:xfrm>
-            <a:off x="4242816" y="5440680"/>
-            <a:ext cx="1737360" cy="329184"/>
-          </a:xfrm>
-          <a:prstGeom prst="roundRect">
-            <a:avLst>
-              <a:gd name="adj" fmla="val 22222"/>
-            </a:avLst>
-          </a:prstGeom>
-          <a:solidFill>
-            <a:srgbClr val="7A6A55"/>
-          </a:solidFill>
-          <a:ln/>
-        </p:spPr>
-        <p:txBody>
-          <a:bodyPr wrap="square" lIns="0" tIns="0" rIns="0" bIns="0" rtlCol="0" anchor="ctr"/>
-          <a:lstStyle/>
-          <a:p>
-            <a:pPr algn="ctr" indent="0" marL="0">
-              <a:buNone/>
-            </a:pPr>
-            <a:r>
-              <a:rPr lang="en-US" sz="1200" b="1" dirty="0">
-                <a:solidFill>
-                  <a:srgbClr val="FFFFFF"/>
-                </a:solidFill>
-              </a:rPr>
-              <a:t>Notion: 20</a:t>
-            </a:r>
-            <a:endParaRPr lang="en-US" sz="1200" dirty="0"/>
-          </a:p>
-        </p:txBody>
-      </p:sp>
-      <p:sp>
-        <p:nvSpPr>
-          <p:cNvPr id="12" name="label Linear: 14"/>
-          <p:cNvSpPr txBox="1"/>
-          <p:nvPr/>
-        </p:nvSpPr>
-        <p:spPr>
-          <a:xfrm>
-            <a:off x="6135624" y="5440680"/>
-            <a:ext cx="1737360" cy="329184"/>
-          </a:xfrm>
-          <a:prstGeom prst="roundRect">
-            <a:avLst>
-              <a:gd name="adj" fmla="val 22222"/>
-            </a:avLst>
-          </a:prstGeom>
-          <a:solidFill>
-            <a:srgbClr val="5E6AD2"/>
-          </a:solidFill>
-          <a:ln/>
-        </p:spPr>
-        <p:txBody>
-          <a:bodyPr wrap="square" lIns="0" tIns="0" rIns="0" bIns="0" rtlCol="0" anchor="ctr"/>
-          <a:lstStyle/>
-          <a:p>
-            <a:pPr algn="ctr" indent="0" marL="0">
-              <a:buNone/>
-            </a:pPr>
-            <a:r>
-              <a:rPr lang="en-US" sz="1200" b="1" dirty="0">
-                <a:solidFill>
-                  <a:srgbClr val="FFFFFF"/>
-                </a:solidFill>
-              </a:rPr>
-              <a:t>Linear: 14</a:t>
-            </a:r>
-            <a:endParaRPr lang="en-US" sz="1200" dirty="0"/>
-          </a:p>
-        </p:txBody>
-      </p:sp>
-      <p:sp>
-        <p:nvSpPr>
-          <p:cNvPr id="13" name="label Todoist: 10"/>
-          <p:cNvSpPr txBox="1"/>
-          <p:nvPr/>
-        </p:nvSpPr>
-        <p:spPr>
-          <a:xfrm>
-            <a:off x="8028432" y="5440680"/>
-            <a:ext cx="1737360" cy="329184"/>
-          </a:xfrm>
-          <a:prstGeom prst="roundRect">
-            <a:avLst>
-              <a:gd name="adj" fmla="val 22222"/>
-            </a:avLst>
-          </a:prstGeom>
-          <a:solidFill>
-            <a:srgbClr val="C2410C"/>
-          </a:solidFill>
-          <a:ln/>
-        </p:spPr>
-        <p:txBody>
-          <a:bodyPr wrap="square" lIns="0" tIns="0" rIns="0" bIns="0" rtlCol="0" anchor="ctr"/>
-          <a:lstStyle/>
-          <a:p>
-            <a:pPr algn="ctr" indent="0" marL="0">
-              <a:buNone/>
-            </a:pPr>
-            <a:r>
-              <a:rPr lang="en-US" sz="1200" b="1" dirty="0">
-                <a:solidFill>
-                  <a:srgbClr val="FFFFFF"/>
-                </a:solidFill>
-              </a:rPr>
-              <a:t>Todoist: 10</a:t>
-            </a:r>
-            <a:endParaRPr lang="en-US" sz="1200" dirty="0"/>
-          </a:p>
-        </p:txBody>
-      </p:sp>
-      <p:sp>
-        <p:nvSpPr>
-          <p:cNvPr id="14" name="label Jira: 23"/>
-          <p:cNvSpPr txBox="1"/>
-          <p:nvPr/>
-        </p:nvSpPr>
-        <p:spPr>
-          <a:xfrm>
-            <a:off x="9921240" y="5440680"/>
-            <a:ext cx="1737360" cy="329184"/>
-          </a:xfrm>
-          <a:prstGeom prst="roundRect">
-            <a:avLst>
-              <a:gd name="adj" fmla="val 22222"/>
-            </a:avLst>
-          </a:prstGeom>
-          <a:solidFill>
-            <a:srgbClr val="0C66E4"/>
-          </a:solidFill>
-          <a:ln/>
-        </p:spPr>
-        <p:txBody>
-          <a:bodyPr wrap="square" lIns="0" tIns="0" rIns="0" bIns="0" rtlCol="0" anchor="ctr"/>
-          <a:lstStyle/>
-          <a:p>
-            <a:pPr algn="ctr" indent="0" marL="0">
-              <a:buNone/>
-            </a:pPr>
-            <a:r>
-              <a:rPr lang="en-US" sz="1200" b="1" dirty="0">
-                <a:solidFill>
-                  <a:srgbClr val="FFFFFF"/>
-                </a:solidFill>
-              </a:rPr>
-              <a:t>Jira: 23</a:t>
-            </a:r>
-            <a:endParaRPr lang="en-US" sz="1200" dirty="0"/>
           </a:p>
         </p:txBody>
       </p:sp>
@@ -3539,6 +3307,650 @@
         </p:nvSpPr>
         <p:spPr>
           <a:xfrm>
+            <a:off x="457200" y="320040"/>
+            <a:ext cx="11247120" cy="777240"/>
+          </a:xfrm>
+          <a:prstGeom prst="rect">
+            <a:avLst/>
+          </a:prstGeom>
+          <a:noFill/>
+          <a:ln/>
+        </p:spPr>
+        <p:txBody>
+          <a:bodyPr wrap="square" lIns="0" tIns="0" rIns="0" bIns="0" rtlCol="0" anchor="ctr"/>
+          <a:lstStyle/>
+          <a:p>
+            <a:pPr algn="l" indent="0" marL="0">
+              <a:buNone/>
+            </a:pPr>
+            <a:r>
+              <a:rPr lang="en-US" sz="3600" b="1" dirty="0">
+                <a:solidFill>
+                  <a:schemeClr val="tx1"/>
+                </a:solidFill>
+              </a:rPr>
+              <a:t>A documented format and a reusable skill</a:t>
+            </a:r>
+            <a:endParaRPr lang="en-US" sz="3600" dirty="0"/>
+          </a:p>
+        </p:txBody>
+      </p:sp>
+      <p:sp>
+        <p:nvSpPr>
+          <p:cNvPr id="3" name="localStorageFormats.md card"/>
+          <p:cNvSpPr/>
+          <p:nvPr/>
+        </p:nvSpPr>
+        <p:spPr>
+          <a:xfrm>
+            <a:off x="457200" y="1463040"/>
+            <a:ext cx="5486400" cy="3657600"/>
+          </a:xfrm>
+          <a:prstGeom prst="roundRect">
+            <a:avLst>
+              <a:gd name="adj" fmla="val 3000"/>
+            </a:avLst>
+          </a:prstGeom>
+          <a:solidFill>
+            <a:schemeClr val="bg2"/>
+          </a:solidFill>
+          <a:ln w="12700">
+            <a:solidFill>
+              <a:schemeClr val="bg2"/>
+            </a:solidFill>
+            <a:prstDash val="solid"/>
+          </a:ln>
+        </p:spPr>
+      </p:sp>
+      <p:sp>
+        <p:nvSpPr>
+          <p:cNvPr id="4" name="localStorageFormats.md heading"/>
+          <p:cNvSpPr txBox="1"/>
+          <p:nvPr/>
+        </p:nvSpPr>
+        <p:spPr>
+          <a:xfrm>
+            <a:off x="777240" y="1691640"/>
+            <a:ext cx="4846320" cy="502920"/>
+          </a:xfrm>
+          <a:prstGeom prst="rect">
+            <a:avLst/>
+          </a:prstGeom>
+          <a:noFill/>
+          <a:ln/>
+        </p:spPr>
+        <p:txBody>
+          <a:bodyPr wrap="square" lIns="0" tIns="0" rIns="0" bIns="0" rtlCol="0" anchor="ctr"/>
+          <a:lstStyle/>
+          <a:p>
+            <a:pPr indent="0" marL="0">
+              <a:buNone/>
+            </a:pPr>
+            <a:r>
+              <a:rPr lang="en-US" sz="2000" b="1" dirty="0">
+                <a:solidFill>
+                  <a:schemeClr val="tx1"/>
+                </a:solidFill>
+              </a:rPr>
+              <a:t>localStorageFormats.md</a:t>
+            </a:r>
+            <a:endParaRPr lang="en-US" sz="2000" dirty="0"/>
+          </a:p>
+        </p:txBody>
+      </p:sp>
+      <p:sp>
+        <p:nvSpPr>
+          <p:cNvPr id="5" name="localStorageFormats.md list"/>
+          <p:cNvSpPr txBox="1"/>
+          <p:nvPr/>
+        </p:nvSpPr>
+        <p:spPr>
+          <a:xfrm>
+            <a:off x="777240" y="2331720"/>
+            <a:ext cx="4846320" cy="3108960"/>
+          </a:xfrm>
+          <a:prstGeom prst="rect">
+            <a:avLst/>
+          </a:prstGeom>
+          <a:noFill/>
+          <a:ln/>
+        </p:spPr>
+        <p:txBody>
+          <a:bodyPr wrap="square" lIns="0" tIns="0" rIns="0" bIns="0" rtlCol="0" anchor="t"/>
+          <a:lstStyle/>
+          <a:p>
+            <a:pPr marL="342900" indent="-342900">
+              <a:spcAft>
+                <a:spcPts val="800"/>
+              </a:spcAft>
+              <a:buSzPct val="100000"/>
+              <a:buChar char="•"/>
+            </a:pPr>
+            <a:r>
+              <a:rPr lang="en-US" sz="1500" dirty="0">
+                <a:solidFill>
+                  <a:schemeClr val="tx2"/>
+                </a:solidFill>
+              </a:rPr>
+              <a:t>One sub-folder per service in dataExports/</a:t>
+            </a:r>
+            <a:endParaRPr lang="en-US" sz="1500" dirty="0"/>
+          </a:p>
+          <a:p>
+            <a:pPr marL="342900" indent="-342900">
+              <a:spcAft>
+                <a:spcPts val="800"/>
+              </a:spcAft>
+              <a:buSzPct val="100000"/>
+              <a:buChar char="•"/>
+            </a:pPr>
+            <a:r>
+              <a:rPr lang="en-US" sz="1500" dirty="0">
+                <a:solidFill>
+                  <a:schemeClr val="tx2"/>
+                </a:solidFill>
+              </a:rPr>
+              <a:t>One JSON file per item: &lt;UTC time&gt;_&lt;short id&gt;.json</a:t>
+            </a:r>
+            <a:endParaRPr lang="en-US" sz="1500" dirty="0"/>
+          </a:p>
+          <a:p>
+            <a:pPr marL="342900" indent="-342900">
+              <a:spcAft>
+                <a:spcPts val="800"/>
+              </a:spcAft>
+              <a:buSzPct val="100000"/>
+              <a:buChar char="•"/>
+            </a:pPr>
+            <a:r>
+              <a:rPr lang="en-US" sz="1500" dirty="0">
+                <a:solidFill>
+                  <a:schemeClr val="tx2"/>
+                </a:solidFill>
+              </a:rPr>
+              <a:t>Shared fields: service, id, title, body, author, created, updated, url</a:t>
+            </a:r>
+            <a:endParaRPr lang="en-US" sz="1500" dirty="0"/>
+          </a:p>
+          <a:p>
+            <a:pPr marL="342900" indent="-342900">
+              <a:spcAft>
+                <a:spcPts val="800"/>
+              </a:spcAft>
+              <a:buSzPct val="100000"/>
+              <a:buChar char="•"/>
+            </a:pPr>
+            <a:r>
+              <a:rPr lang="en-US" sz="1500" dirty="0">
+                <a:solidFill>
+                  <a:schemeClr val="tx2"/>
+                </a:solidFill>
+              </a:rPr>
+              <a:t>Service-specific details in a metadata object (email from/to/labels, repo README, issue status/priority…)</a:t>
+            </a:r>
+            <a:endParaRPr lang="en-US" sz="1500" dirty="0"/>
+          </a:p>
+        </p:txBody>
+      </p:sp>
+      <p:sp>
+        <p:nvSpPr>
+          <p:cNvPr id="6" name=".claude/skills/export-service-data card"/>
+          <p:cNvSpPr/>
+          <p:nvPr/>
+        </p:nvSpPr>
+        <p:spPr>
+          <a:xfrm>
+            <a:off x="6172200" y="1463040"/>
+            <a:ext cx="5486400" cy="3657600"/>
+          </a:xfrm>
+          <a:prstGeom prst="roundRect">
+            <a:avLst>
+              <a:gd name="adj" fmla="val 3000"/>
+            </a:avLst>
+          </a:prstGeom>
+          <a:solidFill>
+            <a:schemeClr val="bg2"/>
+          </a:solidFill>
+          <a:ln w="12700">
+            <a:solidFill>
+              <a:schemeClr val="bg2"/>
+            </a:solidFill>
+            <a:prstDash val="solid"/>
+          </a:ln>
+        </p:spPr>
+      </p:sp>
+      <p:sp>
+        <p:nvSpPr>
+          <p:cNvPr id="7" name=".claude/skills/export-service-data heading"/>
+          <p:cNvSpPr txBox="1"/>
+          <p:nvPr/>
+        </p:nvSpPr>
+        <p:spPr>
+          <a:xfrm>
+            <a:off x="6492240" y="1691640"/>
+            <a:ext cx="4846320" cy="502920"/>
+          </a:xfrm>
+          <a:prstGeom prst="rect">
+            <a:avLst/>
+          </a:prstGeom>
+          <a:noFill/>
+          <a:ln/>
+        </p:spPr>
+        <p:txBody>
+          <a:bodyPr wrap="square" lIns="0" tIns="0" rIns="0" bIns="0" rtlCol="0" anchor="ctr"/>
+          <a:lstStyle/>
+          <a:p>
+            <a:pPr indent="0" marL="0">
+              <a:buNone/>
+            </a:pPr>
+            <a:r>
+              <a:rPr lang="en-US" sz="2000" b="1" dirty="0">
+                <a:solidFill>
+                  <a:schemeClr val="tx1"/>
+                </a:solidFill>
+              </a:rPr>
+              <a:t>.claude/skills/export-service-data</a:t>
+            </a:r>
+            <a:endParaRPr lang="en-US" sz="2000" dirty="0"/>
+          </a:p>
+        </p:txBody>
+      </p:sp>
+      <p:sp>
+        <p:nvSpPr>
+          <p:cNvPr id="8" name=".claude/skills/export-service-data list"/>
+          <p:cNvSpPr txBox="1"/>
+          <p:nvPr/>
+        </p:nvSpPr>
+        <p:spPr>
+          <a:xfrm>
+            <a:off x="6492240" y="2331720"/>
+            <a:ext cx="4846320" cy="3108960"/>
+          </a:xfrm>
+          <a:prstGeom prst="rect">
+            <a:avLst/>
+          </a:prstGeom>
+          <a:noFill/>
+          <a:ln/>
+        </p:spPr>
+        <p:txBody>
+          <a:bodyPr wrap="square" lIns="0" tIns="0" rIns="0" bIns="0" rtlCol="0" anchor="t"/>
+          <a:lstStyle/>
+          <a:p>
+            <a:pPr marL="342900" indent="-342900">
+              <a:spcAft>
+                <a:spcPts val="800"/>
+              </a:spcAft>
+              <a:buSzPct val="100000"/>
+              <a:buChar char="•"/>
+            </a:pPr>
+            <a:r>
+              <a:rPr lang="en-US" sz="1500" dirty="0">
+                <a:solidFill>
+                  <a:schemeClr val="tx2"/>
+                </a:solidFill>
+              </a:rPr>
+              <a:t>Tells Claude how to download from each service and store it exactly per the format doc</a:t>
+            </a:r>
+            <a:endParaRPr lang="en-US" sz="1500" dirty="0"/>
+          </a:p>
+          <a:p>
+            <a:pPr marL="342900" indent="-342900">
+              <a:spcAft>
+                <a:spcPts val="800"/>
+              </a:spcAft>
+              <a:buSzPct val="100000"/>
+              <a:buChar char="•"/>
+            </a:pPr>
+            <a:r>
+              <a:rPr lang="en-US" sz="1500" dirty="0">
+                <a:solidFill>
+                  <a:schemeClr val="tx2"/>
+                </a:solidFill>
+              </a:rPr>
+              <a:t>Skips items already on disk by comparing ids</a:t>
+            </a:r>
+            <a:endParaRPr lang="en-US" sz="1500" dirty="0"/>
+          </a:p>
+          <a:p>
+            <a:pPr marL="342900" indent="-342900">
+              <a:spcAft>
+                <a:spcPts val="800"/>
+              </a:spcAft>
+              <a:buSzPct val="100000"/>
+              <a:buChar char="•"/>
+            </a:pPr>
+            <a:r>
+              <a:rPr lang="en-US" sz="1500" dirty="0">
+                <a:solidFill>
+                  <a:schemeClr val="tx2"/>
+                </a:solidFill>
+              </a:rPr>
+              <a:t>Tested in a fresh conversation: skipped the 25 existing items and saved only new ones</a:t>
+            </a:r>
+            <a:endParaRPr lang="en-US" sz="1500" dirty="0"/>
+          </a:p>
+        </p:txBody>
+      </p:sp>
+      <p:sp>
+        <p:nvSpPr>
+          <p:cNvPr id="9" name="label Gmail: 24"/>
+          <p:cNvSpPr txBox="1"/>
+          <p:nvPr/>
+        </p:nvSpPr>
+        <p:spPr>
+          <a:xfrm>
+            <a:off x="457200" y="5440680"/>
+            <a:ext cx="1737360" cy="329184"/>
+          </a:xfrm>
+          <a:prstGeom prst="roundRect">
+            <a:avLst>
+              <a:gd name="adj" fmla="val 22222"/>
+            </a:avLst>
+          </a:prstGeom>
+          <a:solidFill>
+            <a:srgbClr val="D93025"/>
+          </a:solidFill>
+          <a:ln/>
+        </p:spPr>
+        <p:txBody>
+          <a:bodyPr wrap="square" lIns="0" tIns="0" rIns="0" bIns="0" rtlCol="0" anchor="ctr"/>
+          <a:lstStyle/>
+          <a:p>
+            <a:pPr algn="ctr" indent="0" marL="0">
+              <a:buNone/>
+            </a:pPr>
+            <a:r>
+              <a:rPr lang="en-US" sz="1200" b="1" dirty="0">
+                <a:solidFill>
+                  <a:srgbClr val="FFFFFF"/>
+                </a:solidFill>
+              </a:rPr>
+              <a:t>Gmail: 24</a:t>
+            </a:r>
+            <a:endParaRPr lang="en-US" sz="1200" dirty="0"/>
+          </a:p>
+        </p:txBody>
+      </p:sp>
+      <p:sp>
+        <p:nvSpPr>
+          <p:cNvPr id="10" name="label GitHub: 11"/>
+          <p:cNvSpPr txBox="1"/>
+          <p:nvPr/>
+        </p:nvSpPr>
+        <p:spPr>
+          <a:xfrm>
+            <a:off x="2350008" y="5440680"/>
+            <a:ext cx="1737360" cy="329184"/>
+          </a:xfrm>
+          <a:prstGeom prst="roundRect">
+            <a:avLst>
+              <a:gd name="adj" fmla="val 22222"/>
+            </a:avLst>
+          </a:prstGeom>
+          <a:solidFill>
+            <a:srgbClr val="24292F"/>
+          </a:solidFill>
+          <a:ln/>
+        </p:spPr>
+        <p:txBody>
+          <a:bodyPr wrap="square" lIns="0" tIns="0" rIns="0" bIns="0" rtlCol="0" anchor="ctr"/>
+          <a:lstStyle/>
+          <a:p>
+            <a:pPr algn="ctr" indent="0" marL="0">
+              <a:buNone/>
+            </a:pPr>
+            <a:r>
+              <a:rPr lang="en-US" sz="1200" b="1" dirty="0">
+                <a:solidFill>
+                  <a:srgbClr val="FFFFFF"/>
+                </a:solidFill>
+              </a:rPr>
+              <a:t>GitHub: 11</a:t>
+            </a:r>
+            <a:endParaRPr lang="en-US" sz="1200" dirty="0"/>
+          </a:p>
+        </p:txBody>
+      </p:sp>
+      <p:sp>
+        <p:nvSpPr>
+          <p:cNvPr id="11" name="label Notion: 20"/>
+          <p:cNvSpPr txBox="1"/>
+          <p:nvPr/>
+        </p:nvSpPr>
+        <p:spPr>
+          <a:xfrm>
+            <a:off x="4242816" y="5440680"/>
+            <a:ext cx="1737360" cy="329184"/>
+          </a:xfrm>
+          <a:prstGeom prst="roundRect">
+            <a:avLst>
+              <a:gd name="adj" fmla="val 22222"/>
+            </a:avLst>
+          </a:prstGeom>
+          <a:solidFill>
+            <a:srgbClr val="7A6A55"/>
+          </a:solidFill>
+          <a:ln/>
+        </p:spPr>
+        <p:txBody>
+          <a:bodyPr wrap="square" lIns="0" tIns="0" rIns="0" bIns="0" rtlCol="0" anchor="ctr"/>
+          <a:lstStyle/>
+          <a:p>
+            <a:pPr algn="ctr" indent="0" marL="0">
+              <a:buNone/>
+            </a:pPr>
+            <a:r>
+              <a:rPr lang="en-US" sz="1200" b="1" dirty="0">
+                <a:solidFill>
+                  <a:srgbClr val="FFFFFF"/>
+                </a:solidFill>
+              </a:rPr>
+              <a:t>Notion: 20</a:t>
+            </a:r>
+            <a:endParaRPr lang="en-US" sz="1200" dirty="0"/>
+          </a:p>
+        </p:txBody>
+      </p:sp>
+      <p:sp>
+        <p:nvSpPr>
+          <p:cNvPr id="12" name="label Linear: 14"/>
+          <p:cNvSpPr txBox="1"/>
+          <p:nvPr/>
+        </p:nvSpPr>
+        <p:spPr>
+          <a:xfrm>
+            <a:off x="6135624" y="5440680"/>
+            <a:ext cx="1737360" cy="329184"/>
+          </a:xfrm>
+          <a:prstGeom prst="roundRect">
+            <a:avLst>
+              <a:gd name="adj" fmla="val 22222"/>
+            </a:avLst>
+          </a:prstGeom>
+          <a:solidFill>
+            <a:srgbClr val="5E6AD2"/>
+          </a:solidFill>
+          <a:ln/>
+        </p:spPr>
+        <p:txBody>
+          <a:bodyPr wrap="square" lIns="0" tIns="0" rIns="0" bIns="0" rtlCol="0" anchor="ctr"/>
+          <a:lstStyle/>
+          <a:p>
+            <a:pPr algn="ctr" indent="0" marL="0">
+              <a:buNone/>
+            </a:pPr>
+            <a:r>
+              <a:rPr lang="en-US" sz="1200" b="1" dirty="0">
+                <a:solidFill>
+                  <a:srgbClr val="FFFFFF"/>
+                </a:solidFill>
+              </a:rPr>
+              <a:t>Linear: 14</a:t>
+            </a:r>
+            <a:endParaRPr lang="en-US" sz="1200" dirty="0"/>
+          </a:p>
+        </p:txBody>
+      </p:sp>
+      <p:sp>
+        <p:nvSpPr>
+          <p:cNvPr id="13" name="label Todoist: 10"/>
+          <p:cNvSpPr txBox="1"/>
+          <p:nvPr/>
+        </p:nvSpPr>
+        <p:spPr>
+          <a:xfrm>
+            <a:off x="8028432" y="5440680"/>
+            <a:ext cx="1737360" cy="329184"/>
+          </a:xfrm>
+          <a:prstGeom prst="roundRect">
+            <a:avLst>
+              <a:gd name="adj" fmla="val 22222"/>
+            </a:avLst>
+          </a:prstGeom>
+          <a:solidFill>
+            <a:srgbClr val="C2410C"/>
+          </a:solidFill>
+          <a:ln/>
+        </p:spPr>
+        <p:txBody>
+          <a:bodyPr wrap="square" lIns="0" tIns="0" rIns="0" bIns="0" rtlCol="0" anchor="ctr"/>
+          <a:lstStyle/>
+          <a:p>
+            <a:pPr algn="ctr" indent="0" marL="0">
+              <a:buNone/>
+            </a:pPr>
+            <a:r>
+              <a:rPr lang="en-US" sz="1200" b="1" dirty="0">
+                <a:solidFill>
+                  <a:srgbClr val="FFFFFF"/>
+                </a:solidFill>
+              </a:rPr>
+              <a:t>Todoist: 10</a:t>
+            </a:r>
+            <a:endParaRPr lang="en-US" sz="1200" dirty="0"/>
+          </a:p>
+        </p:txBody>
+      </p:sp>
+      <p:sp>
+        <p:nvSpPr>
+          <p:cNvPr id="14" name="label Jira: 23"/>
+          <p:cNvSpPr txBox="1"/>
+          <p:nvPr/>
+        </p:nvSpPr>
+        <p:spPr>
+          <a:xfrm>
+            <a:off x="9921240" y="5440680"/>
+            <a:ext cx="1737360" cy="329184"/>
+          </a:xfrm>
+          <a:prstGeom prst="roundRect">
+            <a:avLst>
+              <a:gd name="adj" fmla="val 22222"/>
+            </a:avLst>
+          </a:prstGeom>
+          <a:solidFill>
+            <a:srgbClr val="0C66E4"/>
+          </a:solidFill>
+          <a:ln/>
+        </p:spPr>
+        <p:txBody>
+          <a:bodyPr wrap="square" lIns="0" tIns="0" rIns="0" bIns="0" rtlCol="0" anchor="ctr"/>
+          <a:lstStyle/>
+          <a:p>
+            <a:pPr algn="ctr" indent="0" marL="0">
+              <a:buNone/>
+            </a:pPr>
+            <a:r>
+              <a:rPr lang="en-US" sz="1200" b="1" dirty="0">
+                <a:solidFill>
+                  <a:srgbClr val="FFFFFF"/>
+                </a:solidFill>
+              </a:rPr>
+              <a:t>Jira: 23</a:t>
+            </a:r>
+            <a:endParaRPr lang="en-US" sz="1200" dirty="0"/>
+          </a:p>
+        </p:txBody>
+      </p:sp>
+      <p:sp>
+        <p:nvSpPr>
+          <p:cNvPr id="25" name="Slide Number Placeholder 0"/>
+          <p:cNvSpPr>
+            <a:spLocks noGrp="1"/>
+          </p:cNvSpPr>
+          <p:nvPr>
+            <p:ph type="sldNum" sz="quarter" idx="4294967295"/>
+          </p:nvPr>
+        </p:nvSpPr>
+        <p:spPr>
+          <a:xfrm>
+            <a:off x="11338560" y="6400800"/>
+            <a:ext cx="457200" cy="274320"/>
+          </a:xfrm>
+          <a:prstGeom prst="rect">
+            <a:avLst/>
+          </a:prstGeom>
+          <a:extLst>
+            <a:ext uri="{C572A759-6A51-4108-AA02-DFA0A04FC94B}">
+              <ma14:wrappingTextBoxFlag xmlns:ma14="http://schemas.microsoft.com/office/mac/drawingml/2011/main" val="0"/>
+            </a:ext>
+          </a:extLst>
+        </p:spPr>
+        <p:txBody>
+          <a:bodyPr/>
+          <a:lstStyle>
+            <a:lvl1pPr>
+              <a:defRPr sz="1000">
+                <a:solidFill>
+                  <a:schemeClr val="tx2"/>
+                </a:solidFill>
+              </a:defRPr>
+            </a:lvl1pPr>
+          </a:lstStyle>
+          <a:p>
+            <a:pPr algn="l"/>
+            <a:fld id="{F7021451-1387-4CA6-816F-3879F97B5CBC}" type="slidenum">
+              <a:rPr b="0" lang="en-US"/>
+              <a:t>12</a:t>
+            </a:fld>
+            <a:endParaRPr lang="en-US"/>
+          </a:p>
+        </p:txBody>
+      </p:sp>
+    </p:spTree>
+  </p:cSld>
+  <p:clrMapOvr>
+    <a:masterClrMapping/>
+  </p:clrMapOvr>
+</p:sld>
+</file>
+
+<file path=ppt/slides/slide13.xml><?xml version="1.0" encoding="utf-8"?>
+<p:sld xmlns:a="http://schemas.openxmlformats.org/drawingml/2006/main" xmlns:r="http://schemas.openxmlformats.org/officeDocument/2006/relationships" xmlns:p="http://schemas.openxmlformats.org/presentationml/2006/main">
+  <p:cSld name="Slide 13">
+    <p:spTree>
+      <p:nvGrpSpPr>
+        <p:cNvPr id="1" name=""/>
+        <p:cNvGrpSpPr/>
+        <p:nvPr/>
+      </p:nvGrpSpPr>
+      <p:grpSpPr>
+        <a:xfrm>
+          <a:off x="0" y="0"/>
+          <a:ext cx="0" cy="0"/>
+          <a:chOff x="0" y="0"/>
+          <a:chExt cx="0" cy="0"/>
+        </a:xfrm>
+      </p:grpSpPr>
+      <p:sp>
+        <p:nvSpPr>
+          <p:cNvPr id="2" name="Text 0"/>
+          <p:cNvSpPr/>
+          <p:nvPr>
+            <p:ph idx="100" type="title" hasCustomPrompt="1"/>
+          </p:nvPr>
+        </p:nvSpPr>
+        <p:spPr>
+          <a:xfrm>
             <a:off x="731520" y="2011680"/>
             <a:ext cx="10698480" cy="1280160"/>
           </a:xfrm>
@@ -4454,53 +4866,87 @@
                   <a:schemeClr val="tx1"/>
                 </a:solidFill>
               </a:rPr>
-              <a:t>Every service connected through MCP</a:t>
+              <a:t>Team and extra services</a:t>
             </a:r>
             <a:endParaRPr lang="en-US" sz="3600" dirty="0"/>
           </a:p>
         </p:txBody>
       </p:sp>
-      <p:pic>
-        <p:nvPicPr>
-          <p:cNvPr id="3" name="Claude Code /mcp screen showing github, linear, notion and claude.ai Gmail connected" descr="Claude Code /mcp screen showing github, linear, notion and claude.ai Gmail connected">    </p:cNvPr>
-          <p:cNvPicPr>
-            <a:picLocks noChangeAspect="1"/>
-          </p:cNvPicPr>
-          <p:nvPr/>
-        </p:nvPicPr>
-        <p:blipFill>
-          <a:blip r:embed="rId1"/>
-          <a:stretch>
-            <a:fillRect/>
-          </a:stretch>
-        </p:blipFill>
+      <p:sp>
+        <p:nvSpPr>
+          <p:cNvPr id="3" name="Abraham Gabay card"/>
+          <p:cNvSpPr/>
+          <p:nvPr/>
+        </p:nvSpPr>
         <p:spPr>
           <a:xfrm>
             <a:off x="457200" y="1463040"/>
-            <a:ext cx="6675120" cy="2601457"/>
-          </a:xfrm>
-          <a:prstGeom prst="rect">
-            <a:avLst/>
-          </a:prstGeom>
-          <a:effectLst>
-            <a:outerShdw sx="100000" sy="100000" kx="0" ky="0" algn="bl" rotWithShape="0" blurRad="101600" dist="25400" dir="5400000">
-              <a:srgbClr val="1B2433">
-                <a:alpha val="18000"/>
-              </a:srgbClr>
-            </a:outerShdw>
-          </a:effectLst>
-        </p:spPr>
-      </p:pic>
-      <p:sp>
-        <p:nvSpPr>
-          <p:cNvPr id="4" name="connection notes"/>
+            <a:ext cx="3566160" cy="4206240"/>
+          </a:xfrm>
+          <a:prstGeom prst="roundRect">
+            <a:avLst>
+              <a:gd name="adj" fmla="val 3077"/>
+            </a:avLst>
+          </a:prstGeom>
+          <a:solidFill>
+            <a:schemeClr val="bg2"/>
+          </a:solidFill>
+          <a:ln w="12700">
+            <a:solidFill>
+              <a:schemeClr val="bg2"/>
+            </a:solidFill>
+            <a:prstDash val="solid"/>
+          </a:ln>
+        </p:spPr>
+      </p:sp>
+      <p:sp>
+        <p:nvSpPr>
+          <p:cNvPr id="4" name="Abraham Gabay initials"/>
           <p:cNvSpPr txBox="1"/>
           <p:nvPr/>
         </p:nvSpPr>
         <p:spPr>
           <a:xfrm>
-            <a:off x="7589520" y="1463040"/>
-            <a:ext cx="4114800" cy="4572000"/>
+            <a:off x="777240" y="1737360"/>
+            <a:ext cx="731520" cy="731520"/>
+          </a:xfrm>
+          <a:prstGeom prst="ellipse">
+            <a:avLst/>
+          </a:prstGeom>
+          <a:solidFill>
+            <a:schemeClr val="tx1"/>
+          </a:solidFill>
+          <a:ln/>
+        </p:spPr>
+        <p:txBody>
+          <a:bodyPr wrap="square" lIns="0" tIns="0" rIns="0" bIns="0" rtlCol="0" anchor="ctr"/>
+          <a:lstStyle/>
+          <a:p>
+            <a:pPr algn="ctr" indent="0" marL="0">
+              <a:buNone/>
+            </a:pPr>
+            <a:r>
+              <a:rPr lang="en-US" sz="2000" b="1" dirty="0">
+                <a:solidFill>
+                  <a:schemeClr val="accent1"/>
+                </a:solidFill>
+              </a:rPr>
+              <a:t>AG</a:t>
+            </a:r>
+            <a:endParaRPr lang="en-US" sz="2000" dirty="0"/>
+          </a:p>
+        </p:txBody>
+      </p:sp>
+      <p:sp>
+        <p:nvSpPr>
+          <p:cNvPr id="5" name="Abraham Gabay name"/>
+          <p:cNvSpPr txBox="1"/>
+          <p:nvPr/>
+        </p:nvSpPr>
+        <p:spPr>
+          <a:xfrm>
+            <a:off x="777240" y="2651760"/>
+            <a:ext cx="2926080" cy="457200"/>
           </a:xfrm>
           <a:prstGeom prst="rect">
             <a:avLst/>
@@ -4509,105 +4955,571 @@
           <a:ln/>
         </p:spPr>
         <p:txBody>
+          <a:bodyPr wrap="square" lIns="0" tIns="0" rIns="0" bIns="0" rtlCol="0" anchor="ctr"/>
+          <a:lstStyle/>
+          <a:p>
+            <a:pPr indent="0" marL="0">
+              <a:buNone/>
+            </a:pPr>
+            <a:r>
+              <a:rPr lang="en-US" sz="2200" b="1" dirty="0">
+                <a:solidFill>
+                  <a:schemeClr val="tx1"/>
+                </a:solidFill>
+              </a:rPr>
+              <a:t>Abraham Gabay</a:t>
+            </a:r>
+            <a:endParaRPr lang="en-US" sz="2200" dirty="0"/>
+          </a:p>
+        </p:txBody>
+      </p:sp>
+      <p:sp>
+        <p:nvSpPr>
+          <p:cNvPr id="6" name="label Extra service: Linear"/>
+          <p:cNvSpPr txBox="1"/>
+          <p:nvPr/>
+        </p:nvSpPr>
+        <p:spPr>
+          <a:xfrm>
+            <a:off x="777240" y="3200400"/>
+            <a:ext cx="2377440" cy="329184"/>
+          </a:xfrm>
+          <a:prstGeom prst="roundRect">
+            <a:avLst>
+              <a:gd name="adj" fmla="val 22222"/>
+            </a:avLst>
+          </a:prstGeom>
+          <a:solidFill>
+            <a:srgbClr val="5E6AD2"/>
+          </a:solidFill>
+          <a:ln/>
+        </p:spPr>
+        <p:txBody>
+          <a:bodyPr wrap="square" lIns="0" tIns="0" rIns="0" bIns="0" rtlCol="0" anchor="ctr"/>
+          <a:lstStyle/>
+          <a:p>
+            <a:pPr algn="ctr" indent="0" marL="0">
+              <a:buNone/>
+            </a:pPr>
+            <a:r>
+              <a:rPr lang="en-US" sz="1200" b="1" dirty="0">
+                <a:solidFill>
+                  <a:srgbClr val="FFFFFF"/>
+                </a:solidFill>
+              </a:rPr>
+              <a:t>Extra service: Linear</a:t>
+            </a:r>
+            <a:endParaRPr lang="en-US" sz="1200" dirty="0"/>
+          </a:p>
+        </p:txBody>
+      </p:sp>
+      <p:sp>
+        <p:nvSpPr>
+          <p:cNvPr id="7" name="Abraham Gabay tasks"/>
+          <p:cNvSpPr txBox="1"/>
+          <p:nvPr/>
+        </p:nvSpPr>
+        <p:spPr>
+          <a:xfrm>
+            <a:off x="777240" y="3749040"/>
+            <a:ext cx="2971800" cy="1737360"/>
+          </a:xfrm>
+          <a:prstGeom prst="rect">
+            <a:avLst/>
+          </a:prstGeom>
+          <a:noFill/>
+          <a:ln/>
+        </p:spPr>
+        <p:txBody>
           <a:bodyPr wrap="square" lIns="0" tIns="0" rIns="0" bIns="0" rtlCol="0" anchor="t"/>
           <a:lstStyle/>
           <a:p>
+            <a:pPr marL="342900" indent="-342900">
+              <a:spcAft>
+                <a:spcPts val="600"/>
+              </a:spcAft>
+              <a:buSzPct val="100000"/>
+              <a:buChar char="•"/>
+            </a:pPr>
+            <a:r>
+              <a:rPr lang="en-US" sz="1500" dirty="0">
+                <a:solidFill>
+                  <a:schemeClr val="tx2"/>
+                </a:solidFill>
+              </a:rPr>
+              <a:t>GitHub repo setup</a:t>
+            </a:r>
+            <a:endParaRPr lang="en-US" sz="1500" dirty="0"/>
+          </a:p>
+          <a:p>
+            <a:pPr marL="342900" indent="-342900">
+              <a:spcAft>
+                <a:spcPts val="600"/>
+              </a:spcAft>
+              <a:buSzPct val="100000"/>
+              <a:buChar char="•"/>
+            </a:pPr>
+            <a:r>
+              <a:rPr lang="en-US" sz="1500" dirty="0">
+                <a:solidFill>
+                  <a:schemeClr val="tx2"/>
+                </a:solidFill>
+              </a:rPr>
+              <a:t>Gmail, GitHub and Notion connections and test data</a:t>
+            </a:r>
+            <a:endParaRPr lang="en-US" sz="1500" dirty="0"/>
+          </a:p>
+          <a:p>
+            <a:pPr marL="342900" indent="-342900">
+              <a:spcAft>
+                <a:spcPts val="600"/>
+              </a:spcAft>
+              <a:buSzPct val="100000"/>
+              <a:buChar char="•"/>
+            </a:pPr>
+            <a:r>
+              <a:rPr lang="en-US" sz="1500" dirty="0">
+                <a:solidFill>
+                  <a:schemeClr val="tx2"/>
+                </a:solidFill>
+              </a:rPr>
+              <a:t>Demo video</a:t>
+            </a:r>
+            <a:endParaRPr lang="en-US" sz="1500" dirty="0"/>
+          </a:p>
+        </p:txBody>
+      </p:sp>
+      <p:sp>
+        <p:nvSpPr>
+          <p:cNvPr id="8" name="Joel Aserraf card"/>
+          <p:cNvSpPr/>
+          <p:nvPr/>
+        </p:nvSpPr>
+        <p:spPr>
+          <a:xfrm>
+            <a:off x="4251960" y="1463040"/>
+            <a:ext cx="3566160" cy="4206240"/>
+          </a:xfrm>
+          <a:prstGeom prst="roundRect">
+            <a:avLst>
+              <a:gd name="adj" fmla="val 3077"/>
+            </a:avLst>
+          </a:prstGeom>
+          <a:solidFill>
+            <a:schemeClr val="bg2"/>
+          </a:solidFill>
+          <a:ln w="12700">
+            <a:solidFill>
+              <a:schemeClr val="bg2"/>
+            </a:solidFill>
+            <a:prstDash val="solid"/>
+          </a:ln>
+        </p:spPr>
+      </p:sp>
+      <p:sp>
+        <p:nvSpPr>
+          <p:cNvPr id="9" name="Joel Aserraf initials"/>
+          <p:cNvSpPr txBox="1"/>
+          <p:nvPr/>
+        </p:nvSpPr>
+        <p:spPr>
+          <a:xfrm>
+            <a:off x="4572000" y="1737360"/>
+            <a:ext cx="731520" cy="731520"/>
+          </a:xfrm>
+          <a:prstGeom prst="ellipse">
+            <a:avLst/>
+          </a:prstGeom>
+          <a:solidFill>
+            <a:schemeClr val="tx1"/>
+          </a:solidFill>
+          <a:ln/>
+        </p:spPr>
+        <p:txBody>
+          <a:bodyPr wrap="square" lIns="0" tIns="0" rIns="0" bIns="0" rtlCol="0" anchor="ctr"/>
+          <a:lstStyle/>
+          <a:p>
+            <a:pPr algn="ctr" indent="0" marL="0">
+              <a:buNone/>
+            </a:pPr>
+            <a:r>
+              <a:rPr lang="en-US" sz="2000" b="1" dirty="0">
+                <a:solidFill>
+                  <a:schemeClr val="accent1"/>
+                </a:solidFill>
+              </a:rPr>
+              <a:t>JA</a:t>
+            </a:r>
+            <a:endParaRPr lang="en-US" sz="2000" dirty="0"/>
+          </a:p>
+        </p:txBody>
+      </p:sp>
+      <p:sp>
+        <p:nvSpPr>
+          <p:cNvPr id="10" name="Joel Aserraf name"/>
+          <p:cNvSpPr txBox="1"/>
+          <p:nvPr/>
+        </p:nvSpPr>
+        <p:spPr>
+          <a:xfrm>
+            <a:off x="4572000" y="2651760"/>
+            <a:ext cx="2926080" cy="457200"/>
+          </a:xfrm>
+          <a:prstGeom prst="rect">
+            <a:avLst/>
+          </a:prstGeom>
+          <a:noFill/>
+          <a:ln/>
+        </p:spPr>
+        <p:txBody>
+          <a:bodyPr wrap="square" lIns="0" tIns="0" rIns="0" bIns="0" rtlCol="0" anchor="ctr"/>
+          <a:lstStyle/>
+          <a:p>
             <a:pPr indent="0" marL="0">
               <a:buNone/>
             </a:pPr>
             <a:r>
-              <a:rPr lang="en-US" sz="1500" b="1" dirty="0">
+              <a:rPr lang="en-US" sz="2200" b="1" dirty="0">
                 <a:solidFill>
                   <a:schemeClr val="tx1"/>
                 </a:solidFill>
               </a:rPr>
-              <a:t>GitHub, Notion, Linear, Todoist, Jira</a:t>
+              <a:t>Joel Aserraf</a:t>
+            </a:r>
+            <a:endParaRPr lang="en-US" sz="2200" dirty="0"/>
+          </a:p>
+        </p:txBody>
+      </p:sp>
+      <p:sp>
+        <p:nvSpPr>
+          <p:cNvPr id="11" name="label Extra service: Todoist"/>
+          <p:cNvSpPr txBox="1"/>
+          <p:nvPr/>
+        </p:nvSpPr>
+        <p:spPr>
+          <a:xfrm>
+            <a:off x="4572000" y="3200400"/>
+            <a:ext cx="2377440" cy="329184"/>
+          </a:xfrm>
+          <a:prstGeom prst="roundRect">
+            <a:avLst>
+              <a:gd name="adj" fmla="val 22222"/>
+            </a:avLst>
+          </a:prstGeom>
+          <a:solidFill>
+            <a:srgbClr val="C2410C"/>
+          </a:solidFill>
+          <a:ln/>
+        </p:spPr>
+        <p:txBody>
+          <a:bodyPr wrap="square" lIns="0" tIns="0" rIns="0" bIns="0" rtlCol="0" anchor="ctr"/>
+          <a:lstStyle/>
+          <a:p>
+            <a:pPr algn="ctr" indent="0" marL="0">
+              <a:buNone/>
+            </a:pPr>
+            <a:r>
+              <a:rPr lang="en-US" sz="1200" b="1" dirty="0">
+                <a:solidFill>
+                  <a:srgbClr val="FFFFFF"/>
+                </a:solidFill>
+              </a:rPr>
+              <a:t>Extra service: Todoist</a:t>
+            </a:r>
+            <a:endParaRPr lang="en-US" sz="1200" dirty="0"/>
+          </a:p>
+        </p:txBody>
+      </p:sp>
+      <p:sp>
+        <p:nvSpPr>
+          <p:cNvPr id="12" name="Joel Aserraf tasks"/>
+          <p:cNvSpPr txBox="1"/>
+          <p:nvPr/>
+        </p:nvSpPr>
+        <p:spPr>
+          <a:xfrm>
+            <a:off x="4572000" y="3749040"/>
+            <a:ext cx="2971800" cy="1737360"/>
+          </a:xfrm>
+          <a:prstGeom prst="rect">
+            <a:avLst/>
+          </a:prstGeom>
+          <a:noFill/>
+          <a:ln/>
+        </p:spPr>
+        <p:txBody>
+          <a:bodyPr wrap="square" lIns="0" tIns="0" rIns="0" bIns="0" rtlCol="0" anchor="t"/>
+          <a:lstStyle/>
+          <a:p>
+            <a:pPr marL="342900" indent="-342900">
+              <a:spcAft>
+                <a:spcPts val="600"/>
+              </a:spcAft>
+              <a:buSzPct val="100000"/>
+              <a:buChar char="•"/>
+            </a:pPr>
+            <a:r>
+              <a:rPr lang="en-US" sz="1500" dirty="0">
+                <a:solidFill>
+                  <a:schemeClr val="tx2"/>
+                </a:solidFill>
+              </a:rPr>
+              <a:t>localStorageFormats.md</a:t>
             </a:r>
             <a:endParaRPr lang="en-US" sz="1500" dirty="0"/>
           </a:p>
           <a:p>
+            <a:pPr marL="342900" indent="-342900">
+              <a:spcAft>
+                <a:spcPts val="600"/>
+              </a:spcAft>
+              <a:buSzPct val="100000"/>
+              <a:buChar char="•"/>
+            </a:pPr>
+            <a:r>
+              <a:rPr lang="en-US" sz="1500" dirty="0">
+                <a:solidFill>
+                  <a:schemeClr val="tx2"/>
+                </a:solidFill>
+              </a:rPr>
+              <a:t>Export skill (.claude/skills)</a:t>
+            </a:r>
+            <a:endParaRPr lang="en-US" sz="1500" dirty="0"/>
+          </a:p>
+        </p:txBody>
+      </p:sp>
+      <p:sp>
+        <p:nvSpPr>
+          <p:cNvPr id="13" name="Marco Foununu card"/>
+          <p:cNvSpPr/>
+          <p:nvPr/>
+        </p:nvSpPr>
+        <p:spPr>
+          <a:xfrm>
+            <a:off x="8046720" y="1463040"/>
+            <a:ext cx="3566160" cy="4206240"/>
+          </a:xfrm>
+          <a:prstGeom prst="roundRect">
+            <a:avLst>
+              <a:gd name="adj" fmla="val 3077"/>
+            </a:avLst>
+          </a:prstGeom>
+          <a:solidFill>
+            <a:schemeClr val="bg2"/>
+          </a:solidFill>
+          <a:ln w="12700">
+            <a:solidFill>
+              <a:schemeClr val="bg2"/>
+            </a:solidFill>
+            <a:prstDash val="solid"/>
+          </a:ln>
+        </p:spPr>
+      </p:sp>
+      <p:sp>
+        <p:nvSpPr>
+          <p:cNvPr id="14" name="Marco Foununu initials"/>
+          <p:cNvSpPr txBox="1"/>
+          <p:nvPr/>
+        </p:nvSpPr>
+        <p:spPr>
+          <a:xfrm>
+            <a:off x="8366760" y="1737360"/>
+            <a:ext cx="731520" cy="731520"/>
+          </a:xfrm>
+          <a:prstGeom prst="ellipse">
+            <a:avLst/>
+          </a:prstGeom>
+          <a:solidFill>
+            <a:schemeClr val="tx1"/>
+          </a:solidFill>
+          <a:ln/>
+        </p:spPr>
+        <p:txBody>
+          <a:bodyPr wrap="square" lIns="0" tIns="0" rIns="0" bIns="0" rtlCol="0" anchor="ctr"/>
+          <a:lstStyle/>
+          <a:p>
+            <a:pPr algn="ctr" indent="0" marL="0">
+              <a:buNone/>
+            </a:pPr>
+            <a:r>
+              <a:rPr lang="en-US" sz="2000" b="1" dirty="0">
+                <a:solidFill>
+                  <a:schemeClr val="accent1"/>
+                </a:solidFill>
+              </a:rPr>
+              <a:t>MF</a:t>
+            </a:r>
+            <a:endParaRPr lang="en-US" sz="2000" dirty="0"/>
+          </a:p>
+        </p:txBody>
+      </p:sp>
+      <p:sp>
+        <p:nvSpPr>
+          <p:cNvPr id="15" name="Marco Foununu name"/>
+          <p:cNvSpPr txBox="1"/>
+          <p:nvPr/>
+        </p:nvSpPr>
+        <p:spPr>
+          <a:xfrm>
+            <a:off x="8366760" y="2651760"/>
+            <a:ext cx="2926080" cy="457200"/>
+          </a:xfrm>
+          <a:prstGeom prst="rect">
+            <a:avLst/>
+          </a:prstGeom>
+          <a:noFill/>
+          <a:ln/>
+        </p:spPr>
+        <p:txBody>
+          <a:bodyPr wrap="square" lIns="0" tIns="0" rIns="0" bIns="0" rtlCol="0" anchor="ctr"/>
+          <a:lstStyle/>
+          <a:p>
             <a:pPr indent="0" marL="0">
               <a:buNone/>
             </a:pPr>
             <a:r>
+              <a:rPr lang="en-US" sz="2200" b="1" dirty="0">
+                <a:solidFill>
+                  <a:schemeClr val="tx1"/>
+                </a:solidFill>
+              </a:rPr>
+              <a:t>Marco Foununu</a:t>
+            </a:r>
+            <a:endParaRPr lang="en-US" sz="2200" dirty="0"/>
+          </a:p>
+        </p:txBody>
+      </p:sp>
+      <p:sp>
+        <p:nvSpPr>
+          <p:cNvPr id="16" name="label Extra service: Jira"/>
+          <p:cNvSpPr txBox="1"/>
+          <p:nvPr/>
+        </p:nvSpPr>
+        <p:spPr>
+          <a:xfrm>
+            <a:off x="8366760" y="3200400"/>
+            <a:ext cx="2377440" cy="329184"/>
+          </a:xfrm>
+          <a:prstGeom prst="roundRect">
+            <a:avLst>
+              <a:gd name="adj" fmla="val 22222"/>
+            </a:avLst>
+          </a:prstGeom>
+          <a:solidFill>
+            <a:srgbClr val="0C66E4"/>
+          </a:solidFill>
+          <a:ln/>
+        </p:spPr>
+        <p:txBody>
+          <a:bodyPr wrap="square" lIns="0" tIns="0" rIns="0" bIns="0" rtlCol="0" anchor="ctr"/>
+          <a:lstStyle/>
+          <a:p>
+            <a:pPr algn="ctr" indent="0" marL="0">
+              <a:buNone/>
+            </a:pPr>
+            <a:r>
+              <a:rPr lang="en-US" sz="1200" b="1" dirty="0">
+                <a:solidFill>
+                  <a:srgbClr val="FFFFFF"/>
+                </a:solidFill>
+              </a:rPr>
+              <a:t>Extra service: Jira</a:t>
+            </a:r>
+            <a:endParaRPr lang="en-US" sz="1200" dirty="0"/>
+          </a:p>
+        </p:txBody>
+      </p:sp>
+      <p:sp>
+        <p:nvSpPr>
+          <p:cNvPr id="17" name="Marco Foununu tasks"/>
+          <p:cNvSpPr txBox="1"/>
+          <p:nvPr/>
+        </p:nvSpPr>
+        <p:spPr>
+          <a:xfrm>
+            <a:off x="8366760" y="3749040"/>
+            <a:ext cx="2971800" cy="1737360"/>
+          </a:xfrm>
+          <a:prstGeom prst="rect">
+            <a:avLst/>
+          </a:prstGeom>
+          <a:noFill/>
+          <a:ln/>
+        </p:spPr>
+        <p:txBody>
+          <a:bodyPr wrap="square" lIns="0" tIns="0" rIns="0" bIns="0" rtlCol="0" anchor="t"/>
+          <a:lstStyle/>
+          <a:p>
+            <a:pPr marL="342900" indent="-342900">
+              <a:spcAft>
+                <a:spcPts val="600"/>
+              </a:spcAft>
+              <a:buSzPct val="100000"/>
+              <a:buChar char="•"/>
+            </a:pPr>
+            <a:r>
               <a:rPr lang="en-US" sz="1500" dirty="0">
                 <a:solidFill>
                   <a:schemeClr val="tx2"/>
                 </a:solidFill>
               </a:rPr>
-              <a:t>Vendor-hosted official MCP servers, saved in .mcp.json. GitHub's token comes from an environment variable; the others sign in with OAuth in the browser.</a:t>
+              <a:t>Dashboard website</a:t>
             </a:r>
             <a:endParaRPr lang="en-US" sz="1500" dirty="0"/>
           </a:p>
           <a:p>
+            <a:pPr marL="342900" indent="-342900">
+              <a:spcAft>
+                <a:spcPts val="600"/>
+              </a:spcAft>
+              <a:buSzPct val="100000"/>
+              <a:buChar char="•"/>
+            </a:pPr>
+            <a:r>
+              <a:rPr lang="en-US" sz="1500" dirty="0">
+                <a:solidFill>
+                  <a:schemeClr val="tx2"/>
+                </a:solidFill>
+              </a:rPr>
+              <a:t>Screenshots and presentation</a:t>
+            </a:r>
+            <a:endParaRPr lang="en-US" sz="1500" dirty="0"/>
+          </a:p>
+        </p:txBody>
+      </p:sp>
+      <p:sp>
+        <p:nvSpPr>
+          <p:cNvPr id="18" name="team note"/>
+          <p:cNvSpPr txBox="1"/>
+          <p:nvPr/>
+        </p:nvSpPr>
+        <p:spPr>
+          <a:xfrm>
+            <a:off x="457200" y="5852160"/>
+            <a:ext cx="11247120" cy="411480"/>
+          </a:xfrm>
+          <a:prstGeom prst="rect">
+            <a:avLst/>
+          </a:prstGeom>
+          <a:noFill/>
+          <a:ln/>
+        </p:spPr>
+        <p:txBody>
+          <a:bodyPr wrap="square" lIns="0" tIns="0" rIns="0" bIns="0" rtlCol="0" anchor="ctr"/>
+          <a:lstStyle/>
+          <a:p>
             <a:pPr indent="0" marL="0">
               <a:buNone/>
             </a:pPr>
             <a:r>
-              <a:rPr lang="en-US" sz="800" dirty="0">
+              <a:rPr lang="en-US" sz="1400" i="1" dirty="0">
                 <a:solidFill>
                   <a:schemeClr val="tx2"/>
                 </a:solidFill>
               </a:rPr>
-              <a:t> </a:t>
-            </a:r>
-            <a:endParaRPr lang="en-US" sz="1500" dirty="0"/>
-          </a:p>
-          <a:p>
-            <a:pPr indent="0" marL="0">
-              <a:buNone/>
-            </a:pPr>
-            <a:r>
-              <a:rPr lang="en-US" sz="1500" b="1" dirty="0">
-                <a:solidFill>
-                  <a:schemeClr val="tx1"/>
-                </a:solidFill>
-              </a:rPr>
-              <a:t>Gmail</a:t>
-            </a:r>
-            <a:endParaRPr lang="en-US" sz="1500" dirty="0"/>
-          </a:p>
-          <a:p>
-            <a:pPr indent="0" marL="0">
-              <a:buNone/>
-            </a:pPr>
-            <a:r>
-              <a:rPr lang="en-US" sz="1500" dirty="0">
-                <a:solidFill>
-                  <a:schemeClr val="tx2"/>
-                </a:solidFill>
-              </a:rPr>
-              <a:t>Google's official Gmail MCP server (gmailmcp.googleapis.com), reached through the claude.ai Gmail connector. Google's preview program blocks custom OAuth clients for personal Gmail accounts.</a:t>
-            </a:r>
-            <a:endParaRPr lang="en-US" sz="1500" dirty="0"/>
-          </a:p>
-          <a:p>
-            <a:pPr indent="0" marL="0">
-              <a:buNone/>
-            </a:pPr>
-            <a:r>
-              <a:rPr lang="en-US" sz="800" dirty="0">
-                <a:solidFill>
-                  <a:schemeClr val="tx2"/>
-                </a:solidFill>
-              </a:rPr>
-              <a:t> </a:t>
-            </a:r>
-            <a:endParaRPr lang="en-US" sz="1500" dirty="0"/>
-          </a:p>
-          <a:p>
-            <a:pPr indent="0" marL="0">
-              <a:buNone/>
-            </a:pPr>
-            <a:r>
-              <a:rPr lang="en-US" sz="1500" b="1" dirty="0">
-                <a:solidFill>
-                  <a:schemeClr val="accent6"/>
-                </a:solidFill>
-              </a:rPr>
-              <a:t>No passwords or keys are in the repo.</a:t>
-            </a:r>
-            <a:endParaRPr lang="en-US" sz="1500" dirty="0"/>
+              <a:t>We worked together on one shared computer and one set of test accounts, helping each other throughout.</a:t>
+            </a:r>
+            <a:endParaRPr lang="en-US" sz="1400" dirty="0"/>
           </a:p>
         </p:txBody>
       </p:sp>
@@ -4713,95 +5625,15 @@
                   <a:schemeClr val="tx1"/>
                 </a:solidFill>
               </a:rPr>
-              <a:t>Gmail: original vs dashboard</a:t>
+              <a:t>Every service connected through MCP</a:t>
             </a:r>
             <a:endParaRPr lang="en-US" sz="3600" dirty="0"/>
-          </a:p>
-        </p:txBody>
-      </p:sp>
-      <p:sp>
-        <p:nvSpPr>
-          <p:cNvPr id="3" name="label Original in Gmail"/>
-          <p:cNvSpPr txBox="1"/>
-          <p:nvPr/>
-        </p:nvSpPr>
-        <p:spPr>
-          <a:xfrm>
-            <a:off x="457200" y="1280160"/>
-            <a:ext cx="2377440" cy="329184"/>
-          </a:xfrm>
-          <a:prstGeom prst="roundRect">
-            <a:avLst>
-              <a:gd name="adj" fmla="val 22222"/>
-            </a:avLst>
-          </a:prstGeom>
-          <a:solidFill>
-            <a:srgbClr val="D93025"/>
-          </a:solidFill>
-          <a:ln/>
-        </p:spPr>
-        <p:txBody>
-          <a:bodyPr wrap="square" lIns="0" tIns="0" rIns="0" bIns="0" rtlCol="0" anchor="ctr"/>
-          <a:lstStyle/>
-          <a:p>
-            <a:pPr algn="ctr" indent="0" marL="0">
-              <a:buNone/>
-            </a:pPr>
-            <a:r>
-              <a:rPr lang="en-US" sz="1200" b="1" dirty="0">
-                <a:solidFill>
-                  <a:srgbClr val="FFFFFF"/>
-                </a:solidFill>
-              </a:rPr>
-              <a:t>Original in Gmail</a:t>
-            </a:r>
-            <a:endParaRPr lang="en-US" sz="1200" dirty="0"/>
-          </a:p>
-        </p:txBody>
-      </p:sp>
-      <p:sp>
-        <p:nvSpPr>
-          <p:cNvPr id="4" name="label In the dashboard"/>
-          <p:cNvSpPr txBox="1"/>
-          <p:nvPr/>
-        </p:nvSpPr>
-        <p:spPr>
-          <a:xfrm>
-            <a:off x="7223760" y="1280160"/>
-            <a:ext cx="2377440" cy="329184"/>
-          </a:xfrm>
-          <a:prstGeom prst="roundRect">
-            <a:avLst>
-              <a:gd name="adj" fmla="val 22222"/>
-            </a:avLst>
-          </a:prstGeom>
-          <a:solidFill>
-            <a:schemeClr val="tx1"/>
-          </a:solidFill>
-          <a:ln/>
-        </p:spPr>
-        <p:txBody>
-          <a:bodyPr wrap="square" lIns="0" tIns="0" rIns="0" bIns="0" rtlCol="0" anchor="ctr"/>
-          <a:lstStyle/>
-          <a:p>
-            <a:pPr algn="ctr" indent="0" marL="0">
-              <a:buNone/>
-            </a:pPr>
-            <a:r>
-              <a:rPr lang="en-US" sz="1200" b="1" dirty="0">
-                <a:solidFill>
-                  <a:srgbClr val="FFFFFF"/>
-                </a:solidFill>
-              </a:rPr>
-              <a:t>In the dashboard</a:t>
-            </a:r>
-            <a:endParaRPr lang="en-US" sz="1200" dirty="0"/>
           </a:p>
         </p:txBody>
       </p:sp>
       <p:pic>
         <p:nvPicPr>
-          <p:cNvPr id="5" name="Original Gmail content" descr="Original Gmail content">    </p:cNvPr>
+          <p:cNvPr id="3" name="Claude Code /mcp screen showing github, linear, notion and claude.ai Gmail connected" descr="Claude Code /mcp screen showing github, linear, notion and claude.ai Gmail connected">    </p:cNvPr>
           <p:cNvPicPr>
             <a:picLocks noChangeAspect="1"/>
           </p:cNvPicPr>
@@ -4815,8 +5647,8 @@
         </p:blipFill>
         <p:spPr>
           <a:xfrm>
-            <a:off x="457200" y="1783080"/>
-            <a:ext cx="6400800" cy="3398121"/>
+            <a:off x="457200" y="1463040"/>
+            <a:ext cx="6675120" cy="2601457"/>
           </a:xfrm>
           <a:prstGeom prst="rect">
             <a:avLst/>
@@ -4830,47 +5662,16 @@
           </a:effectLst>
         </p:spPr>
       </p:pic>
-      <p:pic>
-        <p:nvPicPr>
-          <p:cNvPr id="6" name="Gmail item opened in the dashboard" descr="Gmail item opened in the dashboard">    </p:cNvPr>
-          <p:cNvPicPr>
-            <a:picLocks noChangeAspect="1"/>
-          </p:cNvPicPr>
-          <p:nvPr/>
-        </p:nvPicPr>
-        <p:blipFill>
-          <a:blip r:embed="rId2"/>
-          <a:stretch>
-            <a:fillRect/>
-          </a:stretch>
-        </p:blipFill>
-        <p:spPr>
-          <a:xfrm>
-            <a:off x="7223760" y="1783080"/>
-            <a:ext cx="4363537" cy="4526280"/>
-          </a:xfrm>
-          <a:prstGeom prst="rect">
-            <a:avLst/>
-          </a:prstGeom>
-          <a:effectLst>
-            <a:outerShdw sx="100000" sy="100000" kx="0" ky="0" algn="bl" rotWithShape="0" blurRad="101600" dist="25400" dir="5400000">
-              <a:srgbClr val="1B2433">
-                <a:alpha val="18000"/>
-              </a:srgbClr>
-            </a:outerShdw>
-          </a:effectLst>
-        </p:spPr>
-      </p:pic>
-      <p:sp>
-        <p:nvSpPr>
-          <p:cNvPr id="7" name="Gmail caption"/>
+      <p:sp>
+        <p:nvSpPr>
+          <p:cNvPr id="4" name="connection notes"/>
           <p:cNvSpPr txBox="1"/>
           <p:nvPr/>
         </p:nvSpPr>
         <p:spPr>
           <a:xfrm>
-            <a:off x="457200" y="5455521"/>
-            <a:ext cx="6400800" cy="899559"/>
+            <a:off x="7589520" y="1463040"/>
+            <a:ext cx="4114800" cy="4572000"/>
           </a:xfrm>
           <a:prstGeom prst="rect">
             <a:avLst/>
@@ -4886,50 +5687,98 @@
               <a:buNone/>
             </a:pPr>
             <a:r>
-              <a:rPr lang="en-US" sz="1300" b="1" dirty="0">
+              <a:rPr lang="en-US" sz="1500" b="1" dirty="0">
                 <a:solidFill>
                   <a:schemeClr val="tx1"/>
                 </a:solidFill>
               </a:rPr>
-              <a:t>Item: </a:t>
-            </a:r>
+              <a:t>GitHub, Notion, Linear, Todoist, Jira</a:t>
+            </a:r>
+            <a:endParaRPr lang="en-US" sz="1500" dirty="0"/>
+          </a:p>
+          <a:p>
             <a:pPr indent="0" marL="0">
               <a:buNone/>
             </a:pPr>
             <a:r>
-              <a:rPr lang="en-US" sz="1300" dirty="0">
+              <a:rPr lang="en-US" sz="1500" dirty="0">
                 <a:solidFill>
                   <a:schemeClr val="tx2"/>
                 </a:solidFill>
               </a:rPr>
-              <a:t>Email “Project Atlas kickoff recap”</a:t>
-            </a:r>
-            <a:endParaRPr lang="en-US" sz="1300" dirty="0"/>
+              <a:t>Vendor-hosted official MCP servers, saved in .mcp.json. GitHub's token comes from an environment variable; the others sign in with OAuth in the browser.</a:t>
+            </a:r>
+            <a:endParaRPr lang="en-US" sz="1500" dirty="0"/>
           </a:p>
           <a:p>
             <a:pPr indent="0" marL="0">
               <a:buNone/>
             </a:pPr>
             <a:r>
-              <a:rPr lang="en-US" sz="1300" b="1" dirty="0">
+              <a:rPr lang="en-US" sz="800" dirty="0">
+                <a:solidFill>
+                  <a:schemeClr val="tx2"/>
+                </a:solidFill>
+              </a:rPr>
+              <a:t> </a:t>
+            </a:r>
+            <a:endParaRPr lang="en-US" sz="1500" dirty="0"/>
+          </a:p>
+          <a:p>
+            <a:pPr indent="0" marL="0">
+              <a:buNone/>
+            </a:pPr>
+            <a:r>
+              <a:rPr lang="en-US" sz="1500" b="1" dirty="0">
                 <a:solidFill>
                   <a:schemeClr val="tx1"/>
                 </a:solidFill>
               </a:rPr>
-              <a:t>Saved as: </a:t>
-            </a:r>
+              <a:t>Gmail</a:t>
+            </a:r>
+            <a:endParaRPr lang="en-US" sz="1500" dirty="0"/>
+          </a:p>
+          <a:p>
             <a:pPr indent="0" marL="0">
               <a:buNone/>
             </a:pPr>
             <a:r>
-              <a:rPr lang="en-US" sz="1300" dirty="0">
+              <a:rPr lang="en-US" sz="1500" dirty="0">
                 <a:solidFill>
                   <a:schemeClr val="tx2"/>
                 </a:solidFill>
               </a:rPr>
-              <a:t>dataExports/gmail/2026-10-15_23-44-19_ecf43b32.json</a:t>
-            </a:r>
-            <a:endParaRPr lang="en-US" sz="1300" dirty="0"/>
+              <a:t>Google's official Gmail MCP server (gmailmcp.googleapis.com), reached through the claude.ai Gmail connector. Google's preview program blocks custom OAuth clients for personal Gmail accounts.</a:t>
+            </a:r>
+            <a:endParaRPr lang="en-US" sz="1500" dirty="0"/>
+          </a:p>
+          <a:p>
+            <a:pPr indent="0" marL="0">
+              <a:buNone/>
+            </a:pPr>
+            <a:r>
+              <a:rPr lang="en-US" sz="800" dirty="0">
+                <a:solidFill>
+                  <a:schemeClr val="tx2"/>
+                </a:solidFill>
+              </a:rPr>
+              <a:t> </a:t>
+            </a:r>
+            <a:endParaRPr lang="en-US" sz="1500" dirty="0"/>
+          </a:p>
+          <a:p>
+            <a:pPr indent="0" marL="0">
+              <a:buNone/>
+            </a:pPr>
+            <a:r>
+              <a:rPr lang="en-US" sz="1500" b="1" dirty="0">
+                <a:solidFill>
+                  <a:schemeClr val="accent6"/>
+                </a:solidFill>
+              </a:rPr>
+              <a:t>No passwords or keys are in the repo.</a:t>
+            </a:r>
+            <a:endParaRPr lang="en-US" sz="1500" dirty="0"/>
           </a:p>
         </p:txBody>
       </p:sp>
@@ -5035,7 +5884,7 @@
                   <a:schemeClr val="tx1"/>
                 </a:solidFill>
               </a:rPr>
-              <a:t>GitHub: original vs dashboard</a:t>
+              <a:t>Gmail: original vs dashboard</a:t>
             </a:r>
             <a:endParaRPr lang="en-US" sz="3600" dirty="0"/>
           </a:p>
@@ -5043,7 +5892,7 @@
       </p:sp>
       <p:sp>
         <p:nvSpPr>
-          <p:cNvPr id="3" name="label Original in GitHub"/>
+          <p:cNvPr id="3" name="label Original in Gmail"/>
           <p:cNvSpPr txBox="1"/>
           <p:nvPr/>
         </p:nvSpPr>
@@ -5058,7 +5907,7 @@
             </a:avLst>
           </a:prstGeom>
           <a:solidFill>
-            <a:srgbClr val="24292F"/>
+            <a:srgbClr val="D93025"/>
           </a:solidFill>
           <a:ln/>
         </p:spPr>
@@ -5075,7 +5924,7 @@
                   <a:srgbClr val="FFFFFF"/>
                 </a:solidFill>
               </a:rPr>
-              <a:t>Original in GitHub</a:t>
+              <a:t>Original in Gmail</a:t>
             </a:r>
             <a:endParaRPr lang="en-US" sz="1200" dirty="0"/>
           </a:p>
@@ -5123,7 +5972,7 @@
       </p:sp>
       <p:pic>
         <p:nvPicPr>
-          <p:cNvPr id="5" name="Original GitHub content" descr="Original GitHub content">    </p:cNvPr>
+          <p:cNvPr id="5" name="Original Gmail content" descr="Original Gmail content">    </p:cNvPr>
           <p:cNvPicPr>
             <a:picLocks noChangeAspect="1"/>
           </p:cNvPicPr>
@@ -5138,7 +5987,7 @@
         <p:spPr>
           <a:xfrm>
             <a:off x="457200" y="1783080"/>
-            <a:ext cx="6400800" cy="3613785"/>
+            <a:ext cx="6400800" cy="3398121"/>
           </a:xfrm>
           <a:prstGeom prst="rect">
             <a:avLst/>
@@ -5154,7 +6003,7 @@
       </p:pic>
       <p:pic>
         <p:nvPicPr>
-          <p:cNvPr id="6" name="GitHub item opened in the dashboard" descr="GitHub item opened in the dashboard">    </p:cNvPr>
+          <p:cNvPr id="6" name="Gmail item opened in the dashboard" descr="Gmail item opened in the dashboard">    </p:cNvPr>
           <p:cNvPicPr>
             <a:picLocks noChangeAspect="1"/>
           </p:cNvPicPr>
@@ -5169,7 +6018,7 @@
         <p:spPr>
           <a:xfrm>
             <a:off x="7223760" y="1783080"/>
-            <a:ext cx="4344217" cy="4526280"/>
+            <a:ext cx="4363537" cy="4526280"/>
           </a:xfrm>
           <a:prstGeom prst="rect">
             <a:avLst/>
@@ -5183,6 +6032,78 @@
           </a:effectLst>
         </p:spPr>
       </p:pic>
+      <p:sp>
+        <p:nvSpPr>
+          <p:cNvPr id="7" name="Gmail caption"/>
+          <p:cNvSpPr txBox="1"/>
+          <p:nvPr/>
+        </p:nvSpPr>
+        <p:spPr>
+          <a:xfrm>
+            <a:off x="457200" y="5455521"/>
+            <a:ext cx="6400800" cy="899559"/>
+          </a:xfrm>
+          <a:prstGeom prst="rect">
+            <a:avLst/>
+          </a:prstGeom>
+          <a:noFill/>
+          <a:ln/>
+        </p:spPr>
+        <p:txBody>
+          <a:bodyPr wrap="square" lIns="0" tIns="0" rIns="0" bIns="0" rtlCol="0" anchor="t"/>
+          <a:lstStyle/>
+          <a:p>
+            <a:pPr indent="0" marL="0">
+              <a:buNone/>
+            </a:pPr>
+            <a:r>
+              <a:rPr lang="en-US" sz="1300" b="1" dirty="0">
+                <a:solidFill>
+                  <a:schemeClr val="tx1"/>
+                </a:solidFill>
+              </a:rPr>
+              <a:t>Item: </a:t>
+            </a:r>
+            <a:pPr indent="0" marL="0">
+              <a:buNone/>
+            </a:pPr>
+            <a:r>
+              <a:rPr lang="en-US" sz="1300" dirty="0">
+                <a:solidFill>
+                  <a:schemeClr val="tx2"/>
+                </a:solidFill>
+              </a:rPr>
+              <a:t>Email “Project Atlas kickoff recap”</a:t>
+            </a:r>
+            <a:endParaRPr lang="en-US" sz="1300" dirty="0"/>
+          </a:p>
+          <a:p>
+            <a:pPr indent="0" marL="0">
+              <a:buNone/>
+            </a:pPr>
+            <a:r>
+              <a:rPr lang="en-US" sz="1300" b="1" dirty="0">
+                <a:solidFill>
+                  <a:schemeClr val="tx1"/>
+                </a:solidFill>
+              </a:rPr>
+              <a:t>Saved as: </a:t>
+            </a:r>
+            <a:pPr indent="0" marL="0">
+              <a:buNone/>
+            </a:pPr>
+            <a:r>
+              <a:rPr lang="en-US" sz="1300" dirty="0">
+                <a:solidFill>
+                  <a:schemeClr val="tx2"/>
+                </a:solidFill>
+              </a:rPr>
+              <a:t>dataExports/gmail/2026-10-15_23-44-19_ecf43b32.json</a:t>
+            </a:r>
+            <a:endParaRPr lang="en-US" sz="1300" dirty="0"/>
+          </a:p>
+        </p:txBody>
+      </p:sp>
       <p:sp>
         <p:nvSpPr>
           <p:cNvPr id="25" name="Slide Number Placeholder 0"/>
@@ -5285,7 +6206,7 @@
                   <a:schemeClr val="tx1"/>
                 </a:solidFill>
               </a:rPr>
-              <a:t>Notion: original vs dashboard</a:t>
+              <a:t>GitHub: original vs dashboard</a:t>
             </a:r>
             <a:endParaRPr lang="en-US" sz="3600" dirty="0"/>
           </a:p>
@@ -5293,7 +6214,7 @@
       </p:sp>
       <p:sp>
         <p:nvSpPr>
-          <p:cNvPr id="3" name="label Original in Notion"/>
+          <p:cNvPr id="3" name="label Original in GitHub"/>
           <p:cNvSpPr txBox="1"/>
           <p:nvPr/>
         </p:nvSpPr>
@@ -5308,7 +6229,7 @@
             </a:avLst>
           </a:prstGeom>
           <a:solidFill>
-            <a:srgbClr val="7A6A55"/>
+            <a:srgbClr val="24292F"/>
           </a:solidFill>
           <a:ln/>
         </p:spPr>
@@ -5325,7 +6246,7 @@
                   <a:srgbClr val="FFFFFF"/>
                 </a:solidFill>
               </a:rPr>
-              <a:t>Original in Notion</a:t>
+              <a:t>Original in GitHub</a:t>
             </a:r>
             <a:endParaRPr lang="en-US" sz="1200" dirty="0"/>
           </a:p>
@@ -5373,7 +6294,7 @@
       </p:sp>
       <p:pic>
         <p:nvPicPr>
-          <p:cNvPr id="5" name="Original Notion content" descr="Original Notion content">    </p:cNvPr>
+          <p:cNvPr id="5" name="Original GitHub content" descr="Original GitHub content">    </p:cNvPr>
           <p:cNvPicPr>
             <a:picLocks noChangeAspect="1"/>
           </p:cNvPicPr>
@@ -5388,7 +6309,7 @@
         <p:spPr>
           <a:xfrm>
             <a:off x="457200" y="1783080"/>
-            <a:ext cx="6400800" cy="3600450"/>
+            <a:ext cx="6400800" cy="3613785"/>
           </a:xfrm>
           <a:prstGeom prst="rect">
             <a:avLst/>
@@ -5404,7 +6325,7 @@
       </p:pic>
       <p:pic>
         <p:nvPicPr>
-          <p:cNvPr id="6" name="Notion item opened in the dashboard" descr="Notion item opened in the dashboard">    </p:cNvPr>
+          <p:cNvPr id="6" name="GitHub item opened in the dashboard" descr="GitHub item opened in the dashboard">    </p:cNvPr>
           <p:cNvPicPr>
             <a:picLocks noChangeAspect="1"/>
           </p:cNvPicPr>
@@ -5419,7 +6340,7 @@
         <p:spPr>
           <a:xfrm>
             <a:off x="7223760" y="1783080"/>
-            <a:ext cx="4507992" cy="3838592"/>
+            <a:ext cx="4344217" cy="4526280"/>
           </a:xfrm>
           <a:prstGeom prst="rect">
             <a:avLst/>
@@ -5433,78 +6354,6 @@
           </a:effectLst>
         </p:spPr>
       </p:pic>
-      <p:sp>
-        <p:nvSpPr>
-          <p:cNvPr id="7" name="Notion caption"/>
-          <p:cNvSpPr txBox="1"/>
-          <p:nvPr/>
-        </p:nvSpPr>
-        <p:spPr>
-          <a:xfrm>
-            <a:off x="457200" y="5657850"/>
-            <a:ext cx="6400800" cy="697230"/>
-          </a:xfrm>
-          <a:prstGeom prst="rect">
-            <a:avLst/>
-          </a:prstGeom>
-          <a:noFill/>
-          <a:ln/>
-        </p:spPr>
-        <p:txBody>
-          <a:bodyPr wrap="square" lIns="0" tIns="0" rIns="0" bIns="0" rtlCol="0" anchor="t"/>
-          <a:lstStyle/>
-          <a:p>
-            <a:pPr indent="0" marL="0">
-              <a:buNone/>
-            </a:pPr>
-            <a:r>
-              <a:rPr lang="en-US" sz="1300" b="1" dirty="0">
-                <a:solidFill>
-                  <a:schemeClr val="tx1"/>
-                </a:solidFill>
-              </a:rPr>
-              <a:t>Item: </a:t>
-            </a:r>
-            <a:pPr indent="0" marL="0">
-              <a:buNone/>
-            </a:pPr>
-            <a:r>
-              <a:rPr lang="en-US" sz="1300" dirty="0">
-                <a:solidFill>
-                  <a:schemeClr val="tx2"/>
-                </a:solidFill>
-              </a:rPr>
-              <a:t>Page “Project Atlas – Kickoff Brief”</a:t>
-            </a:r>
-            <a:endParaRPr lang="en-US" sz="1300" dirty="0"/>
-          </a:p>
-          <a:p>
-            <a:pPr indent="0" marL="0">
-              <a:buNone/>
-            </a:pPr>
-            <a:r>
-              <a:rPr lang="en-US" sz="1300" b="1" dirty="0">
-                <a:solidFill>
-                  <a:schemeClr val="tx1"/>
-                </a:solidFill>
-              </a:rPr>
-              <a:t>Saved as: </a:t>
-            </a:r>
-            <a:pPr indent="0" marL="0">
-              <a:buNone/>
-            </a:pPr>
-            <a:r>
-              <a:rPr lang="en-US" sz="1300" dirty="0">
-                <a:solidFill>
-                  <a:schemeClr val="tx2"/>
-                </a:solidFill>
-              </a:rPr>
-              <a:t>dataExports/notion/2026-10-15_22-49-00_3fa6f7558e41.json</a:t>
-            </a:r>
-            <a:endParaRPr lang="en-US" sz="1300" dirty="0"/>
-          </a:p>
-        </p:txBody>
-      </p:sp>
       <p:sp>
         <p:nvSpPr>
           <p:cNvPr id="25" name="Slide Number Placeholder 0"/>
@@ -5607,7 +6456,7 @@
                   <a:schemeClr val="tx1"/>
                 </a:solidFill>
               </a:rPr>
-              <a:t>Linear: original vs dashboard</a:t>
+              <a:t>Notion: original vs dashboard</a:t>
             </a:r>
             <a:endParaRPr lang="en-US" sz="3600" dirty="0"/>
           </a:p>
@@ -5615,7 +6464,7 @@
       </p:sp>
       <p:sp>
         <p:nvSpPr>
-          <p:cNvPr id="3" name="label Original in Linear"/>
+          <p:cNvPr id="3" name="label Original in Notion"/>
           <p:cNvSpPr txBox="1"/>
           <p:nvPr/>
         </p:nvSpPr>
@@ -5630,7 +6479,7 @@
             </a:avLst>
           </a:prstGeom>
           <a:solidFill>
-            <a:srgbClr val="5E6AD2"/>
+            <a:srgbClr val="7A6A55"/>
           </a:solidFill>
           <a:ln/>
         </p:spPr>
@@ -5647,7 +6496,7 @@
                   <a:srgbClr val="FFFFFF"/>
                 </a:solidFill>
               </a:rPr>
-              <a:t>Original in Linear</a:t>
+              <a:t>Original in Notion</a:t>
             </a:r>
             <a:endParaRPr lang="en-US" sz="1200" dirty="0"/>
           </a:p>
@@ -5695,7 +6544,7 @@
       </p:sp>
       <p:pic>
         <p:nvPicPr>
-          <p:cNvPr id="5" name="Original Linear content" descr="Original Linear content">    </p:cNvPr>
+          <p:cNvPr id="5" name="Original Notion content" descr="Original Notion content">    </p:cNvPr>
           <p:cNvPicPr>
             <a:picLocks noChangeAspect="1"/>
           </p:cNvPicPr>
@@ -5710,7 +6559,7 @@
         <p:spPr>
           <a:xfrm>
             <a:off x="457200" y="1783080"/>
-            <a:ext cx="6400800" cy="2880360"/>
+            <a:ext cx="6400800" cy="3600450"/>
           </a:xfrm>
           <a:prstGeom prst="rect">
             <a:avLst/>
@@ -5726,7 +6575,7 @@
       </p:pic>
       <p:pic>
         <p:nvPicPr>
-          <p:cNvPr id="6" name="Linear item opened in the dashboard" descr="Linear item opened in the dashboard">    </p:cNvPr>
+          <p:cNvPr id="6" name="Notion item opened in the dashboard" descr="Notion item opened in the dashboard">    </p:cNvPr>
           <p:cNvPicPr>
             <a:picLocks noChangeAspect="1"/>
           </p:cNvPicPr>
@@ -5741,7 +6590,7 @@
         <p:spPr>
           <a:xfrm>
             <a:off x="7223760" y="1783080"/>
-            <a:ext cx="4507992" cy="3941896"/>
+            <a:ext cx="4507992" cy="3838592"/>
           </a:xfrm>
           <a:prstGeom prst="rect">
             <a:avLst/>
@@ -5757,14 +6606,14 @@
       </p:pic>
       <p:sp>
         <p:nvSpPr>
-          <p:cNvPr id="7" name="Linear caption"/>
+          <p:cNvPr id="7" name="Notion caption"/>
           <p:cNvSpPr txBox="1"/>
           <p:nvPr/>
         </p:nvSpPr>
         <p:spPr>
           <a:xfrm>
-            <a:off x="457200" y="4937760"/>
-            <a:ext cx="6400800" cy="914400"/>
+            <a:off x="457200" y="5657850"/>
+            <a:ext cx="6400800" cy="697230"/>
           </a:xfrm>
           <a:prstGeom prst="rect">
             <a:avLst/>
@@ -5796,7 +6645,7 @@
                   <a:schemeClr val="tx2"/>
                 </a:solidFill>
               </a:rPr>
-              <a:t>Issue ABR-5 “Reduce routing API p95 latency below 250ms”</a:t>
+              <a:t>Page “Project Atlas – Kickoff Brief”</a:t>
             </a:r>
             <a:endParaRPr lang="en-US" sz="1300" dirty="0"/>
           </a:p>
@@ -5821,7 +6670,7 @@
                   <a:schemeClr val="tx2"/>
                 </a:solidFill>
               </a:rPr>
-              <a:t>dataExports/linear/2026-10-15_22-49-31_ABR-5.json</a:t>
+              <a:t>dataExports/notion/2026-10-15_22-49-00_3fa6f7558e41.json</a:t>
             </a:r>
             <a:endParaRPr lang="en-US" sz="1300" dirty="0"/>
           </a:p>
@@ -5929,7 +6778,7 @@
                   <a:schemeClr val="tx1"/>
                 </a:solidFill>
               </a:rPr>
-              <a:t>Todoist: original vs dashboard</a:t>
+              <a:t>Linear: original vs dashboard</a:t>
             </a:r>
             <a:endParaRPr lang="en-US" sz="3600" dirty="0"/>
           </a:p>
@@ -5937,7 +6786,7 @@
       </p:sp>
       <p:sp>
         <p:nvSpPr>
-          <p:cNvPr id="3" name="label Original in Todoist"/>
+          <p:cNvPr id="3" name="label Original in Linear"/>
           <p:cNvSpPr txBox="1"/>
           <p:nvPr/>
         </p:nvSpPr>
@@ -5952,7 +6801,7 @@
             </a:avLst>
           </a:prstGeom>
           <a:solidFill>
-            <a:srgbClr val="C2410C"/>
+            <a:srgbClr val="5E6AD2"/>
           </a:solidFill>
           <a:ln/>
         </p:spPr>
@@ -5969,7 +6818,7 @@
                   <a:srgbClr val="FFFFFF"/>
                 </a:solidFill>
               </a:rPr>
-              <a:t>Original in Todoist</a:t>
+              <a:t>Original in Linear</a:t>
             </a:r>
             <a:endParaRPr lang="en-US" sz="1200" dirty="0"/>
           </a:p>
@@ -6017,7 +6866,7 @@
       </p:sp>
       <p:pic>
         <p:nvPicPr>
-          <p:cNvPr id="5" name="Original Todoist content" descr="Original Todoist content">    </p:cNvPr>
+          <p:cNvPr id="5" name="Original Linear content" descr="Original Linear content">    </p:cNvPr>
           <p:cNvPicPr>
             <a:picLocks noChangeAspect="1"/>
           </p:cNvPicPr>
@@ -6032,7 +6881,7 @@
         <p:spPr>
           <a:xfrm>
             <a:off x="457200" y="1783080"/>
-            <a:ext cx="6400800" cy="3622675"/>
+            <a:ext cx="6400800" cy="2880360"/>
           </a:xfrm>
           <a:prstGeom prst="rect">
             <a:avLst/>
@@ -6048,7 +6897,7 @@
       </p:pic>
       <p:pic>
         <p:nvPicPr>
-          <p:cNvPr id="6" name="Todoist item opened in the dashboard" descr="Todoist item opened in the dashboard">    </p:cNvPr>
+          <p:cNvPr id="6" name="Linear item opened in the dashboard" descr="Linear item opened in the dashboard">    </p:cNvPr>
           <p:cNvPicPr>
             <a:picLocks noChangeAspect="1"/>
           </p:cNvPicPr>
@@ -6063,7 +6912,7 @@
         <p:spPr>
           <a:xfrm>
             <a:off x="7223760" y="1783080"/>
-            <a:ext cx="4507992" cy="4297829"/>
+            <a:ext cx="4507992" cy="3941896"/>
           </a:xfrm>
           <a:prstGeom prst="rect">
             <a:avLst/>
@@ -6077,6 +6926,78 @@
           </a:effectLst>
         </p:spPr>
       </p:pic>
+      <p:sp>
+        <p:nvSpPr>
+          <p:cNvPr id="7" name="Linear caption"/>
+          <p:cNvSpPr txBox="1"/>
+          <p:nvPr/>
+        </p:nvSpPr>
+        <p:spPr>
+          <a:xfrm>
+            <a:off x="457200" y="4937760"/>
+            <a:ext cx="6400800" cy="914400"/>
+          </a:xfrm>
+          <a:prstGeom prst="rect">
+            <a:avLst/>
+          </a:prstGeom>
+          <a:noFill/>
+          <a:ln/>
+        </p:spPr>
+        <p:txBody>
+          <a:bodyPr wrap="square" lIns="0" tIns="0" rIns="0" bIns="0" rtlCol="0" anchor="t"/>
+          <a:lstStyle/>
+          <a:p>
+            <a:pPr indent="0" marL="0">
+              <a:buNone/>
+            </a:pPr>
+            <a:r>
+              <a:rPr lang="en-US" sz="1300" b="1" dirty="0">
+                <a:solidFill>
+                  <a:schemeClr val="tx1"/>
+                </a:solidFill>
+              </a:rPr>
+              <a:t>Item: </a:t>
+            </a:r>
+            <a:pPr indent="0" marL="0">
+              <a:buNone/>
+            </a:pPr>
+            <a:r>
+              <a:rPr lang="en-US" sz="1300" dirty="0">
+                <a:solidFill>
+                  <a:schemeClr val="tx2"/>
+                </a:solidFill>
+              </a:rPr>
+              <a:t>Issue ABR-5 “Reduce routing API p95 latency below 250ms”</a:t>
+            </a:r>
+            <a:endParaRPr lang="en-US" sz="1300" dirty="0"/>
+          </a:p>
+          <a:p>
+            <a:pPr indent="0" marL="0">
+              <a:buNone/>
+            </a:pPr>
+            <a:r>
+              <a:rPr lang="en-US" sz="1300" b="1" dirty="0">
+                <a:solidFill>
+                  <a:schemeClr val="tx1"/>
+                </a:solidFill>
+              </a:rPr>
+              <a:t>Saved as: </a:t>
+            </a:r>
+            <a:pPr indent="0" marL="0">
+              <a:buNone/>
+            </a:pPr>
+            <a:r>
+              <a:rPr lang="en-US" sz="1300" dirty="0">
+                <a:solidFill>
+                  <a:schemeClr val="tx2"/>
+                </a:solidFill>
+              </a:rPr>
+              <a:t>dataExports/linear/2026-10-15_22-49-31_ABR-5.json</a:t>
+            </a:r>
+            <a:endParaRPr lang="en-US" sz="1300" dirty="0"/>
+          </a:p>
+        </p:txBody>
+      </p:sp>
       <p:sp>
         <p:nvSpPr>
           <p:cNvPr id="25" name="Slide Number Placeholder 0"/>
@@ -6179,7 +7100,7 @@
                   <a:schemeClr val="tx1"/>
                 </a:solidFill>
               </a:rPr>
-              <a:t>Jira: original vs dashboard</a:t>
+              <a:t>Todoist: original vs dashboard</a:t>
             </a:r>
             <a:endParaRPr lang="en-US" sz="3600" dirty="0"/>
           </a:p>
@@ -6187,7 +7108,7 @@
       </p:sp>
       <p:sp>
         <p:nvSpPr>
-          <p:cNvPr id="3" name="label Original in Jira"/>
+          <p:cNvPr id="3" name="label Original in Todoist"/>
           <p:cNvSpPr txBox="1"/>
           <p:nvPr/>
         </p:nvSpPr>
@@ -6202,7 +7123,7 @@
             </a:avLst>
           </a:prstGeom>
           <a:solidFill>
-            <a:srgbClr val="0C66E4"/>
+            <a:srgbClr val="C2410C"/>
           </a:solidFill>
           <a:ln/>
         </p:spPr>
@@ -6219,7 +7140,7 @@
                   <a:srgbClr val="FFFFFF"/>
                 </a:solidFill>
               </a:rPr>
-              <a:t>Original in Jira</a:t>
+              <a:t>Original in Todoist</a:t>
             </a:r>
             <a:endParaRPr lang="en-US" sz="1200" dirty="0"/>
           </a:p>
@@ -6267,7 +7188,7 @@
       </p:sp>
       <p:pic>
         <p:nvPicPr>
-          <p:cNvPr id="5" name="Original Jira content" descr="Original Jira content">    </p:cNvPr>
+          <p:cNvPr id="5" name="Original Todoist content" descr="Original Todoist content">    </p:cNvPr>
           <p:cNvPicPr>
             <a:picLocks noChangeAspect="1"/>
           </p:cNvPicPr>
@@ -6282,7 +7203,7 @@
         <p:spPr>
           <a:xfrm>
             <a:off x="457200" y="1783080"/>
-            <a:ext cx="6400800" cy="3600450"/>
+            <a:ext cx="6400800" cy="3622675"/>
           </a:xfrm>
           <a:prstGeom prst="rect">
             <a:avLst/>
@@ -6298,7 +7219,7 @@
       </p:pic>
       <p:pic>
         <p:nvPicPr>
-          <p:cNvPr id="6" name="Jira item opened in the dashboard" descr="Jira item opened in the dashboard">    </p:cNvPr>
+          <p:cNvPr id="6" name="Todoist item opened in the dashboard" descr="Todoist item opened in the dashboard">    </p:cNvPr>
           <p:cNvPicPr>
             <a:picLocks noChangeAspect="1"/>
           </p:cNvPicPr>
@@ -6313,7 +7234,7 @@
         <p:spPr>
           <a:xfrm>
             <a:off x="7223760" y="1783080"/>
-            <a:ext cx="4507992" cy="4122783"/>
+            <a:ext cx="4507992" cy="4297829"/>
           </a:xfrm>
           <a:prstGeom prst="rect">
             <a:avLst/>
@@ -6327,78 +7248,6 @@
           </a:effectLst>
         </p:spPr>
       </p:pic>
-      <p:sp>
-        <p:nvSpPr>
-          <p:cNvPr id="7" name="Jira caption"/>
-          <p:cNvSpPr txBox="1"/>
-          <p:nvPr/>
-        </p:nvSpPr>
-        <p:spPr>
-          <a:xfrm>
-            <a:off x="457200" y="5657850"/>
-            <a:ext cx="6400800" cy="697230"/>
-          </a:xfrm>
-          <a:prstGeom prst="rect">
-            <a:avLst/>
-          </a:prstGeom>
-          <a:noFill/>
-          <a:ln/>
-        </p:spPr>
-        <p:txBody>
-          <a:bodyPr wrap="square" lIns="0" tIns="0" rIns="0" bIns="0" rtlCol="0" anchor="t"/>
-          <a:lstStyle/>
-          <a:p>
-            <a:pPr indent="0" marL="0">
-              <a:buNone/>
-            </a:pPr>
-            <a:r>
-              <a:rPr lang="en-US" sz="1300" b="1" dirty="0">
-                <a:solidFill>
-                  <a:schemeClr val="tx1"/>
-                </a:solidFill>
-              </a:rPr>
-              <a:t>Item: </a:t>
-            </a:r>
-            <a:pPr indent="0" marL="0">
-              <a:buNone/>
-            </a:pPr>
-            <a:r>
-              <a:rPr lang="en-US" sz="1300" dirty="0">
-                <a:solidFill>
-                  <a:schemeClr val="tx2"/>
-                </a:solidFill>
-              </a:rPr>
-              <a:t>Issue KAN-8 “ETA prediction model v1 for Project Atlas”</a:t>
-            </a:r>
-            <a:endParaRPr lang="en-US" sz="1300" dirty="0"/>
-          </a:p>
-          <a:p>
-            <a:pPr indent="0" marL="0">
-              <a:buNone/>
-            </a:pPr>
-            <a:r>
-              <a:rPr lang="en-US" sz="1300" b="1" dirty="0">
-                <a:solidFill>
-                  <a:schemeClr val="tx1"/>
-                </a:solidFill>
-              </a:rPr>
-              <a:t>Saved as: </a:t>
-            </a:r>
-            <a:pPr indent="0" marL="0">
-              <a:buNone/>
-            </a:pPr>
-            <a:r>
-              <a:rPr lang="en-US" sz="1300" dirty="0">
-                <a:solidFill>
-                  <a:schemeClr val="tx2"/>
-                </a:solidFill>
-              </a:rPr>
-              <a:t>dataExports/jira/2026-10-20_21-21-17_KAN-8.json</a:t>
-            </a:r>
-            <a:endParaRPr lang="en-US" sz="1300" dirty="0"/>
-          </a:p>
-        </p:txBody>
-      </p:sp>
       <p:sp>
         <p:nvSpPr>
           <p:cNvPr id="25" name="Slide Number Placeholder 0"/>

</xml_diff>

<commit_message>
Update MCP connections screenshot
</commit_message>
<xml_diff>
--- a/Homework3_Presentation.pptx
+++ b/Homework3_Presentation.pptx
@@ -119,19 +119,19 @@
   <p:extLst>
     <p:ext uri="{521415D9-36F7-43E2-AB2F-B90AF26B5E84}">
       <p14:sectionLst xmlns:p14="http://schemas.microsoft.com/office/powerpoint/2010/main">
-        <p14:section name="Introduction" id="{50b1a9a4-d922-d4db-b55d-a4ed8cb44d70}">
+        <p14:section name="Introduction" id="{3ed258fd-dece-0f44-2f08-7b23a1e18afc}">
           <p14:sldIdLst>
             <p14:sldId id="256"/>
             <p14:sldId id="257"/>
             <p14:sldId id="258"/>
           </p14:sldIdLst>
         </p14:section>
-        <p14:section name="Connections" id="{0570c131-1662-7e2f-2164-35e7b5ac5a23}">
+        <p14:section name="Connections" id="{ee9d8780-a0e7-1a5a-81be-f6138a956bd7}">
           <p14:sldIdLst>
             <p14:sldId id="259"/>
           </p14:sldIdLst>
         </p14:section>
-        <p14:section name="Original vs dashboard" id="{d3d1325c-7c44-605b-2e23-92be9f86f35b}">
+        <p14:section name="Original vs dashboard" id="{afe15690-116a-21f7-0a40-f01c2b217ffb}">
           <p14:sldIdLst>
             <p14:sldId id="260"/>
             <p14:sldId id="261"/>
@@ -141,13 +141,13 @@
             <p14:sldId id="265"/>
           </p14:sldIdLst>
         </p14:section>
-        <p14:section name="Dashboard" id="{b321d368-fc82-16aa-c534-b759f397d4e1}">
+        <p14:section name="Dashboard" id="{1bb0b348-c37a-90a0-e0be-b19dcbf252ab}">
           <p14:sldIdLst>
             <p14:sldId id="266"/>
             <p14:sldId id="267"/>
           </p14:sldIdLst>
         </p14:section>
-        <p14:section name="Summary" id="{e9783b14-e356-0ca8-f1ae-9e9201579723}">
+        <p14:section name="Summary" id="{c95f66e4-6e3b-1870-33c9-39625fbb803e}">
           <p14:sldIdLst>
             <p14:sldId id="268"/>
           </p14:sldIdLst>
@@ -5633,7 +5633,7 @@
       </p:sp>
       <p:pic>
         <p:nvPicPr>
-          <p:cNvPr id="3" name="Claude Code /mcp screen showing github, linear, notion and claude.ai Gmail connected" descr="Claude Code /mcp screen showing github, linear, notion and claude.ai Gmail connected">    </p:cNvPr>
+          <p:cNvPr id="3" name="Claude Code /mcp screen showing atlassian, github, linear, notion, todoist and claude.ai Gmail connected" descr="Claude Code /mcp screen showing atlassian, github, linear, notion, todoist and claude.ai Gmail connected">    </p:cNvPr>
           <p:cNvPicPr>
             <a:picLocks noChangeAspect="1"/>
           </p:cNvPicPr>
@@ -5648,7 +5648,7 @@
         <p:spPr>
           <a:xfrm>
             <a:off x="457200" y="1463040"/>
-            <a:ext cx="6675120" cy="2601457"/>
+            <a:ext cx="6675120" cy="3042613"/>
           </a:xfrm>
           <a:prstGeom prst="rect">
             <a:avLst/>

</xml_diff>